<commit_message>
Sunuma platform ve indirme bilgileri eklendi (v1.0.0)
- Kapanis slaytina Windows 10/11 (x64) + macOS (Apple Silicon) platform
  satirlari ve GitHub Releases v1.0.0 indirme bilgisi (ozel repo notu) eklendi
- macOS paketi icin tek cumlelik notarizasyon dipnotu eklendi
  (Apple Silicon, ilk acilista sag tik -> Ac)
- Acilis slaytindaki platform etiketi Windows x64 / macOS arm64 yapildi
- Uretici betik depoya eklendi; PPTX ve PDF yeniden uretildi

Co-Authored-By: Claude Fable 5 <noreply@anthropic.com>
</commit_message>
<xml_diff>
--- a/docs/presentation/German-Course-AI-Trilingual.pptx
+++ b/docs/presentation/German-Course-AI-Trilingual.pptx
@@ -2,18 +2,18 @@
 <file path=ppt/presentation.xml><?xml version="1.0" encoding="utf-8"?>
 <p:presentation xmlns:p="http://schemas.openxmlformats.org/presentationml/2006/main">
   <p:sldMasterIdLst>
-    <p:sldMasterId xmlns:r="http://schemas.openxmlformats.org/officeDocument/2006/relationships" id="2147483648" r:id="R50089299b57a401e"/>
+    <p:sldMasterId xmlns:r="http://schemas.openxmlformats.org/officeDocument/2006/relationships" id="2147483648" r:id="R925416c520d144d7"/>
   </p:sldMasterIdLst>
   <p:notesMasterIdLst>
-    <p:notesMasterId xmlns:r="http://schemas.openxmlformats.org/officeDocument/2006/relationships" r:id="R73aa674088a34719"/>
+    <p:notesMasterId xmlns:r="http://schemas.openxmlformats.org/officeDocument/2006/relationships" r:id="R944f634b67534c4b"/>
   </p:notesMasterIdLst>
   <p:sldIdLst>
-    <p:sldId xmlns:r="http://schemas.openxmlformats.org/officeDocument/2006/relationships" id="256" r:id="R16e7261788684942"/>
-    <p:sldId xmlns:r="http://schemas.openxmlformats.org/officeDocument/2006/relationships" id="257" r:id="R528cc220f1ac4477"/>
-    <p:sldId xmlns:r="http://schemas.openxmlformats.org/officeDocument/2006/relationships" id="258" r:id="R82d53c9db81c4cb1"/>
-    <p:sldId xmlns:r="http://schemas.openxmlformats.org/officeDocument/2006/relationships" id="259" r:id="R536bd6fd730c4868"/>
-    <p:sldId xmlns:r="http://schemas.openxmlformats.org/officeDocument/2006/relationships" id="260" r:id="R5df2d9b80d564d24"/>
-    <p:sldId xmlns:r="http://schemas.openxmlformats.org/officeDocument/2006/relationships" id="261" r:id="R3f5ea4dde0af4b47"/>
+    <p:sldId xmlns:r="http://schemas.openxmlformats.org/officeDocument/2006/relationships" id="256" r:id="R6c47d783ae2549ee"/>
+    <p:sldId xmlns:r="http://schemas.openxmlformats.org/officeDocument/2006/relationships" id="257" r:id="R1ff21c9a833d428b"/>
+    <p:sldId xmlns:r="http://schemas.openxmlformats.org/officeDocument/2006/relationships" id="258" r:id="Rea0b44f9643f49fe"/>
+    <p:sldId xmlns:r="http://schemas.openxmlformats.org/officeDocument/2006/relationships" id="259" r:id="R25588092b3cc4d92"/>
+    <p:sldId xmlns:r="http://schemas.openxmlformats.org/officeDocument/2006/relationships" id="260" r:id="Rb6535701c7294d2e"/>
+    <p:sldId xmlns:r="http://schemas.openxmlformats.org/officeDocument/2006/relationships" id="261" r:id="R350b568ab17c4af3"/>
   </p:sldIdLst>
   <p:sldSz cx="12192000" cy="6858000"/>
   <p:notesSz cx="6858000" cy="9144000"/>
@@ -937,6 +937,11 @@
           </a:p>
           <a:p xmlns:a="http://schemas.openxmlformats.org/drawingml/2006/main">
             <a:r>
+              <a:t>- https://github.com/Azizsekerdil/GermanCourseAI/releases/tag/v1.0.0</a:t>
+            </a:r>
+          </a:p>
+          <a:p xmlns:a="http://schemas.openxmlformats.org/drawingml/2006/main">
+            <a:r>
               <a:t>[/Sources]</a:t>
             </a:r>
           </a:p>
@@ -1005,7 +1010,7 @@
   </p:cSld>
   <p:clrMap bg1="lt1" tx1="dk1" bg2="lt2" tx2="dk2" accent1="accent1" accent2="accent2" accent3="accent3" accent4="accent4" accent5="accent5" accent6="accent6" hlink="hlink" folHlink="folHlink"/>
   <p:sldLayoutIdLst>
-    <p:sldLayoutId xmlns:r="http://schemas.openxmlformats.org/officeDocument/2006/relationships" id="2147483649" r:id="Rfc865ebd5cc24468"/>
+    <p:sldLayoutId xmlns:r="http://schemas.openxmlformats.org/officeDocument/2006/relationships" id="2147483649" r:id="R7874d5378f794973"/>
   </p:sldLayoutIdLst>
   <p:txStyles>
     <p:titleStyle>
@@ -1556,7 +1561,7 @@
           <p:cNvPr id="13" name="box-1">
             <a:extLst xmlns:a="http://schemas.openxmlformats.org/drawingml/2006/main">
               <a:ext uri="{FF2B5EF4-FFF2-40B4-BE49-F238E27FC236}">
-                <a16:creationId xmlns:a16="http://schemas.microsoft.com/office/drawing/2014/main" id="{139C1B21-9F8D-4E4E-9520-5F2E6ED4986C}"/>
+                <a16:creationId xmlns:a16="http://schemas.microsoft.com/office/drawing/2014/main" id="{CCA520DB-A332-41F7-B660-CFF11DEDF158}"/>
               </a:ext>
             </a:extLst>
           </p:cNvPr>
@@ -1589,7 +1594,7 @@
           <p:cNvPr id="2" name="text-2">
             <a:extLst xmlns:a="http://schemas.openxmlformats.org/drawingml/2006/main">
               <a:ext uri="{FF2B5EF4-FFF2-40B4-BE49-F238E27FC236}">
-                <a16:creationId xmlns:a16="http://schemas.microsoft.com/office/drawing/2014/main" id="{CC5361F4-933E-4085-9150-F7019530D06C}"/>
+                <a16:creationId xmlns:a16="http://schemas.microsoft.com/office/drawing/2014/main" id="{61267023-FF07-4D30-B45A-971BFFA33FFF}"/>
               </a:ext>
             </a:extLst>
           </p:cNvPr>
@@ -1645,7 +1650,7 @@
           <p:cNvPr id="3" name="text-3">
             <a:extLst xmlns:a="http://schemas.openxmlformats.org/drawingml/2006/main">
               <a:ext uri="{FF2B5EF4-FFF2-40B4-BE49-F238E27FC236}">
-                <a16:creationId xmlns:a16="http://schemas.microsoft.com/office/drawing/2014/main" id="{4EDAC175-15AE-489F-A1FB-B8B3C326D7E1}"/>
+                <a16:creationId xmlns:a16="http://schemas.microsoft.com/office/drawing/2014/main" id="{5F5650EC-2956-424B-98BE-C4FDEBEB4BF6}"/>
               </a:ext>
             </a:extLst>
           </p:cNvPr>
@@ -1701,7 +1706,7 @@
           <p:cNvPr id="4" name="text-4">
             <a:extLst xmlns:a="http://schemas.openxmlformats.org/drawingml/2006/main">
               <a:ext uri="{FF2B5EF4-FFF2-40B4-BE49-F238E27FC236}">
-                <a16:creationId xmlns:a16="http://schemas.microsoft.com/office/drawing/2014/main" id="{863BC0B5-6D2F-4EB8-B686-EA165F9D9B88}"/>
+                <a16:creationId xmlns:a16="http://schemas.microsoft.com/office/drawing/2014/main" id="{042E64A7-98FE-49AE-9A1B-16A457068F73}"/>
               </a:ext>
             </a:extLst>
           </p:cNvPr>
@@ -1757,7 +1762,7 @@
           <p:cNvPr id="5" name="text-5">
             <a:extLst xmlns:a="http://schemas.openxmlformats.org/drawingml/2006/main">
               <a:ext uri="{FF2B5EF4-FFF2-40B4-BE49-F238E27FC236}">
-                <a16:creationId xmlns:a16="http://schemas.microsoft.com/office/drawing/2014/main" id="{2D4DC81A-C104-4B1C-924F-33D17A05312E}"/>
+                <a16:creationId xmlns:a16="http://schemas.microsoft.com/office/drawing/2014/main" id="{586042F5-9CD0-4F69-85E0-DF4959003A4C}"/>
               </a:ext>
             </a:extLst>
           </p:cNvPr>
@@ -1813,7 +1818,7 @@
           <p:cNvPr id="6" name="text-6">
             <a:extLst xmlns:a="http://schemas.openxmlformats.org/drawingml/2006/main">
               <a:ext uri="{FF2B5EF4-FFF2-40B4-BE49-F238E27FC236}">
-                <a16:creationId xmlns:a16="http://schemas.microsoft.com/office/drawing/2014/main" id="{FF3667E2-4B93-4190-B260-F81B87ECE30A}"/>
+                <a16:creationId xmlns:a16="http://schemas.microsoft.com/office/drawing/2014/main" id="{8C84A7AA-014B-42A5-B22A-1C726A25EA4B}"/>
               </a:ext>
             </a:extLst>
           </p:cNvPr>
@@ -1869,7 +1874,7 @@
           <p:cNvPr id="7" name="text-7">
             <a:extLst xmlns:a="http://schemas.openxmlformats.org/drawingml/2006/main">
               <a:ext uri="{FF2B5EF4-FFF2-40B4-BE49-F238E27FC236}">
-                <a16:creationId xmlns:a16="http://schemas.microsoft.com/office/drawing/2014/main" id="{9679CAF3-7109-40AC-9C1B-B65F9D4138E3}"/>
+                <a16:creationId xmlns:a16="http://schemas.microsoft.com/office/drawing/2014/main" id="{48E8C130-6CBB-45CB-A523-736875386D9F}"/>
               </a:ext>
             </a:extLst>
           </p:cNvPr>
@@ -1925,7 +1930,7 @@
           <p:cNvPr id="8" name="text-8">
             <a:extLst xmlns:a="http://schemas.openxmlformats.org/drawingml/2006/main">
               <a:ext uri="{FF2B5EF4-FFF2-40B4-BE49-F238E27FC236}">
-                <a16:creationId xmlns:a16="http://schemas.microsoft.com/office/drawing/2014/main" id="{B231AC5C-C408-4641-A2C8-4A8F3E1FFAF7}"/>
+                <a16:creationId xmlns:a16="http://schemas.microsoft.com/office/drawing/2014/main" id="{F2015877-5EB1-4595-8497-8687C7D635D5}"/>
               </a:ext>
             </a:extLst>
           </p:cNvPr>
@@ -1981,7 +1986,7 @@
           <p:cNvPr id="9" name="text-9">
             <a:extLst xmlns:a="http://schemas.openxmlformats.org/drawingml/2006/main">
               <a:ext uri="{FF2B5EF4-FFF2-40B4-BE49-F238E27FC236}">
-                <a16:creationId xmlns:a16="http://schemas.microsoft.com/office/drawing/2014/main" id="{8DE7905E-FD01-4D4D-A813-36DEB3274B0F}"/>
+                <a16:creationId xmlns:a16="http://schemas.microsoft.com/office/drawing/2014/main" id="{5D61D76D-4253-434E-89EE-5C3ADCFD35F8}"/>
               </a:ext>
             </a:extLst>
           </p:cNvPr>
@@ -2037,7 +2042,7 @@
           <p:cNvPr id="10" name="box-10">
             <a:extLst xmlns:a="http://schemas.openxmlformats.org/drawingml/2006/main">
               <a:ext uri="{FF2B5EF4-FFF2-40B4-BE49-F238E27FC236}">
-                <a16:creationId xmlns:a16="http://schemas.microsoft.com/office/drawing/2014/main" id="{D56071B0-EAEE-4B97-9A34-188AE4680E82}"/>
+                <a16:creationId xmlns:a16="http://schemas.microsoft.com/office/drawing/2014/main" id="{11615049-7E32-496D-87D3-B30F9F4094A0}"/>
               </a:ext>
             </a:extLst>
           </p:cNvPr>
@@ -2074,7 +2079,7 @@
           <p:nvPr/>
         </p:nvPicPr>
         <p:blipFill>
-          <a:blip xmlns:r="http://schemas.openxmlformats.org/officeDocument/2006/relationships" xmlns:a="http://schemas.openxmlformats.org/drawingml/2006/main" r:embed="R72289274b5e64b96"/>
+          <a:blip xmlns:r="http://schemas.openxmlformats.org/officeDocument/2006/relationships" xmlns:a="http://schemas.openxmlformats.org/drawingml/2006/main" r:embed="R93e3aa85f4464eb3"/>
           <a:stretch xmlns:a="http://schemas.openxmlformats.org/drawingml/2006/main"/>
         </p:blipFill>
         <p:spPr>
@@ -2092,7 +2097,7 @@
           <p:cNvPr id="12" name="text-11">
             <a:extLst xmlns:a="http://schemas.openxmlformats.org/drawingml/2006/main">
               <a:ext uri="{FF2B5EF4-FFF2-40B4-BE49-F238E27FC236}">
-                <a16:creationId xmlns:a16="http://schemas.microsoft.com/office/drawing/2014/main" id="{8532823E-EAFF-4D78-9CDA-6A8C6B621EBA}"/>
+                <a16:creationId xmlns:a16="http://schemas.microsoft.com/office/drawing/2014/main" id="{282CCCFB-42C9-4AD4-93AD-0D5A8DC0D5FB}"/>
               </a:ext>
             </a:extLst>
           </p:cNvPr>
@@ -2138,7 +2143,7 @@
                 <a:ea typeface="Arial"/>
                 <a:cs typeface="Arial"/>
               </a:rPr>
-              <a:t>Windows · Python · SQLite</a:t>
+              <a:t>Windows x64 · macOS arm64</a:t>
             </a:r>
           </a:p>
         </p:txBody>
@@ -2146,7 +2151,7 @@
     </p:spTree>
     <p:extLst>
       <p:ext uri="{BB962C8B-B14F-4D97-AF65-F5344CB8AC3E}">
-        <p14:creationId xmlns:p14="http://schemas.microsoft.com/office/powerpoint/2010/main" val="1061628849"/>
+        <p14:creationId xmlns:p14="http://schemas.microsoft.com/office/powerpoint/2010/main" val="541527519"/>
       </p:ext>
     </p:extLst>
   </p:cSld>
@@ -2177,7 +2182,7 @@
           <p:cNvPr id="14" name="box-12">
             <a:extLst xmlns:a="http://schemas.openxmlformats.org/drawingml/2006/main">
               <a:ext uri="{FF2B5EF4-FFF2-40B4-BE49-F238E27FC236}">
-                <a16:creationId xmlns:a16="http://schemas.microsoft.com/office/drawing/2014/main" id="{6BA5CB82-C4DE-431C-85D1-A00813C24E62}"/>
+                <a16:creationId xmlns:a16="http://schemas.microsoft.com/office/drawing/2014/main" id="{AFEF2905-D59A-4C8E-9642-78744B99A926}"/>
               </a:ext>
             </a:extLst>
           </p:cNvPr>
@@ -2210,7 +2215,7 @@
           <p:cNvPr id="2" name="text-13">
             <a:extLst xmlns:a="http://schemas.openxmlformats.org/drawingml/2006/main">
               <a:ext uri="{FF2B5EF4-FFF2-40B4-BE49-F238E27FC236}">
-                <a16:creationId xmlns:a16="http://schemas.microsoft.com/office/drawing/2014/main" id="{37F8E4AF-EB7A-41C5-8EE5-0D824CBD8728}"/>
+                <a16:creationId xmlns:a16="http://schemas.microsoft.com/office/drawing/2014/main" id="{E068ACAA-2AC7-4966-AB0B-AC7EF187E773}"/>
               </a:ext>
             </a:extLst>
           </p:cNvPr>
@@ -2266,7 +2271,7 @@
           <p:cNvPr id="3" name="text-14">
             <a:extLst xmlns:a="http://schemas.openxmlformats.org/drawingml/2006/main">
               <a:ext uri="{FF2B5EF4-FFF2-40B4-BE49-F238E27FC236}">
-                <a16:creationId xmlns:a16="http://schemas.microsoft.com/office/drawing/2014/main" id="{50772582-9454-430C-A87C-D320296D424E}"/>
+                <a16:creationId xmlns:a16="http://schemas.microsoft.com/office/drawing/2014/main" id="{3A11917C-1F2E-46A8-9F3B-AF5196D36FC6}"/>
               </a:ext>
             </a:extLst>
           </p:cNvPr>
@@ -2322,7 +2327,7 @@
           <p:cNvPr id="4" name="text-15">
             <a:extLst xmlns:a="http://schemas.openxmlformats.org/drawingml/2006/main">
               <a:ext uri="{FF2B5EF4-FFF2-40B4-BE49-F238E27FC236}">
-                <a16:creationId xmlns:a16="http://schemas.microsoft.com/office/drawing/2014/main" id="{8894CEA1-B95B-44B3-8CDF-2F4574619A0F}"/>
+                <a16:creationId xmlns:a16="http://schemas.microsoft.com/office/drawing/2014/main" id="{82C2B217-191A-472A-95F1-3E59E762CEAA}"/>
               </a:ext>
             </a:extLst>
           </p:cNvPr>
@@ -2378,7 +2383,7 @@
           <p:cNvPr id="5" name="text-16">
             <a:extLst xmlns:a="http://schemas.openxmlformats.org/drawingml/2006/main">
               <a:ext uri="{FF2B5EF4-FFF2-40B4-BE49-F238E27FC236}">
-                <a16:creationId xmlns:a16="http://schemas.microsoft.com/office/drawing/2014/main" id="{485ADA50-925A-4F35-8C54-08B3CDC09C5A}"/>
+                <a16:creationId xmlns:a16="http://schemas.microsoft.com/office/drawing/2014/main" id="{40D8EADA-8A26-4008-AD0A-7CF9BBDF468A}"/>
               </a:ext>
             </a:extLst>
           </p:cNvPr>
@@ -2434,7 +2439,7 @@
           <p:cNvPr id="6" name="text-17">
             <a:extLst xmlns:a="http://schemas.openxmlformats.org/drawingml/2006/main">
               <a:ext uri="{FF2B5EF4-FFF2-40B4-BE49-F238E27FC236}">
-                <a16:creationId xmlns:a16="http://schemas.microsoft.com/office/drawing/2014/main" id="{E6D481B7-0256-4171-99CC-C95FFAB7B91F}"/>
+                <a16:creationId xmlns:a16="http://schemas.microsoft.com/office/drawing/2014/main" id="{8E7E55F7-5932-4DD8-B536-EC1D65EF3104}"/>
               </a:ext>
             </a:extLst>
           </p:cNvPr>
@@ -2490,7 +2495,7 @@
           <p:cNvPr id="7" name="box-18">
             <a:extLst xmlns:a="http://schemas.openxmlformats.org/drawingml/2006/main">
               <a:ext uri="{FF2B5EF4-FFF2-40B4-BE49-F238E27FC236}">
-                <a16:creationId xmlns:a16="http://schemas.microsoft.com/office/drawing/2014/main" id="{67A04007-D882-4C7F-AABF-2C0EDCA44B2B}"/>
+                <a16:creationId xmlns:a16="http://schemas.microsoft.com/office/drawing/2014/main" id="{B2CFFD31-0883-412C-B5AC-9909650F42B7}"/>
               </a:ext>
             </a:extLst>
           </p:cNvPr>
@@ -2523,7 +2528,7 @@
           <p:cNvPr id="8" name="text-19">
             <a:extLst xmlns:a="http://schemas.openxmlformats.org/drawingml/2006/main">
               <a:ext uri="{FF2B5EF4-FFF2-40B4-BE49-F238E27FC236}">
-                <a16:creationId xmlns:a16="http://schemas.microsoft.com/office/drawing/2014/main" id="{18EDB591-F019-4C9B-9B1C-7C62264849AA}"/>
+                <a16:creationId xmlns:a16="http://schemas.microsoft.com/office/drawing/2014/main" id="{07F811D6-4351-4FF5-80D0-6FE0FF10C337}"/>
               </a:ext>
             </a:extLst>
           </p:cNvPr>
@@ -2579,7 +2584,7 @@
           <p:cNvPr id="9" name="text-20">
             <a:extLst xmlns:a="http://schemas.openxmlformats.org/drawingml/2006/main">
               <a:ext uri="{FF2B5EF4-FFF2-40B4-BE49-F238E27FC236}">
-                <a16:creationId xmlns:a16="http://schemas.microsoft.com/office/drawing/2014/main" id="{39843D61-9FE8-43C9-9A4A-7420D05A6C44}"/>
+                <a16:creationId xmlns:a16="http://schemas.microsoft.com/office/drawing/2014/main" id="{9D730B93-8FEC-4B9F-AB35-4E89C8198E2A}"/>
               </a:ext>
             </a:extLst>
           </p:cNvPr>
@@ -2635,7 +2640,7 @@
           <p:cNvPr id="10" name="text-21">
             <a:extLst xmlns:a="http://schemas.openxmlformats.org/drawingml/2006/main">
               <a:ext uri="{FF2B5EF4-FFF2-40B4-BE49-F238E27FC236}">
-                <a16:creationId xmlns:a16="http://schemas.microsoft.com/office/drawing/2014/main" id="{31E89790-02BD-41B8-87A6-2C339AB94FC1}"/>
+                <a16:creationId xmlns:a16="http://schemas.microsoft.com/office/drawing/2014/main" id="{8CEB4B68-030C-44F6-91DA-0F0A0822BD0D}"/>
               </a:ext>
             </a:extLst>
           </p:cNvPr>
@@ -2691,7 +2696,7 @@
           <p:cNvPr id="11" name="box-22">
             <a:extLst xmlns:a="http://schemas.openxmlformats.org/drawingml/2006/main">
               <a:ext uri="{FF2B5EF4-FFF2-40B4-BE49-F238E27FC236}">
-                <a16:creationId xmlns:a16="http://schemas.microsoft.com/office/drawing/2014/main" id="{2899F56B-F5F1-486D-8416-3329F3FA3222}"/>
+                <a16:creationId xmlns:a16="http://schemas.microsoft.com/office/drawing/2014/main" id="{8F44A2E7-9BD6-4079-937A-CFA7ACF00E92}"/>
               </a:ext>
             </a:extLst>
           </p:cNvPr>
@@ -2728,7 +2733,7 @@
           <p:nvPr/>
         </p:nvPicPr>
         <p:blipFill>
-          <a:blip xmlns:r="http://schemas.openxmlformats.org/officeDocument/2006/relationships" xmlns:a="http://schemas.openxmlformats.org/drawingml/2006/main" r:embed="R0f3e55033af64b3d"/>
+          <a:blip xmlns:r="http://schemas.openxmlformats.org/officeDocument/2006/relationships" xmlns:a="http://schemas.openxmlformats.org/drawingml/2006/main" r:embed="R44bebcc1930c4710"/>
           <a:stretch xmlns:a="http://schemas.openxmlformats.org/drawingml/2006/main"/>
         </p:blipFill>
         <p:spPr>
@@ -2746,7 +2751,7 @@
           <p:cNvPr id="13" name="text-23">
             <a:extLst xmlns:a="http://schemas.openxmlformats.org/drawingml/2006/main">
               <a:ext uri="{FF2B5EF4-FFF2-40B4-BE49-F238E27FC236}">
-                <a16:creationId xmlns:a16="http://schemas.microsoft.com/office/drawing/2014/main" id="{6298E69B-4AF4-4BEF-AE8B-C9E425D7BE87}"/>
+                <a16:creationId xmlns:a16="http://schemas.microsoft.com/office/drawing/2014/main" id="{7E92A051-BBE5-4809-9D28-826C05728046}"/>
               </a:ext>
             </a:extLst>
           </p:cNvPr>
@@ -2800,7 +2805,7 @@
     </p:spTree>
     <p:extLst>
       <p:ext uri="{BB962C8B-B14F-4D97-AF65-F5344CB8AC3E}">
-        <p14:creationId xmlns:p14="http://schemas.microsoft.com/office/powerpoint/2010/main" val="1116104727"/>
+        <p14:creationId xmlns:p14="http://schemas.microsoft.com/office/powerpoint/2010/main" val="2022796525"/>
       </p:ext>
     </p:extLst>
   </p:cSld>
@@ -2831,7 +2836,7 @@
           <p:cNvPr id="19" name="box-24">
             <a:extLst xmlns:a="http://schemas.openxmlformats.org/drawingml/2006/main">
               <a:ext uri="{FF2B5EF4-FFF2-40B4-BE49-F238E27FC236}">
-                <a16:creationId xmlns:a16="http://schemas.microsoft.com/office/drawing/2014/main" id="{785C1A73-BFDE-4131-9B76-79A0F2AF4CF5}"/>
+                <a16:creationId xmlns:a16="http://schemas.microsoft.com/office/drawing/2014/main" id="{794C1A4F-076D-4BE6-81E4-8BA499BBAE67}"/>
               </a:ext>
             </a:extLst>
           </p:cNvPr>
@@ -2864,7 +2869,7 @@
           <p:cNvPr id="2" name="text-25">
             <a:extLst xmlns:a="http://schemas.openxmlformats.org/drawingml/2006/main">
               <a:ext uri="{FF2B5EF4-FFF2-40B4-BE49-F238E27FC236}">
-                <a16:creationId xmlns:a16="http://schemas.microsoft.com/office/drawing/2014/main" id="{0D7087E7-F568-4559-8C03-EA7EF678BC83}"/>
+                <a16:creationId xmlns:a16="http://schemas.microsoft.com/office/drawing/2014/main" id="{5B442726-6168-4B1F-A5C8-009AA4F375E6}"/>
               </a:ext>
             </a:extLst>
           </p:cNvPr>
@@ -2920,7 +2925,7 @@
           <p:cNvPr id="3" name="text-26">
             <a:extLst xmlns:a="http://schemas.openxmlformats.org/drawingml/2006/main">
               <a:ext uri="{FF2B5EF4-FFF2-40B4-BE49-F238E27FC236}">
-                <a16:creationId xmlns:a16="http://schemas.microsoft.com/office/drawing/2014/main" id="{E31C89F9-005B-46C1-AF94-04D1D0F458C1}"/>
+                <a16:creationId xmlns:a16="http://schemas.microsoft.com/office/drawing/2014/main" id="{49FDF277-6683-4DA2-B0B5-AB7B708EB39A}"/>
               </a:ext>
             </a:extLst>
           </p:cNvPr>
@@ -2976,7 +2981,7 @@
           <p:cNvPr id="4" name="text-27">
             <a:extLst xmlns:a="http://schemas.openxmlformats.org/drawingml/2006/main">
               <a:ext uri="{FF2B5EF4-FFF2-40B4-BE49-F238E27FC236}">
-                <a16:creationId xmlns:a16="http://schemas.microsoft.com/office/drawing/2014/main" id="{EF1B1B87-1448-48EF-81C1-140BCD9A727E}"/>
+                <a16:creationId xmlns:a16="http://schemas.microsoft.com/office/drawing/2014/main" id="{2D867B5F-D3E3-4936-980D-876BFB52AE82}"/>
               </a:ext>
             </a:extLst>
           </p:cNvPr>
@@ -3032,7 +3037,7 @@
           <p:cNvPr id="5" name="text-28">
             <a:extLst xmlns:a="http://schemas.openxmlformats.org/drawingml/2006/main">
               <a:ext uri="{FF2B5EF4-FFF2-40B4-BE49-F238E27FC236}">
-                <a16:creationId xmlns:a16="http://schemas.microsoft.com/office/drawing/2014/main" id="{1FD0BCC0-9E9C-4637-800F-ABCEB0CB8691}"/>
+                <a16:creationId xmlns:a16="http://schemas.microsoft.com/office/drawing/2014/main" id="{C83BDE62-72E9-4CEE-818F-AB747E5EA0C5}"/>
               </a:ext>
             </a:extLst>
           </p:cNvPr>
@@ -3088,7 +3093,7 @@
           <p:cNvPr id="6" name="text-29">
             <a:extLst xmlns:a="http://schemas.openxmlformats.org/drawingml/2006/main">
               <a:ext uri="{FF2B5EF4-FFF2-40B4-BE49-F238E27FC236}">
-                <a16:creationId xmlns:a16="http://schemas.microsoft.com/office/drawing/2014/main" id="{0CCEB4AA-BCD1-4CC9-BD39-A2FCBE651B3D}"/>
+                <a16:creationId xmlns:a16="http://schemas.microsoft.com/office/drawing/2014/main" id="{8CFA9AFF-E82F-4DD3-919D-D5CD2DDAE6A8}"/>
               </a:ext>
             </a:extLst>
           </p:cNvPr>
@@ -3144,7 +3149,7 @@
           <p:cNvPr id="7" name="box-30">
             <a:extLst xmlns:a="http://schemas.openxmlformats.org/drawingml/2006/main">
               <a:ext uri="{FF2B5EF4-FFF2-40B4-BE49-F238E27FC236}">
-                <a16:creationId xmlns:a16="http://schemas.microsoft.com/office/drawing/2014/main" id="{DD5AD303-7742-4B16-BD0F-E57D4FD0E769}"/>
+                <a16:creationId xmlns:a16="http://schemas.microsoft.com/office/drawing/2014/main" id="{80698B3A-CC96-4BA6-A786-5114C9042D35}"/>
               </a:ext>
             </a:extLst>
           </p:cNvPr>
@@ -3177,7 +3182,7 @@
           <p:cNvPr id="8" name="text-31">
             <a:extLst xmlns:a="http://schemas.openxmlformats.org/drawingml/2006/main">
               <a:ext uri="{FF2B5EF4-FFF2-40B4-BE49-F238E27FC236}">
-                <a16:creationId xmlns:a16="http://schemas.microsoft.com/office/drawing/2014/main" id="{65EC0C35-C1F4-4C6F-B41C-C9D0082A5E7E}"/>
+                <a16:creationId xmlns:a16="http://schemas.microsoft.com/office/drawing/2014/main" id="{A46491DA-C0FD-4E3B-B343-D06A0B896BE2}"/>
               </a:ext>
             </a:extLst>
           </p:cNvPr>
@@ -3233,7 +3238,7 @@
           <p:cNvPr id="9" name="text-32">
             <a:extLst xmlns:a="http://schemas.openxmlformats.org/drawingml/2006/main">
               <a:ext uri="{FF2B5EF4-FFF2-40B4-BE49-F238E27FC236}">
-                <a16:creationId xmlns:a16="http://schemas.microsoft.com/office/drawing/2014/main" id="{2AFA887A-A4D5-4A91-9AEF-16011EA22015}"/>
+                <a16:creationId xmlns:a16="http://schemas.microsoft.com/office/drawing/2014/main" id="{82E94A7E-D0E1-42F3-8EA7-9173E17E74E9}"/>
               </a:ext>
             </a:extLst>
           </p:cNvPr>
@@ -3289,7 +3294,7 @@
           <p:cNvPr id="10" name="text-33">
             <a:extLst xmlns:a="http://schemas.openxmlformats.org/drawingml/2006/main">
               <a:ext uri="{FF2B5EF4-FFF2-40B4-BE49-F238E27FC236}">
-                <a16:creationId xmlns:a16="http://schemas.microsoft.com/office/drawing/2014/main" id="{15A42E34-8285-4C3A-8EB0-576142CCE61A}"/>
+                <a16:creationId xmlns:a16="http://schemas.microsoft.com/office/drawing/2014/main" id="{18AD1510-EF5B-4248-B561-A34A8D57249D}"/>
               </a:ext>
             </a:extLst>
           </p:cNvPr>
@@ -3345,7 +3350,7 @@
           <p:cNvPr id="11" name="box-34">
             <a:extLst xmlns:a="http://schemas.openxmlformats.org/drawingml/2006/main">
               <a:ext uri="{FF2B5EF4-FFF2-40B4-BE49-F238E27FC236}">
-                <a16:creationId xmlns:a16="http://schemas.microsoft.com/office/drawing/2014/main" id="{98015508-5830-434C-849C-5569682FD405}"/>
+                <a16:creationId xmlns:a16="http://schemas.microsoft.com/office/drawing/2014/main" id="{869F3B1B-6B84-4A71-938C-547B5B365D26}"/>
               </a:ext>
             </a:extLst>
           </p:cNvPr>
@@ -3378,7 +3383,7 @@
           <p:cNvPr id="12" name="text-35">
             <a:extLst xmlns:a="http://schemas.openxmlformats.org/drawingml/2006/main">
               <a:ext uri="{FF2B5EF4-FFF2-40B4-BE49-F238E27FC236}">
-                <a16:creationId xmlns:a16="http://schemas.microsoft.com/office/drawing/2014/main" id="{01EDE3CE-087F-4BF3-B0CA-F341FF5DBB6D}"/>
+                <a16:creationId xmlns:a16="http://schemas.microsoft.com/office/drawing/2014/main" id="{BCD1F13A-BA37-4E2B-8549-383615414E30}"/>
               </a:ext>
             </a:extLst>
           </p:cNvPr>
@@ -3434,7 +3439,7 @@
           <p:cNvPr id="13" name="text-36">
             <a:extLst xmlns:a="http://schemas.openxmlformats.org/drawingml/2006/main">
               <a:ext uri="{FF2B5EF4-FFF2-40B4-BE49-F238E27FC236}">
-                <a16:creationId xmlns:a16="http://schemas.microsoft.com/office/drawing/2014/main" id="{A4C5D945-B0FE-4193-A339-9841409080B2}"/>
+                <a16:creationId xmlns:a16="http://schemas.microsoft.com/office/drawing/2014/main" id="{DE09831D-6F19-4048-96BF-0EA3D445F070}"/>
               </a:ext>
             </a:extLst>
           </p:cNvPr>
@@ -3490,7 +3495,7 @@
           <p:cNvPr id="14" name="text-37">
             <a:extLst xmlns:a="http://schemas.openxmlformats.org/drawingml/2006/main">
               <a:ext uri="{FF2B5EF4-FFF2-40B4-BE49-F238E27FC236}">
-                <a16:creationId xmlns:a16="http://schemas.microsoft.com/office/drawing/2014/main" id="{3A421B5B-CFAC-4F74-860C-F6DC462F1E6D}"/>
+                <a16:creationId xmlns:a16="http://schemas.microsoft.com/office/drawing/2014/main" id="{58518209-6109-4951-82D6-E69CA41B8243}"/>
               </a:ext>
             </a:extLst>
           </p:cNvPr>
@@ -3546,7 +3551,7 @@
           <p:cNvPr id="15" name="box-38">
             <a:extLst xmlns:a="http://schemas.openxmlformats.org/drawingml/2006/main">
               <a:ext uri="{FF2B5EF4-FFF2-40B4-BE49-F238E27FC236}">
-                <a16:creationId xmlns:a16="http://schemas.microsoft.com/office/drawing/2014/main" id="{5B3464BE-3E99-4A2F-BE99-0345620DA956}"/>
+                <a16:creationId xmlns:a16="http://schemas.microsoft.com/office/drawing/2014/main" id="{0DE4E7F9-6407-4AC8-AC6C-85CEC5FB865F}"/>
               </a:ext>
             </a:extLst>
           </p:cNvPr>
@@ -3579,7 +3584,7 @@
           <p:cNvPr id="16" name="text-39">
             <a:extLst xmlns:a="http://schemas.openxmlformats.org/drawingml/2006/main">
               <a:ext uri="{FF2B5EF4-FFF2-40B4-BE49-F238E27FC236}">
-                <a16:creationId xmlns:a16="http://schemas.microsoft.com/office/drawing/2014/main" id="{39B57AF5-14A9-44FE-AFA1-FB879E727568}"/>
+                <a16:creationId xmlns:a16="http://schemas.microsoft.com/office/drawing/2014/main" id="{94346061-2019-44CA-88E3-8D60A0266F29}"/>
               </a:ext>
             </a:extLst>
           </p:cNvPr>
@@ -3635,7 +3640,7 @@
           <p:cNvPr id="17" name="text-40">
             <a:extLst xmlns:a="http://schemas.openxmlformats.org/drawingml/2006/main">
               <a:ext uri="{FF2B5EF4-FFF2-40B4-BE49-F238E27FC236}">
-                <a16:creationId xmlns:a16="http://schemas.microsoft.com/office/drawing/2014/main" id="{6211E0DA-3DA2-4258-B41F-8E59D48F078B}"/>
+                <a16:creationId xmlns:a16="http://schemas.microsoft.com/office/drawing/2014/main" id="{BD7A2075-A05F-478E-A810-0356E7C78E10}"/>
               </a:ext>
             </a:extLst>
           </p:cNvPr>
@@ -3691,7 +3696,7 @@
           <p:cNvPr id="18" name="text-41">
             <a:extLst xmlns:a="http://schemas.openxmlformats.org/drawingml/2006/main">
               <a:ext uri="{FF2B5EF4-FFF2-40B4-BE49-F238E27FC236}">
-                <a16:creationId xmlns:a16="http://schemas.microsoft.com/office/drawing/2014/main" id="{756113A7-D82A-4A4F-B738-2E181BDCF493}"/>
+                <a16:creationId xmlns:a16="http://schemas.microsoft.com/office/drawing/2014/main" id="{2E32DF77-2D8F-45EB-B24F-BD78DEED0678}"/>
               </a:ext>
             </a:extLst>
           </p:cNvPr>
@@ -3745,7 +3750,7 @@
     </p:spTree>
     <p:extLst>
       <p:ext uri="{BB962C8B-B14F-4D97-AF65-F5344CB8AC3E}">
-        <p14:creationId xmlns:p14="http://schemas.microsoft.com/office/powerpoint/2010/main" val="629333680"/>
+        <p14:creationId xmlns:p14="http://schemas.microsoft.com/office/powerpoint/2010/main" val="1134542902"/>
       </p:ext>
     </p:extLst>
   </p:cSld>
@@ -3776,7 +3781,7 @@
           <p:cNvPr id="18" name="box-42">
             <a:extLst xmlns:a="http://schemas.openxmlformats.org/drawingml/2006/main">
               <a:ext uri="{FF2B5EF4-FFF2-40B4-BE49-F238E27FC236}">
-                <a16:creationId xmlns:a16="http://schemas.microsoft.com/office/drawing/2014/main" id="{BBF8F542-F407-48E0-9EA1-9755DDF7839E}"/>
+                <a16:creationId xmlns:a16="http://schemas.microsoft.com/office/drawing/2014/main" id="{67F0E3EF-91C9-476C-B381-3137217139E1}"/>
               </a:ext>
             </a:extLst>
           </p:cNvPr>
@@ -3809,7 +3814,7 @@
           <p:cNvPr id="2" name="text-43">
             <a:extLst xmlns:a="http://schemas.openxmlformats.org/drawingml/2006/main">
               <a:ext uri="{FF2B5EF4-FFF2-40B4-BE49-F238E27FC236}">
-                <a16:creationId xmlns:a16="http://schemas.microsoft.com/office/drawing/2014/main" id="{964B489B-3097-4938-8D73-BF5E64B74167}"/>
+                <a16:creationId xmlns:a16="http://schemas.microsoft.com/office/drawing/2014/main" id="{6FB4FDCF-2193-4093-BDD3-756379C376BC}"/>
               </a:ext>
             </a:extLst>
           </p:cNvPr>
@@ -3865,7 +3870,7 @@
           <p:cNvPr id="3" name="text-44">
             <a:extLst xmlns:a="http://schemas.openxmlformats.org/drawingml/2006/main">
               <a:ext uri="{FF2B5EF4-FFF2-40B4-BE49-F238E27FC236}">
-                <a16:creationId xmlns:a16="http://schemas.microsoft.com/office/drawing/2014/main" id="{BEFE49F0-26BF-455A-89EF-4D3B73DF038F}"/>
+                <a16:creationId xmlns:a16="http://schemas.microsoft.com/office/drawing/2014/main" id="{368E7495-94F6-49FD-96E3-427E82810D89}"/>
               </a:ext>
             </a:extLst>
           </p:cNvPr>
@@ -3921,7 +3926,7 @@
           <p:cNvPr id="4" name="text-45">
             <a:extLst xmlns:a="http://schemas.openxmlformats.org/drawingml/2006/main">
               <a:ext uri="{FF2B5EF4-FFF2-40B4-BE49-F238E27FC236}">
-                <a16:creationId xmlns:a16="http://schemas.microsoft.com/office/drawing/2014/main" id="{2225137A-3D7F-4E04-A8EF-1E3017366419}"/>
+                <a16:creationId xmlns:a16="http://schemas.microsoft.com/office/drawing/2014/main" id="{8BF8A537-760A-438F-8121-04C216AB84CB}"/>
               </a:ext>
             </a:extLst>
           </p:cNvPr>
@@ -3977,7 +3982,7 @@
           <p:cNvPr id="5" name="text-46">
             <a:extLst xmlns:a="http://schemas.openxmlformats.org/drawingml/2006/main">
               <a:ext uri="{FF2B5EF4-FFF2-40B4-BE49-F238E27FC236}">
-                <a16:creationId xmlns:a16="http://schemas.microsoft.com/office/drawing/2014/main" id="{1021882F-BD72-4E59-A583-5E24BF8E7223}"/>
+                <a16:creationId xmlns:a16="http://schemas.microsoft.com/office/drawing/2014/main" id="{7AFDD9D2-C5B1-457C-86DE-2DCDF5587F61}"/>
               </a:ext>
             </a:extLst>
           </p:cNvPr>
@@ -4033,7 +4038,7 @@
           <p:cNvPr id="6" name="box-47">
             <a:extLst xmlns:a="http://schemas.openxmlformats.org/drawingml/2006/main">
               <a:ext uri="{FF2B5EF4-FFF2-40B4-BE49-F238E27FC236}">
-                <a16:creationId xmlns:a16="http://schemas.microsoft.com/office/drawing/2014/main" id="{E35444BD-BF71-442A-ABA8-1DB509690504}"/>
+                <a16:creationId xmlns:a16="http://schemas.microsoft.com/office/drawing/2014/main" id="{DA4ACD0C-DF6C-44F1-976C-C9BB2CE4339A}"/>
               </a:ext>
             </a:extLst>
           </p:cNvPr>
@@ -4066,7 +4071,7 @@
           <p:cNvPr id="7" name="text-48">
             <a:extLst xmlns:a="http://schemas.openxmlformats.org/drawingml/2006/main">
               <a:ext uri="{FF2B5EF4-FFF2-40B4-BE49-F238E27FC236}">
-                <a16:creationId xmlns:a16="http://schemas.microsoft.com/office/drawing/2014/main" id="{0E4C7119-177B-411C-9FF2-3E3173FC94F8}"/>
+                <a16:creationId xmlns:a16="http://schemas.microsoft.com/office/drawing/2014/main" id="{1139617D-2B9B-4015-B912-DB6C8E880E9F}"/>
               </a:ext>
             </a:extLst>
           </p:cNvPr>
@@ -4122,7 +4127,7 @@
           <p:cNvPr id="8" name="text-49">
             <a:extLst xmlns:a="http://schemas.openxmlformats.org/drawingml/2006/main">
               <a:ext uri="{FF2B5EF4-FFF2-40B4-BE49-F238E27FC236}">
-                <a16:creationId xmlns:a16="http://schemas.microsoft.com/office/drawing/2014/main" id="{B6E7277E-FAE5-43B5-AB7F-1D289EC171EA}"/>
+                <a16:creationId xmlns:a16="http://schemas.microsoft.com/office/drawing/2014/main" id="{B792D042-789E-48F8-A6F9-C394C3C41D06}"/>
               </a:ext>
             </a:extLst>
           </p:cNvPr>
@@ -4178,7 +4183,7 @@
           <p:cNvPr id="9" name="box-50">
             <a:extLst xmlns:a="http://schemas.openxmlformats.org/drawingml/2006/main">
               <a:ext uri="{FF2B5EF4-FFF2-40B4-BE49-F238E27FC236}">
-                <a16:creationId xmlns:a16="http://schemas.microsoft.com/office/drawing/2014/main" id="{1BC37BA5-BD0B-4450-B8C6-2B9CDF22D46B}"/>
+                <a16:creationId xmlns:a16="http://schemas.microsoft.com/office/drawing/2014/main" id="{27B1A7F3-AE4B-4B1B-A203-0FC4D146ABFE}"/>
               </a:ext>
             </a:extLst>
           </p:cNvPr>
@@ -4211,7 +4216,7 @@
           <p:cNvPr id="10" name="text-51">
             <a:extLst xmlns:a="http://schemas.openxmlformats.org/drawingml/2006/main">
               <a:ext uri="{FF2B5EF4-FFF2-40B4-BE49-F238E27FC236}">
-                <a16:creationId xmlns:a16="http://schemas.microsoft.com/office/drawing/2014/main" id="{10423DCE-94A9-4C2A-BF7C-90864CA92BDE}"/>
+                <a16:creationId xmlns:a16="http://schemas.microsoft.com/office/drawing/2014/main" id="{2926012E-BE38-4530-A396-2F5D2A42B3EB}"/>
               </a:ext>
             </a:extLst>
           </p:cNvPr>
@@ -4267,7 +4272,7 @@
           <p:cNvPr id="11" name="text-52">
             <a:extLst xmlns:a="http://schemas.openxmlformats.org/drawingml/2006/main">
               <a:ext uri="{FF2B5EF4-FFF2-40B4-BE49-F238E27FC236}">
-                <a16:creationId xmlns:a16="http://schemas.microsoft.com/office/drawing/2014/main" id="{E610272D-B74B-4FB1-AEEC-70A9C8091998}"/>
+                <a16:creationId xmlns:a16="http://schemas.microsoft.com/office/drawing/2014/main" id="{A74348C3-3CC1-4910-8789-5A8DC359E6D6}"/>
               </a:ext>
             </a:extLst>
           </p:cNvPr>
@@ -4323,7 +4328,7 @@
           <p:cNvPr id="12" name="box-53">
             <a:extLst xmlns:a="http://schemas.openxmlformats.org/drawingml/2006/main">
               <a:ext uri="{FF2B5EF4-FFF2-40B4-BE49-F238E27FC236}">
-                <a16:creationId xmlns:a16="http://schemas.microsoft.com/office/drawing/2014/main" id="{B80C276B-CD09-431C-8144-E900A38645CA}"/>
+                <a16:creationId xmlns:a16="http://schemas.microsoft.com/office/drawing/2014/main" id="{EF42DFD7-6833-4A54-A9D4-AD081BC9FCFD}"/>
               </a:ext>
             </a:extLst>
           </p:cNvPr>
@@ -4356,7 +4361,7 @@
           <p:cNvPr id="13" name="text-54">
             <a:extLst xmlns:a="http://schemas.openxmlformats.org/drawingml/2006/main">
               <a:ext uri="{FF2B5EF4-FFF2-40B4-BE49-F238E27FC236}">
-                <a16:creationId xmlns:a16="http://schemas.microsoft.com/office/drawing/2014/main" id="{C78B6E05-2B64-4598-96D4-615D97E7847E}"/>
+                <a16:creationId xmlns:a16="http://schemas.microsoft.com/office/drawing/2014/main" id="{8525FDE6-EB1D-453D-9896-CA66C88604A1}"/>
               </a:ext>
             </a:extLst>
           </p:cNvPr>
@@ -4412,7 +4417,7 @@
           <p:cNvPr id="14" name="text-55">
             <a:extLst xmlns:a="http://schemas.openxmlformats.org/drawingml/2006/main">
               <a:ext uri="{FF2B5EF4-FFF2-40B4-BE49-F238E27FC236}">
-                <a16:creationId xmlns:a16="http://schemas.microsoft.com/office/drawing/2014/main" id="{FC33718F-5EC2-43B4-AE5D-A4059474CCF2}"/>
+                <a16:creationId xmlns:a16="http://schemas.microsoft.com/office/drawing/2014/main" id="{75802C17-A084-4E44-B950-88D0732340D6}"/>
               </a:ext>
             </a:extLst>
           </p:cNvPr>
@@ -4468,7 +4473,7 @@
           <p:cNvPr id="15" name="box-56">
             <a:extLst xmlns:a="http://schemas.openxmlformats.org/drawingml/2006/main">
               <a:ext uri="{FF2B5EF4-FFF2-40B4-BE49-F238E27FC236}">
-                <a16:creationId xmlns:a16="http://schemas.microsoft.com/office/drawing/2014/main" id="{00891825-ED6E-4753-BD22-0011C7773E48}"/>
+                <a16:creationId xmlns:a16="http://schemas.microsoft.com/office/drawing/2014/main" id="{A4999BE6-9176-4A24-81D7-ECA4E970ECD8}"/>
               </a:ext>
             </a:extLst>
           </p:cNvPr>
@@ -4501,7 +4506,7 @@
           <p:cNvPr id="16" name="text-57">
             <a:extLst xmlns:a="http://schemas.openxmlformats.org/drawingml/2006/main">
               <a:ext uri="{FF2B5EF4-FFF2-40B4-BE49-F238E27FC236}">
-                <a16:creationId xmlns:a16="http://schemas.microsoft.com/office/drawing/2014/main" id="{9593AD3F-EA37-45C0-B58B-FD5C5CF6D016}"/>
+                <a16:creationId xmlns:a16="http://schemas.microsoft.com/office/drawing/2014/main" id="{52A3737A-1EA2-46A1-969A-702905503905}"/>
               </a:ext>
             </a:extLst>
           </p:cNvPr>
@@ -4557,7 +4562,7 @@
           <p:cNvPr id="17" name="text-58">
             <a:extLst xmlns:a="http://schemas.openxmlformats.org/drawingml/2006/main">
               <a:ext uri="{FF2B5EF4-FFF2-40B4-BE49-F238E27FC236}">
-                <a16:creationId xmlns:a16="http://schemas.microsoft.com/office/drawing/2014/main" id="{9C0B2FC0-80D8-414F-B64C-788A5790D831}"/>
+                <a16:creationId xmlns:a16="http://schemas.microsoft.com/office/drawing/2014/main" id="{604865D1-C0D9-41B4-A656-487064A1035A}"/>
               </a:ext>
             </a:extLst>
           </p:cNvPr>
@@ -4611,7 +4616,7 @@
     </p:spTree>
     <p:extLst>
       <p:ext uri="{BB962C8B-B14F-4D97-AF65-F5344CB8AC3E}">
-        <p14:creationId xmlns:p14="http://schemas.microsoft.com/office/powerpoint/2010/main" val="2143948592"/>
+        <p14:creationId xmlns:p14="http://schemas.microsoft.com/office/powerpoint/2010/main" val="876660766"/>
       </p:ext>
     </p:extLst>
   </p:cSld>
@@ -4642,7 +4647,7 @@
           <p:cNvPr id="21" name="box-59">
             <a:extLst xmlns:a="http://schemas.openxmlformats.org/drawingml/2006/main">
               <a:ext uri="{FF2B5EF4-FFF2-40B4-BE49-F238E27FC236}">
-                <a16:creationId xmlns:a16="http://schemas.microsoft.com/office/drawing/2014/main" id="{CDC52F53-0815-4D53-99B3-492C96519D8A}"/>
+                <a16:creationId xmlns:a16="http://schemas.microsoft.com/office/drawing/2014/main" id="{FB473E37-7B85-4869-B0AF-A8E7AD8F4AC3}"/>
               </a:ext>
             </a:extLst>
           </p:cNvPr>
@@ -4675,7 +4680,7 @@
           <p:cNvPr id="2" name="text-60">
             <a:extLst xmlns:a="http://schemas.openxmlformats.org/drawingml/2006/main">
               <a:ext uri="{FF2B5EF4-FFF2-40B4-BE49-F238E27FC236}">
-                <a16:creationId xmlns:a16="http://schemas.microsoft.com/office/drawing/2014/main" id="{2B16D6E0-349C-4A63-88B9-D0AD92E8349D}"/>
+                <a16:creationId xmlns:a16="http://schemas.microsoft.com/office/drawing/2014/main" id="{223E0C47-A24D-4117-90B9-FB0DBA8CE697}"/>
               </a:ext>
             </a:extLst>
           </p:cNvPr>
@@ -4731,7 +4736,7 @@
           <p:cNvPr id="3" name="text-61">
             <a:extLst xmlns:a="http://schemas.openxmlformats.org/drawingml/2006/main">
               <a:ext uri="{FF2B5EF4-FFF2-40B4-BE49-F238E27FC236}">
-                <a16:creationId xmlns:a16="http://schemas.microsoft.com/office/drawing/2014/main" id="{8D1E7A65-F793-426E-90A6-6A32CAD10D37}"/>
+                <a16:creationId xmlns:a16="http://schemas.microsoft.com/office/drawing/2014/main" id="{A8144FDD-C565-47CD-84A5-CC8899056F7E}"/>
               </a:ext>
             </a:extLst>
           </p:cNvPr>
@@ -4787,7 +4792,7 @@
           <p:cNvPr id="4" name="text-62">
             <a:extLst xmlns:a="http://schemas.openxmlformats.org/drawingml/2006/main">
               <a:ext uri="{FF2B5EF4-FFF2-40B4-BE49-F238E27FC236}">
-                <a16:creationId xmlns:a16="http://schemas.microsoft.com/office/drawing/2014/main" id="{36316339-69E2-45B3-A7FE-1D24A553328E}"/>
+                <a16:creationId xmlns:a16="http://schemas.microsoft.com/office/drawing/2014/main" id="{14AB353F-4279-4C0E-A7A1-6D26AA6B5C57}"/>
               </a:ext>
             </a:extLst>
           </p:cNvPr>
@@ -4843,7 +4848,7 @@
           <p:cNvPr id="5" name="text-63">
             <a:extLst xmlns:a="http://schemas.openxmlformats.org/drawingml/2006/main">
               <a:ext uri="{FF2B5EF4-FFF2-40B4-BE49-F238E27FC236}">
-                <a16:creationId xmlns:a16="http://schemas.microsoft.com/office/drawing/2014/main" id="{D32BE33D-BED4-414D-9FCA-D5AC48CBC959}"/>
+                <a16:creationId xmlns:a16="http://schemas.microsoft.com/office/drawing/2014/main" id="{D878E27B-5862-4659-A742-4917FF7E75B4}"/>
               </a:ext>
             </a:extLst>
           </p:cNvPr>
@@ -4899,7 +4904,7 @@
           <p:cNvPr id="6" name="box-64">
             <a:extLst xmlns:a="http://schemas.openxmlformats.org/drawingml/2006/main">
               <a:ext uri="{FF2B5EF4-FFF2-40B4-BE49-F238E27FC236}">
-                <a16:creationId xmlns:a16="http://schemas.microsoft.com/office/drawing/2014/main" id="{3167286F-5955-46C4-9D3A-FD6273D97153}"/>
+                <a16:creationId xmlns:a16="http://schemas.microsoft.com/office/drawing/2014/main" id="{A7B7C423-B128-4B70-B1B3-3BD6B2FB60F9}"/>
               </a:ext>
             </a:extLst>
           </p:cNvPr>
@@ -4932,7 +4937,7 @@
           <p:cNvPr id="7" name="dot-65">
             <a:extLst xmlns:a="http://schemas.openxmlformats.org/drawingml/2006/main">
               <a:ext uri="{FF2B5EF4-FFF2-40B4-BE49-F238E27FC236}">
-                <a16:creationId xmlns:a16="http://schemas.microsoft.com/office/drawing/2014/main" id="{23C29A9D-74C3-4E73-B7AA-5F30AF8E5643}"/>
+                <a16:creationId xmlns:a16="http://schemas.microsoft.com/office/drawing/2014/main" id="{F517A83B-C1E7-4668-8199-B82C431AF16E}"/>
               </a:ext>
             </a:extLst>
           </p:cNvPr>
@@ -4963,7 +4968,7 @@
           <p:cNvPr id="8" name="text-66">
             <a:extLst xmlns:a="http://schemas.openxmlformats.org/drawingml/2006/main">
               <a:ext uri="{FF2B5EF4-FFF2-40B4-BE49-F238E27FC236}">
-                <a16:creationId xmlns:a16="http://schemas.microsoft.com/office/drawing/2014/main" id="{4C0B7532-569F-4DA5-A49D-22D9BADDED19}"/>
+                <a16:creationId xmlns:a16="http://schemas.microsoft.com/office/drawing/2014/main" id="{46E7FC02-7F62-4A18-AD02-07B874F84597}"/>
               </a:ext>
             </a:extLst>
           </p:cNvPr>
@@ -5019,7 +5024,7 @@
           <p:cNvPr id="9" name="text-67">
             <a:extLst xmlns:a="http://schemas.openxmlformats.org/drawingml/2006/main">
               <a:ext uri="{FF2B5EF4-FFF2-40B4-BE49-F238E27FC236}">
-                <a16:creationId xmlns:a16="http://schemas.microsoft.com/office/drawing/2014/main" id="{F6C43AF8-BEAB-4843-8EF3-D3C057910912}"/>
+                <a16:creationId xmlns:a16="http://schemas.microsoft.com/office/drawing/2014/main" id="{DE3B1ED9-BB49-474A-8C6A-DBCFFF19D0F0}"/>
               </a:ext>
             </a:extLst>
           </p:cNvPr>
@@ -5075,7 +5080,7 @@
           <p:cNvPr id="10" name="text-68">
             <a:extLst xmlns:a="http://schemas.openxmlformats.org/drawingml/2006/main">
               <a:ext uri="{FF2B5EF4-FFF2-40B4-BE49-F238E27FC236}">
-                <a16:creationId xmlns:a16="http://schemas.microsoft.com/office/drawing/2014/main" id="{39A3C2EF-5E90-4F61-9765-2E60F4BCB749}"/>
+                <a16:creationId xmlns:a16="http://schemas.microsoft.com/office/drawing/2014/main" id="{F00CC188-D5AC-4DEC-A471-54A91E82C336}"/>
               </a:ext>
             </a:extLst>
           </p:cNvPr>
@@ -5131,7 +5136,7 @@
           <p:cNvPr id="11" name="dot-69">
             <a:extLst xmlns:a="http://schemas.openxmlformats.org/drawingml/2006/main">
               <a:ext uri="{FF2B5EF4-FFF2-40B4-BE49-F238E27FC236}">
-                <a16:creationId xmlns:a16="http://schemas.microsoft.com/office/drawing/2014/main" id="{A256F181-DA1A-4C54-B5E6-B3234102579A}"/>
+                <a16:creationId xmlns:a16="http://schemas.microsoft.com/office/drawing/2014/main" id="{9E1C1005-C29B-481C-A93B-2EF692AA2CE4}"/>
               </a:ext>
             </a:extLst>
           </p:cNvPr>
@@ -5162,7 +5167,7 @@
           <p:cNvPr id="12" name="text-70">
             <a:extLst xmlns:a="http://schemas.openxmlformats.org/drawingml/2006/main">
               <a:ext uri="{FF2B5EF4-FFF2-40B4-BE49-F238E27FC236}">
-                <a16:creationId xmlns:a16="http://schemas.microsoft.com/office/drawing/2014/main" id="{E1C0027F-322E-4D91-84F2-C27E74C5D076}"/>
+                <a16:creationId xmlns:a16="http://schemas.microsoft.com/office/drawing/2014/main" id="{5AF22C96-9D87-4684-BB0A-875A0059229B}"/>
               </a:ext>
             </a:extLst>
           </p:cNvPr>
@@ -5218,7 +5223,7 @@
           <p:cNvPr id="13" name="text-71">
             <a:extLst xmlns:a="http://schemas.openxmlformats.org/drawingml/2006/main">
               <a:ext uri="{FF2B5EF4-FFF2-40B4-BE49-F238E27FC236}">
-                <a16:creationId xmlns:a16="http://schemas.microsoft.com/office/drawing/2014/main" id="{A59CADED-6F62-4CD7-B5C4-11CF7A6C2759}"/>
+                <a16:creationId xmlns:a16="http://schemas.microsoft.com/office/drawing/2014/main" id="{F7D1BB8C-0D7F-489E-ACA1-957BDEB2DD2D}"/>
               </a:ext>
             </a:extLst>
           </p:cNvPr>
@@ -5274,7 +5279,7 @@
           <p:cNvPr id="14" name="text-72">
             <a:extLst xmlns:a="http://schemas.openxmlformats.org/drawingml/2006/main">
               <a:ext uri="{FF2B5EF4-FFF2-40B4-BE49-F238E27FC236}">
-                <a16:creationId xmlns:a16="http://schemas.microsoft.com/office/drawing/2014/main" id="{0249D5E8-5E03-4496-B435-71669E1A67BE}"/>
+                <a16:creationId xmlns:a16="http://schemas.microsoft.com/office/drawing/2014/main" id="{3CD65CA8-7104-4B14-BAE4-78B910D85FAC}"/>
               </a:ext>
             </a:extLst>
           </p:cNvPr>
@@ -5330,7 +5335,7 @@
           <p:cNvPr id="15" name="dot-73">
             <a:extLst xmlns:a="http://schemas.openxmlformats.org/drawingml/2006/main">
               <a:ext uri="{FF2B5EF4-FFF2-40B4-BE49-F238E27FC236}">
-                <a16:creationId xmlns:a16="http://schemas.microsoft.com/office/drawing/2014/main" id="{524D57E7-7418-40A1-B0EF-A045AF90D50E}"/>
+                <a16:creationId xmlns:a16="http://schemas.microsoft.com/office/drawing/2014/main" id="{4CEA908C-C365-441C-BC65-D8FEB3997ED3}"/>
               </a:ext>
             </a:extLst>
           </p:cNvPr>
@@ -5361,7 +5366,7 @@
           <p:cNvPr id="16" name="text-74">
             <a:extLst xmlns:a="http://schemas.openxmlformats.org/drawingml/2006/main">
               <a:ext uri="{FF2B5EF4-FFF2-40B4-BE49-F238E27FC236}">
-                <a16:creationId xmlns:a16="http://schemas.microsoft.com/office/drawing/2014/main" id="{44DBF1DD-6026-46EB-8BE3-2FE75C7B75AD}"/>
+                <a16:creationId xmlns:a16="http://schemas.microsoft.com/office/drawing/2014/main" id="{76173E55-15FD-4468-9B12-E131A3A4FCC5}"/>
               </a:ext>
             </a:extLst>
           </p:cNvPr>
@@ -5417,7 +5422,7 @@
           <p:cNvPr id="17" name="text-75">
             <a:extLst xmlns:a="http://schemas.openxmlformats.org/drawingml/2006/main">
               <a:ext uri="{FF2B5EF4-FFF2-40B4-BE49-F238E27FC236}">
-                <a16:creationId xmlns:a16="http://schemas.microsoft.com/office/drawing/2014/main" id="{105AC89A-2EE1-4F5C-9075-A6D5E7CC1B39}"/>
+                <a16:creationId xmlns:a16="http://schemas.microsoft.com/office/drawing/2014/main" id="{9B8C1274-37A2-4AA0-80CA-7D87EF825D71}"/>
               </a:ext>
             </a:extLst>
           </p:cNvPr>
@@ -5473,7 +5478,7 @@
           <p:cNvPr id="18" name="text-76">
             <a:extLst xmlns:a="http://schemas.openxmlformats.org/drawingml/2006/main">
               <a:ext uri="{FF2B5EF4-FFF2-40B4-BE49-F238E27FC236}">
-                <a16:creationId xmlns:a16="http://schemas.microsoft.com/office/drawing/2014/main" id="{4FF73705-EDA9-4364-9C29-9FB3792CEFC5}"/>
+                <a16:creationId xmlns:a16="http://schemas.microsoft.com/office/drawing/2014/main" id="{08535279-17D2-43FC-AF99-84D77E38C720}"/>
               </a:ext>
             </a:extLst>
           </p:cNvPr>
@@ -5529,7 +5534,7 @@
           <p:cNvPr id="19" name="box-77">
             <a:extLst xmlns:a="http://schemas.openxmlformats.org/drawingml/2006/main">
               <a:ext uri="{FF2B5EF4-FFF2-40B4-BE49-F238E27FC236}">
-                <a16:creationId xmlns:a16="http://schemas.microsoft.com/office/drawing/2014/main" id="{4C600D6B-1326-49B0-A82B-565B07487405}"/>
+                <a16:creationId xmlns:a16="http://schemas.microsoft.com/office/drawing/2014/main" id="{45051014-7F20-4542-B8BD-1F642F59DD7C}"/>
               </a:ext>
             </a:extLst>
           </p:cNvPr>
@@ -5562,7 +5567,7 @@
           <p:cNvPr id="20" name="text-78">
             <a:extLst xmlns:a="http://schemas.openxmlformats.org/drawingml/2006/main">
               <a:ext uri="{FF2B5EF4-FFF2-40B4-BE49-F238E27FC236}">
-                <a16:creationId xmlns:a16="http://schemas.microsoft.com/office/drawing/2014/main" id="{87FB96E6-2CC0-4C42-96D7-7F90F3A2D901}"/>
+                <a16:creationId xmlns:a16="http://schemas.microsoft.com/office/drawing/2014/main" id="{225F76A9-BA29-453D-8954-CBDCD6629610}"/>
               </a:ext>
             </a:extLst>
           </p:cNvPr>
@@ -5616,7 +5621,7 @@
     </p:spTree>
     <p:extLst>
       <p:ext uri="{BB962C8B-B14F-4D97-AF65-F5344CB8AC3E}">
-        <p14:creationId xmlns:p14="http://schemas.microsoft.com/office/powerpoint/2010/main" val="1522194945"/>
+        <p14:creationId xmlns:p14="http://schemas.microsoft.com/office/powerpoint/2010/main" val="1384107082"/>
       </p:ext>
     </p:extLst>
   </p:cSld>
@@ -5644,10 +5649,10 @@
       </p:grpSpPr>
       <p:sp>
         <p:nvSpPr>
-          <p:cNvPr id="15" name="box-79">
-            <a:extLst xmlns:a="http://schemas.openxmlformats.org/drawingml/2006/main">
-              <a:ext uri="{FF2B5EF4-FFF2-40B4-BE49-F238E27FC236}">
-                <a16:creationId xmlns:a16="http://schemas.microsoft.com/office/drawing/2014/main" id="{DE7D0D61-9E38-4130-A1FF-DFD2215F5F2C}"/>
+          <p:cNvPr id="18" name="box-79">
+            <a:extLst xmlns:a="http://schemas.openxmlformats.org/drawingml/2006/main">
+              <a:ext uri="{FF2B5EF4-FFF2-40B4-BE49-F238E27FC236}">
+                <a16:creationId xmlns:a16="http://schemas.microsoft.com/office/drawing/2014/main" id="{ED610AAA-7DEF-4AB3-9F83-5E66D11239E1}"/>
               </a:ext>
             </a:extLst>
           </p:cNvPr>
@@ -5680,7 +5685,7 @@
           <p:cNvPr id="2" name="text-80">
             <a:extLst xmlns:a="http://schemas.openxmlformats.org/drawingml/2006/main">
               <a:ext uri="{FF2B5EF4-FFF2-40B4-BE49-F238E27FC236}">
-                <a16:creationId xmlns:a16="http://schemas.microsoft.com/office/drawing/2014/main" id="{894F8F5C-8CE0-4163-9281-EBF4BB5D9916}"/>
+                <a16:creationId xmlns:a16="http://schemas.microsoft.com/office/drawing/2014/main" id="{655FFB04-5677-4211-B205-184E7D4C1C95}"/>
               </a:ext>
             </a:extLst>
           </p:cNvPr>
@@ -5736,7 +5741,7 @@
           <p:cNvPr id="3" name="text-81">
             <a:extLst xmlns:a="http://schemas.openxmlformats.org/drawingml/2006/main">
               <a:ext uri="{FF2B5EF4-FFF2-40B4-BE49-F238E27FC236}">
-                <a16:creationId xmlns:a16="http://schemas.microsoft.com/office/drawing/2014/main" id="{3B15F3D2-31E8-4D7D-9DFE-7619BB17E4EE}"/>
+                <a16:creationId xmlns:a16="http://schemas.microsoft.com/office/drawing/2014/main" id="{856CFA1C-567D-4035-96C5-5CD47C3FDE31}"/>
               </a:ext>
             </a:extLst>
           </p:cNvPr>
@@ -5792,7 +5797,7 @@
           <p:cNvPr id="4" name="text-82">
             <a:extLst xmlns:a="http://schemas.openxmlformats.org/drawingml/2006/main">
               <a:ext uri="{FF2B5EF4-FFF2-40B4-BE49-F238E27FC236}">
-                <a16:creationId xmlns:a16="http://schemas.microsoft.com/office/drawing/2014/main" id="{AD261D4E-1470-4D9E-91D7-ADE96E797F87}"/>
+                <a16:creationId xmlns:a16="http://schemas.microsoft.com/office/drawing/2014/main" id="{D31A45CD-77EB-428A-A2D3-1A0860BC8CC5}"/>
               </a:ext>
             </a:extLst>
           </p:cNvPr>
@@ -5848,7 +5853,7 @@
           <p:cNvPr id="5" name="text-83">
             <a:extLst xmlns:a="http://schemas.openxmlformats.org/drawingml/2006/main">
               <a:ext uri="{FF2B5EF4-FFF2-40B4-BE49-F238E27FC236}">
-                <a16:creationId xmlns:a16="http://schemas.microsoft.com/office/drawing/2014/main" id="{60E33097-20B9-43D0-BA57-C6C446237E8B}"/>
+                <a16:creationId xmlns:a16="http://schemas.microsoft.com/office/drawing/2014/main" id="{D2565E15-6485-4EE3-ADE9-5D9D78EF59E6}"/>
               </a:ext>
             </a:extLst>
           </p:cNvPr>
@@ -5904,7 +5909,7 @@
           <p:cNvPr id="6" name="text-84">
             <a:extLst xmlns:a="http://schemas.openxmlformats.org/drawingml/2006/main">
               <a:ext uri="{FF2B5EF4-FFF2-40B4-BE49-F238E27FC236}">
-                <a16:creationId xmlns:a16="http://schemas.microsoft.com/office/drawing/2014/main" id="{4DA00D95-779E-43C4-82DD-8513EC9CD51E}"/>
+                <a16:creationId xmlns:a16="http://schemas.microsoft.com/office/drawing/2014/main" id="{AB1F2B34-7745-4BB7-B399-715B1C9D2FD1}"/>
               </a:ext>
             </a:extLst>
           </p:cNvPr>
@@ -5960,7 +5965,7 @@
           <p:cNvPr id="7" name="text-85">
             <a:extLst xmlns:a="http://schemas.openxmlformats.org/drawingml/2006/main">
               <a:ext uri="{FF2B5EF4-FFF2-40B4-BE49-F238E27FC236}">
-                <a16:creationId xmlns:a16="http://schemas.microsoft.com/office/drawing/2014/main" id="{F5C55E1F-9DFC-4CE4-A0F0-9580E8CCFCA2}"/>
+                <a16:creationId xmlns:a16="http://schemas.microsoft.com/office/drawing/2014/main" id="{7C6852D6-BE50-4CCA-9307-771B952D9869}"/>
               </a:ext>
             </a:extLst>
           </p:cNvPr>
@@ -6016,7 +6021,7 @@
           <p:cNvPr id="8" name="text-86">
             <a:extLst xmlns:a="http://schemas.openxmlformats.org/drawingml/2006/main">
               <a:ext uri="{FF2B5EF4-FFF2-40B4-BE49-F238E27FC236}">
-                <a16:creationId xmlns:a16="http://schemas.microsoft.com/office/drawing/2014/main" id="{48B8FE2A-BD14-4766-A0D5-602F5126D6EA}"/>
+                <a16:creationId xmlns:a16="http://schemas.microsoft.com/office/drawing/2014/main" id="{23686F73-6D27-4AE3-8D7A-D99FF3B6AD65}"/>
               </a:ext>
             </a:extLst>
           </p:cNvPr>
@@ -6072,7 +6077,7 @@
           <p:cNvPr id="9" name="text-87">
             <a:extLst xmlns:a="http://schemas.openxmlformats.org/drawingml/2006/main">
               <a:ext uri="{FF2B5EF4-FFF2-40B4-BE49-F238E27FC236}">
-                <a16:creationId xmlns:a16="http://schemas.microsoft.com/office/drawing/2014/main" id="{6E4E02FA-E5A2-4110-9712-D5A799A7EACD}"/>
+                <a16:creationId xmlns:a16="http://schemas.microsoft.com/office/drawing/2014/main" id="{F1D98C32-1C27-429A-AD0D-6DEF8ECA28B4}"/>
               </a:ext>
             </a:extLst>
           </p:cNvPr>
@@ -6128,7 +6133,7 @@
           <p:cNvPr id="10" name="text-88">
             <a:extLst xmlns:a="http://schemas.openxmlformats.org/drawingml/2006/main">
               <a:ext uri="{FF2B5EF4-FFF2-40B4-BE49-F238E27FC236}">
-                <a16:creationId xmlns:a16="http://schemas.microsoft.com/office/drawing/2014/main" id="{37A5BA4D-8565-4B54-AFB7-F34BB2D63680}"/>
+                <a16:creationId xmlns:a16="http://schemas.microsoft.com/office/drawing/2014/main" id="{9B19AF61-CE77-49EC-B95E-13B345066EF3}"/>
               </a:ext>
             </a:extLst>
           </p:cNvPr>
@@ -6230,7 +6235,7 @@
           <p:cNvPr id="11" name="text-89">
             <a:extLst xmlns:a="http://schemas.openxmlformats.org/drawingml/2006/main">
               <a:ext uri="{FF2B5EF4-FFF2-40B4-BE49-F238E27FC236}">
-                <a16:creationId xmlns:a16="http://schemas.microsoft.com/office/drawing/2014/main" id="{DCC6D4BF-B6F0-47EA-ABF0-C2D610964DB2}"/>
+                <a16:creationId xmlns:a16="http://schemas.microsoft.com/office/drawing/2014/main" id="{9ED7C3EF-D217-48AB-9080-976A3EB0054B}"/>
               </a:ext>
             </a:extLst>
           </p:cNvPr>
@@ -6332,7 +6337,7 @@
           <p:cNvPr id="12" name="text-90">
             <a:extLst xmlns:a="http://schemas.openxmlformats.org/drawingml/2006/main">
               <a:ext uri="{FF2B5EF4-FFF2-40B4-BE49-F238E27FC236}">
-                <a16:creationId xmlns:a16="http://schemas.microsoft.com/office/drawing/2014/main" id="{D2BB7972-5B4E-49D9-BD57-A77958E841B3}"/>
+                <a16:creationId xmlns:a16="http://schemas.microsoft.com/office/drawing/2014/main" id="{F879CB93-B650-4AF6-B75B-EA13866CC955}"/>
               </a:ext>
             </a:extLst>
           </p:cNvPr>
@@ -6434,7 +6439,7 @@
           <p:cNvPr id="13" name="box-91">
             <a:extLst xmlns:a="http://schemas.openxmlformats.org/drawingml/2006/main">
               <a:ext uri="{FF2B5EF4-FFF2-40B4-BE49-F238E27FC236}">
-                <a16:creationId xmlns:a16="http://schemas.microsoft.com/office/drawing/2014/main" id="{86B9DACC-BD94-43A4-87B9-D0FD40B70969}"/>
+                <a16:creationId xmlns:a16="http://schemas.microsoft.com/office/drawing/2014/main" id="{51698320-5E90-4905-B035-C349A076CE8E}"/>
               </a:ext>
             </a:extLst>
           </p:cNvPr>
@@ -6467,35 +6472,35 @@
           <p:cNvPr id="14" name="text-92">
             <a:extLst xmlns:a="http://schemas.openxmlformats.org/drawingml/2006/main">
               <a:ext uri="{FF2B5EF4-FFF2-40B4-BE49-F238E27FC236}">
-                <a16:creationId xmlns:a16="http://schemas.microsoft.com/office/drawing/2014/main" id="{035ADF0B-1EA4-4D97-BF8E-E64E747F635C}"/>
-              </a:ext>
-            </a:extLst>
-          </p:cNvPr>
-          <p:cNvSpPr>
-            <a:spLocks xmlns:a="http://schemas.openxmlformats.org/drawingml/2006/main" noGrp="1"/>
-          </p:cNvSpPr>
-          <p:nvPr/>
-        </p:nvSpPr>
-        <p:spPr>
-          <a:xfrm xmlns:a="http://schemas.openxmlformats.org/drawingml/2006/main">
-            <a:off x="400050" y="5810250"/>
-            <a:ext cx="10668000" cy="514350"/>
-          </a:xfrm>
-          <a:prstGeom xmlns:a="http://schemas.openxmlformats.org/drawingml/2006/main" prst="rect">
-            <a:avLst/>
-          </a:prstGeom>
-          <a:noFill xmlns:a="http://schemas.openxmlformats.org/drawingml/2006/main"/>
-          <a:ln xmlns:a="http://schemas.openxmlformats.org/drawingml/2006/main" w="0">
-            <a:noFill/>
-            <a:prstDash val="solid"/>
-          </a:ln>
-        </p:spPr>
-        <p:txBody>
-          <a:bodyPr xmlns:a="http://schemas.openxmlformats.org/drawingml/2006/main" anchor="t"/>
-          <a:lstStyle xmlns:a="http://schemas.openxmlformats.org/drawingml/2006/main"/>
-          <a:p xmlns:a="http://schemas.openxmlformats.org/drawingml/2006/main">
-            <a:pPr algn="l">
-              <a:defRPr sz="1200" b="1">
+                <a16:creationId xmlns:a16="http://schemas.microsoft.com/office/drawing/2014/main" id="{4712D08C-8188-44F1-B727-F8EE034E16EC}"/>
+              </a:ext>
+            </a:extLst>
+          </p:cNvPr>
+          <p:cNvSpPr>
+            <a:spLocks xmlns:a="http://schemas.openxmlformats.org/drawingml/2006/main" noGrp="1"/>
+          </p:cNvSpPr>
+          <p:nvPr/>
+        </p:nvSpPr>
+        <p:spPr>
+          <a:xfrm xmlns:a="http://schemas.openxmlformats.org/drawingml/2006/main">
+            <a:off x="400050" y="5715000"/>
+            <a:ext cx="10668000" cy="209550"/>
+          </a:xfrm>
+          <a:prstGeom xmlns:a="http://schemas.openxmlformats.org/drawingml/2006/main" prst="rect">
+            <a:avLst/>
+          </a:prstGeom>
+          <a:noFill xmlns:a="http://schemas.openxmlformats.org/drawingml/2006/main"/>
+          <a:ln xmlns:a="http://schemas.openxmlformats.org/drawingml/2006/main" w="0">
+            <a:noFill/>
+            <a:prstDash val="solid"/>
+          </a:ln>
+        </p:spPr>
+        <p:txBody>
+          <a:bodyPr xmlns:a="http://schemas.openxmlformats.org/drawingml/2006/main" anchor="t"/>
+          <a:lstStyle xmlns:a="http://schemas.openxmlformats.org/drawingml/2006/main"/>
+          <a:p xmlns:a="http://schemas.openxmlformats.org/drawingml/2006/main">
+            <a:pPr algn="l">
+              <a:defRPr sz="1050" b="1">
                 <a:solidFill>
                   <a:srgbClr val="111111"/>
                 </a:solidFill>
@@ -6505,7 +6510,7 @@
               </a:defRPr>
             </a:pPr>
             <a:r>
-              <a:rPr sz="1200" b="1">
+              <a:rPr sz="1050" b="1">
                 <a:solidFill>
                   <a:srgbClr val="111111"/>
                 </a:solidFill>
@@ -6514,6 +6519,174 @@
                 <a:cs typeface="Arial"/>
               </a:rPr>
               <a:t>EXE + source + docs + private GitHub + trilingual deck · EXE + kaynak + belgeler + özel GitHub + üç dilli sunum</a:t>
+            </a:r>
+          </a:p>
+        </p:txBody>
+      </p:sp>
+      <p:sp>
+        <p:nvSpPr>
+          <p:cNvPr id="15" name="text-93">
+            <a:extLst xmlns:a="http://schemas.openxmlformats.org/drawingml/2006/main">
+              <a:ext uri="{FF2B5EF4-FFF2-40B4-BE49-F238E27FC236}">
+                <a16:creationId xmlns:a16="http://schemas.microsoft.com/office/drawing/2014/main" id="{1153917D-7FBF-49B2-A6C8-774A2C08CF48}"/>
+              </a:ext>
+            </a:extLst>
+          </p:cNvPr>
+          <p:cNvSpPr>
+            <a:spLocks xmlns:a="http://schemas.openxmlformats.org/drawingml/2006/main" noGrp="1"/>
+          </p:cNvSpPr>
+          <p:nvPr/>
+        </p:nvSpPr>
+        <p:spPr>
+          <a:xfrm xmlns:a="http://schemas.openxmlformats.org/drawingml/2006/main">
+            <a:off x="400050" y="5962650"/>
+            <a:ext cx="10668000" cy="209550"/>
+          </a:xfrm>
+          <a:prstGeom xmlns:a="http://schemas.openxmlformats.org/drawingml/2006/main" prst="rect">
+            <a:avLst/>
+          </a:prstGeom>
+          <a:noFill xmlns:a="http://schemas.openxmlformats.org/drawingml/2006/main"/>
+          <a:ln xmlns:a="http://schemas.openxmlformats.org/drawingml/2006/main" w="0">
+            <a:noFill/>
+            <a:prstDash val="solid"/>
+          </a:ln>
+        </p:spPr>
+        <p:txBody>
+          <a:bodyPr xmlns:a="http://schemas.openxmlformats.org/drawingml/2006/main" anchor="t"/>
+          <a:lstStyle xmlns:a="http://schemas.openxmlformats.org/drawingml/2006/main"/>
+          <a:p xmlns:a="http://schemas.openxmlformats.org/drawingml/2006/main">
+            <a:pPr algn="l">
+              <a:defRPr sz="1050" b="1">
+                <a:solidFill>
+                  <a:srgbClr val="9A6500"/>
+                </a:solidFill>
+                <a:latin typeface="Arial"/>
+                <a:ea typeface="Arial"/>
+                <a:cs typeface="Arial"/>
+              </a:defRPr>
+            </a:pPr>
+            <a:r>
+              <a:rPr sz="1050" b="1">
+                <a:solidFill>
+                  <a:srgbClr val="9A6500"/>
+                </a:solidFill>
+                <a:latin typeface="Arial"/>
+                <a:ea typeface="Arial"/>
+                <a:cs typeface="Arial"/>
+              </a:rPr>
+              <a:t>Windows 10/11 (x64) + macOS (Apple Silicon) — İndirme: github.com/Azizsekerdil/GermanCourseAI/releases (v1.0.0) · (özel repo)</a:t>
+            </a:r>
+          </a:p>
+        </p:txBody>
+      </p:sp>
+      <p:sp>
+        <p:nvSpPr>
+          <p:cNvPr id="16" name="text-94">
+            <a:extLst xmlns:a="http://schemas.openxmlformats.org/drawingml/2006/main">
+              <a:ext uri="{FF2B5EF4-FFF2-40B4-BE49-F238E27FC236}">
+                <a16:creationId xmlns:a16="http://schemas.microsoft.com/office/drawing/2014/main" id="{C3B2AE6C-212B-4397-A727-EFBB23489BF7}"/>
+              </a:ext>
+            </a:extLst>
+          </p:cNvPr>
+          <p:cNvSpPr>
+            <a:spLocks xmlns:a="http://schemas.openxmlformats.org/drawingml/2006/main" noGrp="1"/>
+          </p:cNvSpPr>
+          <p:nvPr/>
+        </p:nvSpPr>
+        <p:spPr>
+          <a:xfrm xmlns:a="http://schemas.openxmlformats.org/drawingml/2006/main">
+            <a:off x="400050" y="6191250"/>
+            <a:ext cx="10668000" cy="190500"/>
+          </a:xfrm>
+          <a:prstGeom xmlns:a="http://schemas.openxmlformats.org/drawingml/2006/main" prst="rect">
+            <a:avLst/>
+          </a:prstGeom>
+          <a:noFill xmlns:a="http://schemas.openxmlformats.org/drawingml/2006/main"/>
+          <a:ln xmlns:a="http://schemas.openxmlformats.org/drawingml/2006/main" w="0">
+            <a:noFill/>
+            <a:prstDash val="solid"/>
+          </a:ln>
+        </p:spPr>
+        <p:txBody>
+          <a:bodyPr xmlns:a="http://schemas.openxmlformats.org/drawingml/2006/main" anchor="t"/>
+          <a:lstStyle xmlns:a="http://schemas.openxmlformats.org/drawingml/2006/main"/>
+          <a:p xmlns:a="http://schemas.openxmlformats.org/drawingml/2006/main">
+            <a:pPr algn="l">
+              <a:defRPr sz="975" b="0">
+                <a:solidFill>
+                  <a:srgbClr val="5D6470"/>
+                </a:solidFill>
+                <a:latin typeface="Arial"/>
+                <a:ea typeface="Arial"/>
+                <a:cs typeface="Arial"/>
+              </a:defRPr>
+            </a:pPr>
+            <a:r>
+              <a:rPr sz="975" b="0">
+                <a:solidFill>
+                  <a:srgbClr val="5D6470"/>
+                </a:solidFill>
+                <a:latin typeface="Arial"/>
+                <a:ea typeface="Arial"/>
+                <a:cs typeface="Arial"/>
+              </a:rPr>
+              <a:t>Windows 10/11 (x64) &amp; macOS (Apple Silicon) — Download: GitHub Releases (v1.0.0)</a:t>
+            </a:r>
+          </a:p>
+        </p:txBody>
+      </p:sp>
+      <p:sp>
+        <p:nvSpPr>
+          <p:cNvPr id="17" name="text-95">
+            <a:extLst xmlns:a="http://schemas.openxmlformats.org/drawingml/2006/main">
+              <a:ext uri="{FF2B5EF4-FFF2-40B4-BE49-F238E27FC236}">
+                <a16:creationId xmlns:a16="http://schemas.microsoft.com/office/drawing/2014/main" id="{9F84A400-C90D-47D7-8BDC-72084F38780A}"/>
+              </a:ext>
+            </a:extLst>
+          </p:cNvPr>
+          <p:cNvSpPr>
+            <a:spLocks xmlns:a="http://schemas.openxmlformats.org/drawingml/2006/main" noGrp="1"/>
+          </p:cNvSpPr>
+          <p:nvPr/>
+        </p:nvSpPr>
+        <p:spPr>
+          <a:xfrm xmlns:a="http://schemas.openxmlformats.org/drawingml/2006/main">
+            <a:off x="400050" y="6400800"/>
+            <a:ext cx="10668000" cy="190500"/>
+          </a:xfrm>
+          <a:prstGeom xmlns:a="http://schemas.openxmlformats.org/drawingml/2006/main" prst="rect">
+            <a:avLst/>
+          </a:prstGeom>
+          <a:noFill xmlns:a="http://schemas.openxmlformats.org/drawingml/2006/main"/>
+          <a:ln xmlns:a="http://schemas.openxmlformats.org/drawingml/2006/main" w="0">
+            <a:noFill/>
+            <a:prstDash val="solid"/>
+          </a:ln>
+        </p:spPr>
+        <p:txBody>
+          <a:bodyPr xmlns:a="http://schemas.openxmlformats.org/drawingml/2006/main" anchor="t"/>
+          <a:lstStyle xmlns:a="http://schemas.openxmlformats.org/drawingml/2006/main"/>
+          <a:p xmlns:a="http://schemas.openxmlformats.org/drawingml/2006/main">
+            <a:pPr algn="l">
+              <a:defRPr sz="900" b="0">
+                <a:solidFill>
+                  <a:srgbClr val="5D6470"/>
+                </a:solidFill>
+                <a:latin typeface="Arial"/>
+                <a:ea typeface="Arial"/>
+                <a:cs typeface="Arial"/>
+              </a:defRPr>
+            </a:pPr>
+            <a:r>
+              <a:rPr sz="900" b="0">
+                <a:solidFill>
+                  <a:srgbClr val="5D6470"/>
+                </a:solidFill>
+                <a:latin typeface="Arial"/>
+                <a:ea typeface="Arial"/>
+                <a:cs typeface="Arial"/>
+              </a:rPr>
+              <a:t>macOS paketi Apple Silicon (arm64) içindir ve notarize edilmemiştir; ilk açılışta sağ tık → Aç. / Not notarized; first launch: right-click → Open.</a:t>
             </a:r>
           </a:p>
         </p:txBody>
@@ -6521,7 +6694,7 @@
     </p:spTree>
     <p:extLst>
       <p:ext uri="{BB962C8B-B14F-4D97-AF65-F5344CB8AC3E}">
-        <p14:creationId xmlns:p14="http://schemas.microsoft.com/office/powerpoint/2010/main" val="1341667284"/>
+        <p14:creationId xmlns:p14="http://schemas.microsoft.com/office/powerpoint/2010/main" val="1056817073"/>
       </p:ext>
     </p:extLst>
   </p:cSld>

</xml_diff>

<commit_message>
Wörterbuch DE-EN: bidirectional German-English dictionary tab
- gca/dictionary.py: search engine merging built-in and user entries
  (automatic direction, plural/umlaut/ß-tolerant lookup, exact > prefix > substring)
- gca/dict_data.py: 1,260+ A1-B1 entries with article and plural
- gca/tabs/dictionary.py: TTS, ask AI, add to word bank, CSV/TSV import/export, history
- db: dict_entries table + DictRepo; i18n keys in TR/EN/DE
- 8 new tests (37 total), README TR/EN and presentation (18 areas) updated

Co-Authored-By: Claude Fable 5.1 <noreply@anthropic.com>
</commit_message>
<xml_diff>
--- a/docs/presentation/German-Course-AI-Trilingual.pptx
+++ b/docs/presentation/German-Course-AI-Trilingual.pptx
@@ -2,18 +2,18 @@
 <file path=ppt/presentation.xml><?xml version="1.0" encoding="utf-8"?>
 <p:presentation xmlns:p="http://schemas.openxmlformats.org/presentationml/2006/main">
   <p:sldMasterIdLst>
-    <p:sldMasterId xmlns:r="http://schemas.openxmlformats.org/officeDocument/2006/relationships" id="2147483648" r:id="R925416c520d144d7"/>
+    <p:sldMasterId xmlns:r="http://schemas.openxmlformats.org/officeDocument/2006/relationships" id="2147483648" r:id="Rbd43e295a9674cb8"/>
   </p:sldMasterIdLst>
   <p:notesMasterIdLst>
-    <p:notesMasterId xmlns:r="http://schemas.openxmlformats.org/officeDocument/2006/relationships" r:id="R944f634b67534c4b"/>
+    <p:notesMasterId xmlns:r="http://schemas.openxmlformats.org/officeDocument/2006/relationships" r:id="Rd8bc9dd3271643e2"/>
   </p:notesMasterIdLst>
   <p:sldIdLst>
-    <p:sldId xmlns:r="http://schemas.openxmlformats.org/officeDocument/2006/relationships" id="256" r:id="R6c47d783ae2549ee"/>
-    <p:sldId xmlns:r="http://schemas.openxmlformats.org/officeDocument/2006/relationships" id="257" r:id="R1ff21c9a833d428b"/>
-    <p:sldId xmlns:r="http://schemas.openxmlformats.org/officeDocument/2006/relationships" id="258" r:id="Rea0b44f9643f49fe"/>
-    <p:sldId xmlns:r="http://schemas.openxmlformats.org/officeDocument/2006/relationships" id="259" r:id="R25588092b3cc4d92"/>
-    <p:sldId xmlns:r="http://schemas.openxmlformats.org/officeDocument/2006/relationships" id="260" r:id="Rb6535701c7294d2e"/>
-    <p:sldId xmlns:r="http://schemas.openxmlformats.org/officeDocument/2006/relationships" id="261" r:id="R350b568ab17c4af3"/>
+    <p:sldId xmlns:r="http://schemas.openxmlformats.org/officeDocument/2006/relationships" id="256" r:id="R094b538f0e0a4cb6"/>
+    <p:sldId xmlns:r="http://schemas.openxmlformats.org/officeDocument/2006/relationships" id="257" r:id="R02f827ab557249fa"/>
+    <p:sldId xmlns:r="http://schemas.openxmlformats.org/officeDocument/2006/relationships" id="258" r:id="R91fdfa594b25460e"/>
+    <p:sldId xmlns:r="http://schemas.openxmlformats.org/officeDocument/2006/relationships" id="259" r:id="R439e9f595e1f426a"/>
+    <p:sldId xmlns:r="http://schemas.openxmlformats.org/officeDocument/2006/relationships" id="260" r:id="R23d5cc8c62ab4666"/>
+    <p:sldId xmlns:r="http://schemas.openxmlformats.org/officeDocument/2006/relationships" id="261" r:id="R1b58d015e9274aca"/>
   </p:sldIdLst>
   <p:sldSz cx="12192000" cy="6858000"/>
   <p:notesSz cx="6858000" cy="9144000"/>
@@ -1010,7 +1010,7 @@
   </p:cSld>
   <p:clrMap bg1="lt1" tx1="dk1" bg2="lt2" tx2="dk2" accent1="accent1" accent2="accent2" accent3="accent3" accent4="accent4" accent5="accent5" accent6="accent6" hlink="hlink" folHlink="folHlink"/>
   <p:sldLayoutIdLst>
-    <p:sldLayoutId xmlns:r="http://schemas.openxmlformats.org/officeDocument/2006/relationships" id="2147483649" r:id="R7874d5378f794973"/>
+    <p:sldLayoutId xmlns:r="http://schemas.openxmlformats.org/officeDocument/2006/relationships" id="2147483649" r:id="R58a114006b0a47c3"/>
   </p:sldLayoutIdLst>
   <p:txStyles>
     <p:titleStyle>
@@ -1561,7 +1561,7 @@
           <p:cNvPr id="13" name="box-1">
             <a:extLst xmlns:a="http://schemas.openxmlformats.org/drawingml/2006/main">
               <a:ext uri="{FF2B5EF4-FFF2-40B4-BE49-F238E27FC236}">
-                <a16:creationId xmlns:a16="http://schemas.microsoft.com/office/drawing/2014/main" id="{CCA520DB-A332-41F7-B660-CFF11DEDF158}"/>
+                <a16:creationId xmlns:a16="http://schemas.microsoft.com/office/drawing/2014/main" id="{BD025786-6C25-47CC-A5F0-C8E285B14334}"/>
               </a:ext>
             </a:extLst>
           </p:cNvPr>
@@ -1594,7 +1594,7 @@
           <p:cNvPr id="2" name="text-2">
             <a:extLst xmlns:a="http://schemas.openxmlformats.org/drawingml/2006/main">
               <a:ext uri="{FF2B5EF4-FFF2-40B4-BE49-F238E27FC236}">
-                <a16:creationId xmlns:a16="http://schemas.microsoft.com/office/drawing/2014/main" id="{61267023-FF07-4D30-B45A-971BFFA33FFF}"/>
+                <a16:creationId xmlns:a16="http://schemas.microsoft.com/office/drawing/2014/main" id="{1F52B061-E2DA-44FB-99DC-0535120771CC}"/>
               </a:ext>
             </a:extLst>
           </p:cNvPr>
@@ -1650,7 +1650,7 @@
           <p:cNvPr id="3" name="text-3">
             <a:extLst xmlns:a="http://schemas.openxmlformats.org/drawingml/2006/main">
               <a:ext uri="{FF2B5EF4-FFF2-40B4-BE49-F238E27FC236}">
-                <a16:creationId xmlns:a16="http://schemas.microsoft.com/office/drawing/2014/main" id="{5F5650EC-2956-424B-98BE-C4FDEBEB4BF6}"/>
+                <a16:creationId xmlns:a16="http://schemas.microsoft.com/office/drawing/2014/main" id="{E03511C0-E60F-4506-AC66-63E8E3E426A6}"/>
               </a:ext>
             </a:extLst>
           </p:cNvPr>
@@ -1706,7 +1706,7 @@
           <p:cNvPr id="4" name="text-4">
             <a:extLst xmlns:a="http://schemas.openxmlformats.org/drawingml/2006/main">
               <a:ext uri="{FF2B5EF4-FFF2-40B4-BE49-F238E27FC236}">
-                <a16:creationId xmlns:a16="http://schemas.microsoft.com/office/drawing/2014/main" id="{042E64A7-98FE-49AE-9A1B-16A457068F73}"/>
+                <a16:creationId xmlns:a16="http://schemas.microsoft.com/office/drawing/2014/main" id="{476A2E35-FF67-44ED-AEF4-78EEA11C3AC2}"/>
               </a:ext>
             </a:extLst>
           </p:cNvPr>
@@ -1762,7 +1762,7 @@
           <p:cNvPr id="5" name="text-5">
             <a:extLst xmlns:a="http://schemas.openxmlformats.org/drawingml/2006/main">
               <a:ext uri="{FF2B5EF4-FFF2-40B4-BE49-F238E27FC236}">
-                <a16:creationId xmlns:a16="http://schemas.microsoft.com/office/drawing/2014/main" id="{586042F5-9CD0-4F69-85E0-DF4959003A4C}"/>
+                <a16:creationId xmlns:a16="http://schemas.microsoft.com/office/drawing/2014/main" id="{4DA3AA05-FBBE-4EFA-8F43-723A69B41226}"/>
               </a:ext>
             </a:extLst>
           </p:cNvPr>
@@ -1818,7 +1818,7 @@
           <p:cNvPr id="6" name="text-6">
             <a:extLst xmlns:a="http://schemas.openxmlformats.org/drawingml/2006/main">
               <a:ext uri="{FF2B5EF4-FFF2-40B4-BE49-F238E27FC236}">
-                <a16:creationId xmlns:a16="http://schemas.microsoft.com/office/drawing/2014/main" id="{8C84A7AA-014B-42A5-B22A-1C726A25EA4B}"/>
+                <a16:creationId xmlns:a16="http://schemas.microsoft.com/office/drawing/2014/main" id="{3CC5B6E1-1E9B-447C-A270-D11598FDD8CF}"/>
               </a:ext>
             </a:extLst>
           </p:cNvPr>
@@ -1874,7 +1874,7 @@
           <p:cNvPr id="7" name="text-7">
             <a:extLst xmlns:a="http://schemas.openxmlformats.org/drawingml/2006/main">
               <a:ext uri="{FF2B5EF4-FFF2-40B4-BE49-F238E27FC236}">
-                <a16:creationId xmlns:a16="http://schemas.microsoft.com/office/drawing/2014/main" id="{48E8C130-6CBB-45CB-A523-736875386D9F}"/>
+                <a16:creationId xmlns:a16="http://schemas.microsoft.com/office/drawing/2014/main" id="{CBCE2E5B-9DA5-4FD2-99F1-C10A4147C454}"/>
               </a:ext>
             </a:extLst>
           </p:cNvPr>
@@ -1930,7 +1930,7 @@
           <p:cNvPr id="8" name="text-8">
             <a:extLst xmlns:a="http://schemas.openxmlformats.org/drawingml/2006/main">
               <a:ext uri="{FF2B5EF4-FFF2-40B4-BE49-F238E27FC236}">
-                <a16:creationId xmlns:a16="http://schemas.microsoft.com/office/drawing/2014/main" id="{F2015877-5EB1-4595-8497-8687C7D635D5}"/>
+                <a16:creationId xmlns:a16="http://schemas.microsoft.com/office/drawing/2014/main" id="{E72332B6-54AB-4FD6-A089-9BC32E9975B5}"/>
               </a:ext>
             </a:extLst>
           </p:cNvPr>
@@ -1986,7 +1986,7 @@
           <p:cNvPr id="9" name="text-9">
             <a:extLst xmlns:a="http://schemas.openxmlformats.org/drawingml/2006/main">
               <a:ext uri="{FF2B5EF4-FFF2-40B4-BE49-F238E27FC236}">
-                <a16:creationId xmlns:a16="http://schemas.microsoft.com/office/drawing/2014/main" id="{5D61D76D-4253-434E-89EE-5C3ADCFD35F8}"/>
+                <a16:creationId xmlns:a16="http://schemas.microsoft.com/office/drawing/2014/main" id="{10AD1910-823E-4EA0-87F7-D1F92F5C86F0}"/>
               </a:ext>
             </a:extLst>
           </p:cNvPr>
@@ -2042,7 +2042,7 @@
           <p:cNvPr id="10" name="box-10">
             <a:extLst xmlns:a="http://schemas.openxmlformats.org/drawingml/2006/main">
               <a:ext uri="{FF2B5EF4-FFF2-40B4-BE49-F238E27FC236}">
-                <a16:creationId xmlns:a16="http://schemas.microsoft.com/office/drawing/2014/main" id="{11615049-7E32-496D-87D3-B30F9F4094A0}"/>
+                <a16:creationId xmlns:a16="http://schemas.microsoft.com/office/drawing/2014/main" id="{C61DB1B5-436B-41F9-9871-100BE711F74C}"/>
               </a:ext>
             </a:extLst>
           </p:cNvPr>
@@ -2079,7 +2079,7 @@
           <p:nvPr/>
         </p:nvPicPr>
         <p:blipFill>
-          <a:blip xmlns:r="http://schemas.openxmlformats.org/officeDocument/2006/relationships" xmlns:a="http://schemas.openxmlformats.org/drawingml/2006/main" r:embed="R93e3aa85f4464eb3"/>
+          <a:blip xmlns:r="http://schemas.openxmlformats.org/officeDocument/2006/relationships" xmlns:a="http://schemas.openxmlformats.org/drawingml/2006/main" r:embed="R3d35d683b58a4c02"/>
           <a:stretch xmlns:a="http://schemas.openxmlformats.org/drawingml/2006/main"/>
         </p:blipFill>
         <p:spPr>
@@ -2097,7 +2097,7 @@
           <p:cNvPr id="12" name="text-11">
             <a:extLst xmlns:a="http://schemas.openxmlformats.org/drawingml/2006/main">
               <a:ext uri="{FF2B5EF4-FFF2-40B4-BE49-F238E27FC236}">
-                <a16:creationId xmlns:a16="http://schemas.microsoft.com/office/drawing/2014/main" id="{282CCCFB-42C9-4AD4-93AD-0D5A8DC0D5FB}"/>
+                <a16:creationId xmlns:a16="http://schemas.microsoft.com/office/drawing/2014/main" id="{66E07B7C-169D-4C0A-A15F-EEEA1BD6BA71}"/>
               </a:ext>
             </a:extLst>
           </p:cNvPr>
@@ -2151,7 +2151,7 @@
     </p:spTree>
     <p:extLst>
       <p:ext uri="{BB962C8B-B14F-4D97-AF65-F5344CB8AC3E}">
-        <p14:creationId xmlns:p14="http://schemas.microsoft.com/office/powerpoint/2010/main" val="541527519"/>
+        <p14:creationId xmlns:p14="http://schemas.microsoft.com/office/powerpoint/2010/main" val="30447237"/>
       </p:ext>
     </p:extLst>
   </p:cSld>
@@ -2182,7 +2182,7 @@
           <p:cNvPr id="14" name="box-12">
             <a:extLst xmlns:a="http://schemas.openxmlformats.org/drawingml/2006/main">
               <a:ext uri="{FF2B5EF4-FFF2-40B4-BE49-F238E27FC236}">
-                <a16:creationId xmlns:a16="http://schemas.microsoft.com/office/drawing/2014/main" id="{AFEF2905-D59A-4C8E-9642-78744B99A926}"/>
+                <a16:creationId xmlns:a16="http://schemas.microsoft.com/office/drawing/2014/main" id="{5FEAAD70-FE91-412E-8250-EA29A9F0317D}"/>
               </a:ext>
             </a:extLst>
           </p:cNvPr>
@@ -2215,7 +2215,7 @@
           <p:cNvPr id="2" name="text-13">
             <a:extLst xmlns:a="http://schemas.openxmlformats.org/drawingml/2006/main">
               <a:ext uri="{FF2B5EF4-FFF2-40B4-BE49-F238E27FC236}">
-                <a16:creationId xmlns:a16="http://schemas.microsoft.com/office/drawing/2014/main" id="{E068ACAA-2AC7-4966-AB0B-AC7EF187E773}"/>
+                <a16:creationId xmlns:a16="http://schemas.microsoft.com/office/drawing/2014/main" id="{255F1637-D4E0-4E03-B7C1-AC5AB66B50B7}"/>
               </a:ext>
             </a:extLst>
           </p:cNvPr>
@@ -2271,7 +2271,7 @@
           <p:cNvPr id="3" name="text-14">
             <a:extLst xmlns:a="http://schemas.openxmlformats.org/drawingml/2006/main">
               <a:ext uri="{FF2B5EF4-FFF2-40B4-BE49-F238E27FC236}">
-                <a16:creationId xmlns:a16="http://schemas.microsoft.com/office/drawing/2014/main" id="{3A11917C-1F2E-46A8-9F3B-AF5196D36FC6}"/>
+                <a16:creationId xmlns:a16="http://schemas.microsoft.com/office/drawing/2014/main" id="{F6D83F94-B08A-4AAC-80DB-839A2B1DA196}"/>
               </a:ext>
             </a:extLst>
           </p:cNvPr>
@@ -2327,7 +2327,7 @@
           <p:cNvPr id="4" name="text-15">
             <a:extLst xmlns:a="http://schemas.openxmlformats.org/drawingml/2006/main">
               <a:ext uri="{FF2B5EF4-FFF2-40B4-BE49-F238E27FC236}">
-                <a16:creationId xmlns:a16="http://schemas.microsoft.com/office/drawing/2014/main" id="{82C2B217-191A-472A-95F1-3E59E762CEAA}"/>
+                <a16:creationId xmlns:a16="http://schemas.microsoft.com/office/drawing/2014/main" id="{77648BCF-3DD1-4310-909F-8F5554DE3282}"/>
               </a:ext>
             </a:extLst>
           </p:cNvPr>
@@ -2383,7 +2383,7 @@
           <p:cNvPr id="5" name="text-16">
             <a:extLst xmlns:a="http://schemas.openxmlformats.org/drawingml/2006/main">
               <a:ext uri="{FF2B5EF4-FFF2-40B4-BE49-F238E27FC236}">
-                <a16:creationId xmlns:a16="http://schemas.microsoft.com/office/drawing/2014/main" id="{40D8EADA-8A26-4008-AD0A-7CF9BBDF468A}"/>
+                <a16:creationId xmlns:a16="http://schemas.microsoft.com/office/drawing/2014/main" id="{83A79BEF-C93E-4BC0-8D40-F3D41E321B88}"/>
               </a:ext>
             </a:extLst>
           </p:cNvPr>
@@ -2439,7 +2439,7 @@
           <p:cNvPr id="6" name="text-17">
             <a:extLst xmlns:a="http://schemas.openxmlformats.org/drawingml/2006/main">
               <a:ext uri="{FF2B5EF4-FFF2-40B4-BE49-F238E27FC236}">
-                <a16:creationId xmlns:a16="http://schemas.microsoft.com/office/drawing/2014/main" id="{8E7E55F7-5932-4DD8-B536-EC1D65EF3104}"/>
+                <a16:creationId xmlns:a16="http://schemas.microsoft.com/office/drawing/2014/main" id="{11AF26BA-C96F-4335-8D3E-5F3402D80638}"/>
               </a:ext>
             </a:extLst>
           </p:cNvPr>
@@ -2495,7 +2495,7 @@
           <p:cNvPr id="7" name="box-18">
             <a:extLst xmlns:a="http://schemas.openxmlformats.org/drawingml/2006/main">
               <a:ext uri="{FF2B5EF4-FFF2-40B4-BE49-F238E27FC236}">
-                <a16:creationId xmlns:a16="http://schemas.microsoft.com/office/drawing/2014/main" id="{B2CFFD31-0883-412C-B5AC-9909650F42B7}"/>
+                <a16:creationId xmlns:a16="http://schemas.microsoft.com/office/drawing/2014/main" id="{04067BA7-DAF1-4359-88C5-48D4E5C62001}"/>
               </a:ext>
             </a:extLst>
           </p:cNvPr>
@@ -2528,7 +2528,7 @@
           <p:cNvPr id="8" name="text-19">
             <a:extLst xmlns:a="http://schemas.openxmlformats.org/drawingml/2006/main">
               <a:ext uri="{FF2B5EF4-FFF2-40B4-BE49-F238E27FC236}">
-                <a16:creationId xmlns:a16="http://schemas.microsoft.com/office/drawing/2014/main" id="{07F811D6-4351-4FF5-80D0-6FE0FF10C337}"/>
+                <a16:creationId xmlns:a16="http://schemas.microsoft.com/office/drawing/2014/main" id="{C8FCCA59-4EAF-4CBD-A7BA-931FF8EBA3E5}"/>
               </a:ext>
             </a:extLst>
           </p:cNvPr>
@@ -2574,7 +2574,7 @@
                 <a:ea typeface="Arial"/>
                 <a:cs typeface="Arial"/>
               </a:rPr>
-              <a:t>17 Bereiche verbinden Wiederholung, Wortschatz, Prüfung, Grammatik und Praxis in einem ruhigen Windows-Arbeitsraum.</a:t>
+              <a:t>18 Bereiche verbinden Wiederholung, Wortschatz, ein zweisprachiges Wörterbuch DE-EN, Prüfung, Grammatik und Praxis in einem ruhigen Windows-Arbeitsraum.</a:t>
             </a:r>
           </a:p>
         </p:txBody>
@@ -2584,7 +2584,7 @@
           <p:cNvPr id="9" name="text-20">
             <a:extLst xmlns:a="http://schemas.openxmlformats.org/drawingml/2006/main">
               <a:ext uri="{FF2B5EF4-FFF2-40B4-BE49-F238E27FC236}">
-                <a16:creationId xmlns:a16="http://schemas.microsoft.com/office/drawing/2014/main" id="{9D730B93-8FEC-4B9F-AB35-4E89C8198E2A}"/>
+                <a16:creationId xmlns:a16="http://schemas.microsoft.com/office/drawing/2014/main" id="{F50F33E0-329E-4298-AA50-3CE468BD7C15}"/>
               </a:ext>
             </a:extLst>
           </p:cNvPr>
@@ -2640,7 +2640,7 @@
           <p:cNvPr id="10" name="text-21">
             <a:extLst xmlns:a="http://schemas.openxmlformats.org/drawingml/2006/main">
               <a:ext uri="{FF2B5EF4-FFF2-40B4-BE49-F238E27FC236}">
-                <a16:creationId xmlns:a16="http://schemas.microsoft.com/office/drawing/2014/main" id="{8CEB4B68-030C-44F6-91DA-0F0A0822BD0D}"/>
+                <a16:creationId xmlns:a16="http://schemas.microsoft.com/office/drawing/2014/main" id="{46324EEC-29AF-488A-AE28-7DDA587D8680}"/>
               </a:ext>
             </a:extLst>
           </p:cNvPr>
@@ -2696,7 +2696,7 @@
           <p:cNvPr id="11" name="box-22">
             <a:extLst xmlns:a="http://schemas.openxmlformats.org/drawingml/2006/main">
               <a:ext uri="{FF2B5EF4-FFF2-40B4-BE49-F238E27FC236}">
-                <a16:creationId xmlns:a16="http://schemas.microsoft.com/office/drawing/2014/main" id="{8F44A2E7-9BD6-4079-937A-CFA7ACF00E92}"/>
+                <a16:creationId xmlns:a16="http://schemas.microsoft.com/office/drawing/2014/main" id="{CECD7995-7AE5-4E2F-A66A-EFD490C0CE25}"/>
               </a:ext>
             </a:extLst>
           </p:cNvPr>
@@ -2733,7 +2733,7 @@
           <p:nvPr/>
         </p:nvPicPr>
         <p:blipFill>
-          <a:blip xmlns:r="http://schemas.openxmlformats.org/officeDocument/2006/relationships" xmlns:a="http://schemas.openxmlformats.org/drawingml/2006/main" r:embed="R44bebcc1930c4710"/>
+          <a:blip xmlns:r="http://schemas.openxmlformats.org/officeDocument/2006/relationships" xmlns:a="http://schemas.openxmlformats.org/drawingml/2006/main" r:embed="Reb50836f06df44e9"/>
           <a:stretch xmlns:a="http://schemas.openxmlformats.org/drawingml/2006/main"/>
         </p:blipFill>
         <p:spPr>
@@ -2751,7 +2751,7 @@
           <p:cNvPr id="13" name="text-23">
             <a:extLst xmlns:a="http://schemas.openxmlformats.org/drawingml/2006/main">
               <a:ext uri="{FF2B5EF4-FFF2-40B4-BE49-F238E27FC236}">
-                <a16:creationId xmlns:a16="http://schemas.microsoft.com/office/drawing/2014/main" id="{7E92A051-BBE5-4809-9D28-826C05728046}"/>
+                <a16:creationId xmlns:a16="http://schemas.microsoft.com/office/drawing/2014/main" id="{4BC43FC3-81E4-4A37-8CD1-28178D87A4CF}"/>
               </a:ext>
             </a:extLst>
           </p:cNvPr>
@@ -2805,7 +2805,7 @@
     </p:spTree>
     <p:extLst>
       <p:ext uri="{BB962C8B-B14F-4D97-AF65-F5344CB8AC3E}">
-        <p14:creationId xmlns:p14="http://schemas.microsoft.com/office/powerpoint/2010/main" val="2022796525"/>
+        <p14:creationId xmlns:p14="http://schemas.microsoft.com/office/powerpoint/2010/main" val="600625755"/>
       </p:ext>
     </p:extLst>
   </p:cSld>
@@ -2836,7 +2836,7 @@
           <p:cNvPr id="19" name="box-24">
             <a:extLst xmlns:a="http://schemas.openxmlformats.org/drawingml/2006/main">
               <a:ext uri="{FF2B5EF4-FFF2-40B4-BE49-F238E27FC236}">
-                <a16:creationId xmlns:a16="http://schemas.microsoft.com/office/drawing/2014/main" id="{794C1A4F-076D-4BE6-81E4-8BA499BBAE67}"/>
+                <a16:creationId xmlns:a16="http://schemas.microsoft.com/office/drawing/2014/main" id="{745715F3-DE9A-48C2-B66C-96A476A54715}"/>
               </a:ext>
             </a:extLst>
           </p:cNvPr>
@@ -2869,7 +2869,7 @@
           <p:cNvPr id="2" name="text-25">
             <a:extLst xmlns:a="http://schemas.openxmlformats.org/drawingml/2006/main">
               <a:ext uri="{FF2B5EF4-FFF2-40B4-BE49-F238E27FC236}">
-                <a16:creationId xmlns:a16="http://schemas.microsoft.com/office/drawing/2014/main" id="{5B442726-6168-4B1F-A5C8-009AA4F375E6}"/>
+                <a16:creationId xmlns:a16="http://schemas.microsoft.com/office/drawing/2014/main" id="{19A687DA-52B2-43E1-8A5E-05A06428D305}"/>
               </a:ext>
             </a:extLst>
           </p:cNvPr>
@@ -2925,7 +2925,7 @@
           <p:cNvPr id="3" name="text-26">
             <a:extLst xmlns:a="http://schemas.openxmlformats.org/drawingml/2006/main">
               <a:ext uri="{FF2B5EF4-FFF2-40B4-BE49-F238E27FC236}">
-                <a16:creationId xmlns:a16="http://schemas.microsoft.com/office/drawing/2014/main" id="{49FDF277-6683-4DA2-B0B5-AB7B708EB39A}"/>
+                <a16:creationId xmlns:a16="http://schemas.microsoft.com/office/drawing/2014/main" id="{0983BFA4-D022-4E81-8A99-0B51E0778FDF}"/>
               </a:ext>
             </a:extLst>
           </p:cNvPr>
@@ -2981,7 +2981,7 @@
           <p:cNvPr id="4" name="text-27">
             <a:extLst xmlns:a="http://schemas.openxmlformats.org/drawingml/2006/main">
               <a:ext uri="{FF2B5EF4-FFF2-40B4-BE49-F238E27FC236}">
-                <a16:creationId xmlns:a16="http://schemas.microsoft.com/office/drawing/2014/main" id="{2D867B5F-D3E3-4936-980D-876BFB52AE82}"/>
+                <a16:creationId xmlns:a16="http://schemas.microsoft.com/office/drawing/2014/main" id="{1CACEE5B-FA8F-480E-9331-BC77FF8A0713}"/>
               </a:ext>
             </a:extLst>
           </p:cNvPr>
@@ -3037,7 +3037,7 @@
           <p:cNvPr id="5" name="text-28">
             <a:extLst xmlns:a="http://schemas.openxmlformats.org/drawingml/2006/main">
               <a:ext uri="{FF2B5EF4-FFF2-40B4-BE49-F238E27FC236}">
-                <a16:creationId xmlns:a16="http://schemas.microsoft.com/office/drawing/2014/main" id="{C83BDE62-72E9-4CEE-818F-AB747E5EA0C5}"/>
+                <a16:creationId xmlns:a16="http://schemas.microsoft.com/office/drawing/2014/main" id="{143349AE-F1CF-45AF-A549-F068E33FB3DA}"/>
               </a:ext>
             </a:extLst>
           </p:cNvPr>
@@ -3093,7 +3093,7 @@
           <p:cNvPr id="6" name="text-29">
             <a:extLst xmlns:a="http://schemas.openxmlformats.org/drawingml/2006/main">
               <a:ext uri="{FF2B5EF4-FFF2-40B4-BE49-F238E27FC236}">
-                <a16:creationId xmlns:a16="http://schemas.microsoft.com/office/drawing/2014/main" id="{8CFA9AFF-E82F-4DD3-919D-D5CD2DDAE6A8}"/>
+                <a16:creationId xmlns:a16="http://schemas.microsoft.com/office/drawing/2014/main" id="{86AA954F-4D28-4170-825F-2F0134BEE582}"/>
               </a:ext>
             </a:extLst>
           </p:cNvPr>
@@ -3149,7 +3149,7 @@
           <p:cNvPr id="7" name="box-30">
             <a:extLst xmlns:a="http://schemas.openxmlformats.org/drawingml/2006/main">
               <a:ext uri="{FF2B5EF4-FFF2-40B4-BE49-F238E27FC236}">
-                <a16:creationId xmlns:a16="http://schemas.microsoft.com/office/drawing/2014/main" id="{80698B3A-CC96-4BA6-A786-5114C9042D35}"/>
+                <a16:creationId xmlns:a16="http://schemas.microsoft.com/office/drawing/2014/main" id="{3A98FDE9-4E43-490F-ABE7-58292EBA83B6}"/>
               </a:ext>
             </a:extLst>
           </p:cNvPr>
@@ -3182,7 +3182,7 @@
           <p:cNvPr id="8" name="text-31">
             <a:extLst xmlns:a="http://schemas.openxmlformats.org/drawingml/2006/main">
               <a:ext uri="{FF2B5EF4-FFF2-40B4-BE49-F238E27FC236}">
-                <a16:creationId xmlns:a16="http://schemas.microsoft.com/office/drawing/2014/main" id="{A46491DA-C0FD-4E3B-B343-D06A0B896BE2}"/>
+                <a16:creationId xmlns:a16="http://schemas.microsoft.com/office/drawing/2014/main" id="{F5FAB578-268D-4DD7-AAE6-576CE3CF9EED}"/>
               </a:ext>
             </a:extLst>
           </p:cNvPr>
@@ -3238,7 +3238,7 @@
           <p:cNvPr id="9" name="text-32">
             <a:extLst xmlns:a="http://schemas.openxmlformats.org/drawingml/2006/main">
               <a:ext uri="{FF2B5EF4-FFF2-40B4-BE49-F238E27FC236}">
-                <a16:creationId xmlns:a16="http://schemas.microsoft.com/office/drawing/2014/main" id="{82E94A7E-D0E1-42F3-8EA7-9173E17E74E9}"/>
+                <a16:creationId xmlns:a16="http://schemas.microsoft.com/office/drawing/2014/main" id="{313CE2A0-013F-4D4A-B87B-8D397DE93C91}"/>
               </a:ext>
             </a:extLst>
           </p:cNvPr>
@@ -3294,7 +3294,7 @@
           <p:cNvPr id="10" name="text-33">
             <a:extLst xmlns:a="http://schemas.openxmlformats.org/drawingml/2006/main">
               <a:ext uri="{FF2B5EF4-FFF2-40B4-BE49-F238E27FC236}">
-                <a16:creationId xmlns:a16="http://schemas.microsoft.com/office/drawing/2014/main" id="{18AD1510-EF5B-4248-B561-A34A8D57249D}"/>
+                <a16:creationId xmlns:a16="http://schemas.microsoft.com/office/drawing/2014/main" id="{56DB5CB0-E68A-4AA1-B2BF-D6430C303489}"/>
               </a:ext>
             </a:extLst>
           </p:cNvPr>
@@ -3350,7 +3350,7 @@
           <p:cNvPr id="11" name="box-34">
             <a:extLst xmlns:a="http://schemas.openxmlformats.org/drawingml/2006/main">
               <a:ext uri="{FF2B5EF4-FFF2-40B4-BE49-F238E27FC236}">
-                <a16:creationId xmlns:a16="http://schemas.microsoft.com/office/drawing/2014/main" id="{869F3B1B-6B84-4A71-938C-547B5B365D26}"/>
+                <a16:creationId xmlns:a16="http://schemas.microsoft.com/office/drawing/2014/main" id="{975AABAC-176A-4C8A-B012-5768692C523A}"/>
               </a:ext>
             </a:extLst>
           </p:cNvPr>
@@ -3383,7 +3383,7 @@
           <p:cNvPr id="12" name="text-35">
             <a:extLst xmlns:a="http://schemas.openxmlformats.org/drawingml/2006/main">
               <a:ext uri="{FF2B5EF4-FFF2-40B4-BE49-F238E27FC236}">
-                <a16:creationId xmlns:a16="http://schemas.microsoft.com/office/drawing/2014/main" id="{BCD1F13A-BA37-4E2B-8549-383615414E30}"/>
+                <a16:creationId xmlns:a16="http://schemas.microsoft.com/office/drawing/2014/main" id="{D4CD2609-E7FC-4364-B621-E2FCF038A09D}"/>
               </a:ext>
             </a:extLst>
           </p:cNvPr>
@@ -3439,7 +3439,7 @@
           <p:cNvPr id="13" name="text-36">
             <a:extLst xmlns:a="http://schemas.openxmlformats.org/drawingml/2006/main">
               <a:ext uri="{FF2B5EF4-FFF2-40B4-BE49-F238E27FC236}">
-                <a16:creationId xmlns:a16="http://schemas.microsoft.com/office/drawing/2014/main" id="{DE09831D-6F19-4048-96BF-0EA3D445F070}"/>
+                <a16:creationId xmlns:a16="http://schemas.microsoft.com/office/drawing/2014/main" id="{7E775B3E-6795-4995-9D1E-868F919E7371}"/>
               </a:ext>
             </a:extLst>
           </p:cNvPr>
@@ -3485,7 +3485,7 @@
                 <a:ea typeface="Arial"/>
                 <a:cs typeface="Arial"/>
               </a:rPr>
-              <a:t>160 A1 entries, strict spelling, exams, favorites and mistakes share one SQLite record.</a:t>
+              <a:t>160 A1 entries, a 1,260-entry DE-EN dictionary, strict spelling, exams, favorites and mistakes share one SQLite record.</a:t>
             </a:r>
           </a:p>
         </p:txBody>
@@ -3495,7 +3495,7 @@
           <p:cNvPr id="14" name="text-37">
             <a:extLst xmlns:a="http://schemas.openxmlformats.org/drawingml/2006/main">
               <a:ext uri="{FF2B5EF4-FFF2-40B4-BE49-F238E27FC236}">
-                <a16:creationId xmlns:a16="http://schemas.microsoft.com/office/drawing/2014/main" id="{58518209-6109-4951-82D6-E69CA41B8243}"/>
+                <a16:creationId xmlns:a16="http://schemas.microsoft.com/office/drawing/2014/main" id="{2206685E-001E-4D2B-9A10-2C2BCFB15CEE}"/>
               </a:ext>
             </a:extLst>
           </p:cNvPr>
@@ -3551,7 +3551,7 @@
           <p:cNvPr id="15" name="box-38">
             <a:extLst xmlns:a="http://schemas.openxmlformats.org/drawingml/2006/main">
               <a:ext uri="{FF2B5EF4-FFF2-40B4-BE49-F238E27FC236}">
-                <a16:creationId xmlns:a16="http://schemas.microsoft.com/office/drawing/2014/main" id="{0DE4E7F9-6407-4AC8-AC6C-85CEC5FB865F}"/>
+                <a16:creationId xmlns:a16="http://schemas.microsoft.com/office/drawing/2014/main" id="{BA97ECE1-9815-4389-8BAE-623E2904208B}"/>
               </a:ext>
             </a:extLst>
           </p:cNvPr>
@@ -3584,7 +3584,7 @@
           <p:cNvPr id="16" name="text-39">
             <a:extLst xmlns:a="http://schemas.openxmlformats.org/drawingml/2006/main">
               <a:ext uri="{FF2B5EF4-FFF2-40B4-BE49-F238E27FC236}">
-                <a16:creationId xmlns:a16="http://schemas.microsoft.com/office/drawing/2014/main" id="{94346061-2019-44CA-88E3-8D60A0266F29}"/>
+                <a16:creationId xmlns:a16="http://schemas.microsoft.com/office/drawing/2014/main" id="{B9C9039C-5D48-49E2-9366-E7A57552DD0B}"/>
               </a:ext>
             </a:extLst>
           </p:cNvPr>
@@ -3640,7 +3640,7 @@
           <p:cNvPr id="17" name="text-40">
             <a:extLst xmlns:a="http://schemas.openxmlformats.org/drawingml/2006/main">
               <a:ext uri="{FF2B5EF4-FFF2-40B4-BE49-F238E27FC236}">
-                <a16:creationId xmlns:a16="http://schemas.microsoft.com/office/drawing/2014/main" id="{BD7A2075-A05F-478E-A810-0356E7C78E10}"/>
+                <a16:creationId xmlns:a16="http://schemas.microsoft.com/office/drawing/2014/main" id="{DE079705-456B-4EFD-A68E-F6871E46C95A}"/>
               </a:ext>
             </a:extLst>
           </p:cNvPr>
@@ -3696,7 +3696,7 @@
           <p:cNvPr id="18" name="text-41">
             <a:extLst xmlns:a="http://schemas.openxmlformats.org/drawingml/2006/main">
               <a:ext uri="{FF2B5EF4-FFF2-40B4-BE49-F238E27FC236}">
-                <a16:creationId xmlns:a16="http://schemas.microsoft.com/office/drawing/2014/main" id="{2E32DF77-2D8F-45EB-B24F-BD78DEED0678}"/>
+                <a16:creationId xmlns:a16="http://schemas.microsoft.com/office/drawing/2014/main" id="{6F2FE22C-5D60-4635-BAAE-B1C378AED884}"/>
               </a:ext>
             </a:extLst>
           </p:cNvPr>
@@ -3750,7 +3750,7 @@
     </p:spTree>
     <p:extLst>
       <p:ext uri="{BB962C8B-B14F-4D97-AF65-F5344CB8AC3E}">
-        <p14:creationId xmlns:p14="http://schemas.microsoft.com/office/powerpoint/2010/main" val="1134542902"/>
+        <p14:creationId xmlns:p14="http://schemas.microsoft.com/office/powerpoint/2010/main" val="1436768494"/>
       </p:ext>
     </p:extLst>
   </p:cSld>
@@ -3781,7 +3781,7 @@
           <p:cNvPr id="18" name="box-42">
             <a:extLst xmlns:a="http://schemas.openxmlformats.org/drawingml/2006/main">
               <a:ext uri="{FF2B5EF4-FFF2-40B4-BE49-F238E27FC236}">
-                <a16:creationId xmlns:a16="http://schemas.microsoft.com/office/drawing/2014/main" id="{67F0E3EF-91C9-476C-B381-3137217139E1}"/>
+                <a16:creationId xmlns:a16="http://schemas.microsoft.com/office/drawing/2014/main" id="{9A49CECE-053E-413F-BE68-EB98269DC560}"/>
               </a:ext>
             </a:extLst>
           </p:cNvPr>
@@ -3814,7 +3814,7 @@
           <p:cNvPr id="2" name="text-43">
             <a:extLst xmlns:a="http://schemas.openxmlformats.org/drawingml/2006/main">
               <a:ext uri="{FF2B5EF4-FFF2-40B4-BE49-F238E27FC236}">
-                <a16:creationId xmlns:a16="http://schemas.microsoft.com/office/drawing/2014/main" id="{6FB4FDCF-2193-4093-BDD3-756379C376BC}"/>
+                <a16:creationId xmlns:a16="http://schemas.microsoft.com/office/drawing/2014/main" id="{F01ECE95-D0FC-4043-B0A2-8100311E9321}"/>
               </a:ext>
             </a:extLst>
           </p:cNvPr>
@@ -3870,7 +3870,7 @@
           <p:cNvPr id="3" name="text-44">
             <a:extLst xmlns:a="http://schemas.openxmlformats.org/drawingml/2006/main">
               <a:ext uri="{FF2B5EF4-FFF2-40B4-BE49-F238E27FC236}">
-                <a16:creationId xmlns:a16="http://schemas.microsoft.com/office/drawing/2014/main" id="{368E7495-94F6-49FD-96E3-427E82810D89}"/>
+                <a16:creationId xmlns:a16="http://schemas.microsoft.com/office/drawing/2014/main" id="{36890FB4-048D-46EE-9EB7-1A2F60D044F4}"/>
               </a:ext>
             </a:extLst>
           </p:cNvPr>
@@ -3926,7 +3926,7 @@
           <p:cNvPr id="4" name="text-45">
             <a:extLst xmlns:a="http://schemas.openxmlformats.org/drawingml/2006/main">
               <a:ext uri="{FF2B5EF4-FFF2-40B4-BE49-F238E27FC236}">
-                <a16:creationId xmlns:a16="http://schemas.microsoft.com/office/drawing/2014/main" id="{8BF8A537-760A-438F-8121-04C216AB84CB}"/>
+                <a16:creationId xmlns:a16="http://schemas.microsoft.com/office/drawing/2014/main" id="{9250F9EF-5094-4C4D-8BA8-1FB5A03D3C99}"/>
               </a:ext>
             </a:extLst>
           </p:cNvPr>
@@ -3982,7 +3982,7 @@
           <p:cNvPr id="5" name="text-46">
             <a:extLst xmlns:a="http://schemas.openxmlformats.org/drawingml/2006/main">
               <a:ext uri="{FF2B5EF4-FFF2-40B4-BE49-F238E27FC236}">
-                <a16:creationId xmlns:a16="http://schemas.microsoft.com/office/drawing/2014/main" id="{7AFDD9D2-C5B1-457C-86DE-2DCDF5587F61}"/>
+                <a16:creationId xmlns:a16="http://schemas.microsoft.com/office/drawing/2014/main" id="{F094DCFC-6B32-4FED-86F9-F40C8B5C5873}"/>
               </a:ext>
             </a:extLst>
           </p:cNvPr>
@@ -4038,7 +4038,7 @@
           <p:cNvPr id="6" name="box-47">
             <a:extLst xmlns:a="http://schemas.openxmlformats.org/drawingml/2006/main">
               <a:ext uri="{FF2B5EF4-FFF2-40B4-BE49-F238E27FC236}">
-                <a16:creationId xmlns:a16="http://schemas.microsoft.com/office/drawing/2014/main" id="{DA4ACD0C-DF6C-44F1-976C-C9BB2CE4339A}"/>
+                <a16:creationId xmlns:a16="http://schemas.microsoft.com/office/drawing/2014/main" id="{990C520E-607D-4773-A1CC-469184FF66BE}"/>
               </a:ext>
             </a:extLst>
           </p:cNvPr>
@@ -4071,7 +4071,7 @@
           <p:cNvPr id="7" name="text-48">
             <a:extLst xmlns:a="http://schemas.openxmlformats.org/drawingml/2006/main">
               <a:ext uri="{FF2B5EF4-FFF2-40B4-BE49-F238E27FC236}">
-                <a16:creationId xmlns:a16="http://schemas.microsoft.com/office/drawing/2014/main" id="{1139617D-2B9B-4015-B912-DB6C8E880E9F}"/>
+                <a16:creationId xmlns:a16="http://schemas.microsoft.com/office/drawing/2014/main" id="{B4D9FC9E-4437-4BB5-B530-0CE4E1F82D51}"/>
               </a:ext>
             </a:extLst>
           </p:cNvPr>
@@ -4127,7 +4127,7 @@
           <p:cNvPr id="8" name="text-49">
             <a:extLst xmlns:a="http://schemas.openxmlformats.org/drawingml/2006/main">
               <a:ext uri="{FF2B5EF4-FFF2-40B4-BE49-F238E27FC236}">
-                <a16:creationId xmlns:a16="http://schemas.microsoft.com/office/drawing/2014/main" id="{B792D042-789E-48F8-A6F9-C394C3C41D06}"/>
+                <a16:creationId xmlns:a16="http://schemas.microsoft.com/office/drawing/2014/main" id="{E0EC76BB-899B-401A-97A3-B8E149D343B3}"/>
               </a:ext>
             </a:extLst>
           </p:cNvPr>
@@ -4183,7 +4183,7 @@
           <p:cNvPr id="9" name="box-50">
             <a:extLst xmlns:a="http://schemas.openxmlformats.org/drawingml/2006/main">
               <a:ext uri="{FF2B5EF4-FFF2-40B4-BE49-F238E27FC236}">
-                <a16:creationId xmlns:a16="http://schemas.microsoft.com/office/drawing/2014/main" id="{27B1A7F3-AE4B-4B1B-A203-0FC4D146ABFE}"/>
+                <a16:creationId xmlns:a16="http://schemas.microsoft.com/office/drawing/2014/main" id="{8839ADEE-2B21-491E-8619-5BF633260228}"/>
               </a:ext>
             </a:extLst>
           </p:cNvPr>
@@ -4216,7 +4216,7 @@
           <p:cNvPr id="10" name="text-51">
             <a:extLst xmlns:a="http://schemas.openxmlformats.org/drawingml/2006/main">
               <a:ext uri="{FF2B5EF4-FFF2-40B4-BE49-F238E27FC236}">
-                <a16:creationId xmlns:a16="http://schemas.microsoft.com/office/drawing/2014/main" id="{2926012E-BE38-4530-A396-2F5D2A42B3EB}"/>
+                <a16:creationId xmlns:a16="http://schemas.microsoft.com/office/drawing/2014/main" id="{0A86C5E1-60B3-428C-8D03-31F298A28FAC}"/>
               </a:ext>
             </a:extLst>
           </p:cNvPr>
@@ -4272,7 +4272,7 @@
           <p:cNvPr id="11" name="text-52">
             <a:extLst xmlns:a="http://schemas.openxmlformats.org/drawingml/2006/main">
               <a:ext uri="{FF2B5EF4-FFF2-40B4-BE49-F238E27FC236}">
-                <a16:creationId xmlns:a16="http://schemas.microsoft.com/office/drawing/2014/main" id="{A74348C3-3CC1-4910-8789-5A8DC359E6D6}"/>
+                <a16:creationId xmlns:a16="http://schemas.microsoft.com/office/drawing/2014/main" id="{2317AE37-C2FE-45C1-93B0-58D662D94F72}"/>
               </a:ext>
             </a:extLst>
           </p:cNvPr>
@@ -4328,7 +4328,7 @@
           <p:cNvPr id="12" name="box-53">
             <a:extLst xmlns:a="http://schemas.openxmlformats.org/drawingml/2006/main">
               <a:ext uri="{FF2B5EF4-FFF2-40B4-BE49-F238E27FC236}">
-                <a16:creationId xmlns:a16="http://schemas.microsoft.com/office/drawing/2014/main" id="{EF42DFD7-6833-4A54-A9D4-AD081BC9FCFD}"/>
+                <a16:creationId xmlns:a16="http://schemas.microsoft.com/office/drawing/2014/main" id="{E27B6F67-FF6C-4135-A2C9-19A2E98A07D3}"/>
               </a:ext>
             </a:extLst>
           </p:cNvPr>
@@ -4361,7 +4361,7 @@
           <p:cNvPr id="13" name="text-54">
             <a:extLst xmlns:a="http://schemas.openxmlformats.org/drawingml/2006/main">
               <a:ext uri="{FF2B5EF4-FFF2-40B4-BE49-F238E27FC236}">
-                <a16:creationId xmlns:a16="http://schemas.microsoft.com/office/drawing/2014/main" id="{8525FDE6-EB1D-453D-9896-CA66C88604A1}"/>
+                <a16:creationId xmlns:a16="http://schemas.microsoft.com/office/drawing/2014/main" id="{4433BAE4-6AAC-4398-B4A8-2EC983A585CA}"/>
               </a:ext>
             </a:extLst>
           </p:cNvPr>
@@ -4417,7 +4417,7 @@
           <p:cNvPr id="14" name="text-55">
             <a:extLst xmlns:a="http://schemas.openxmlformats.org/drawingml/2006/main">
               <a:ext uri="{FF2B5EF4-FFF2-40B4-BE49-F238E27FC236}">
-                <a16:creationId xmlns:a16="http://schemas.microsoft.com/office/drawing/2014/main" id="{75802C17-A084-4E44-B950-88D0732340D6}"/>
+                <a16:creationId xmlns:a16="http://schemas.microsoft.com/office/drawing/2014/main" id="{B2EA36EB-7FC3-4824-84AC-D319FFC41AF6}"/>
               </a:ext>
             </a:extLst>
           </p:cNvPr>
@@ -4473,7 +4473,7 @@
           <p:cNvPr id="15" name="box-56">
             <a:extLst xmlns:a="http://schemas.openxmlformats.org/drawingml/2006/main">
               <a:ext uri="{FF2B5EF4-FFF2-40B4-BE49-F238E27FC236}">
-                <a16:creationId xmlns:a16="http://schemas.microsoft.com/office/drawing/2014/main" id="{A4999BE6-9176-4A24-81D7-ECA4E970ECD8}"/>
+                <a16:creationId xmlns:a16="http://schemas.microsoft.com/office/drawing/2014/main" id="{11207B2D-848D-4A11-80AC-1EBE7A537478}"/>
               </a:ext>
             </a:extLst>
           </p:cNvPr>
@@ -4506,7 +4506,7 @@
           <p:cNvPr id="16" name="text-57">
             <a:extLst xmlns:a="http://schemas.openxmlformats.org/drawingml/2006/main">
               <a:ext uri="{FF2B5EF4-FFF2-40B4-BE49-F238E27FC236}">
-                <a16:creationId xmlns:a16="http://schemas.microsoft.com/office/drawing/2014/main" id="{52A3737A-1EA2-46A1-969A-702905503905}"/>
+                <a16:creationId xmlns:a16="http://schemas.microsoft.com/office/drawing/2014/main" id="{BC366D09-5D23-4DBC-8ACD-F8C05C308303}"/>
               </a:ext>
             </a:extLst>
           </p:cNvPr>
@@ -4552,7 +4552,7 @@
                 <a:ea typeface="Arial"/>
                 <a:cs typeface="Arial"/>
               </a:rPr>
-              <a:t>Ich heiße Alex.</a:t>
+              <a:t>Häuser → das Haus</a:t>
             </a:r>
           </a:p>
         </p:txBody>
@@ -4562,7 +4562,7 @@
           <p:cNvPr id="17" name="text-58">
             <a:extLst xmlns:a="http://schemas.openxmlformats.org/drawingml/2006/main">
               <a:ext uri="{FF2B5EF4-FFF2-40B4-BE49-F238E27FC236}">
-                <a16:creationId xmlns:a16="http://schemas.microsoft.com/office/drawing/2014/main" id="{604865D1-C0D9-41B4-A656-487064A1035A}"/>
+                <a16:creationId xmlns:a16="http://schemas.microsoft.com/office/drawing/2014/main" id="{42F29645-C2BE-4BD4-867C-69F7ABC6888B}"/>
               </a:ext>
             </a:extLst>
           </p:cNvPr>
@@ -4608,7 +4608,7 @@
                 <a:ea typeface="Arial"/>
                 <a:cs typeface="Arial"/>
               </a:rPr>
-              <a:t>Yazım ve ses eşleşir · spelling meets sound · Schrift trifft Laut</a:t>
+              <a:t>Sözlük çoğuldan tekili bulur · dictionary resolves plurals · Wörterbuch findet den Singular</a:t>
             </a:r>
           </a:p>
         </p:txBody>
@@ -4616,7 +4616,7 @@
     </p:spTree>
     <p:extLst>
       <p:ext uri="{BB962C8B-B14F-4D97-AF65-F5344CB8AC3E}">
-        <p14:creationId xmlns:p14="http://schemas.microsoft.com/office/powerpoint/2010/main" val="876660766"/>
+        <p14:creationId xmlns:p14="http://schemas.microsoft.com/office/powerpoint/2010/main" val="1753609021"/>
       </p:ext>
     </p:extLst>
   </p:cSld>
@@ -4647,7 +4647,7 @@
           <p:cNvPr id="21" name="box-59">
             <a:extLst xmlns:a="http://schemas.openxmlformats.org/drawingml/2006/main">
               <a:ext uri="{FF2B5EF4-FFF2-40B4-BE49-F238E27FC236}">
-                <a16:creationId xmlns:a16="http://schemas.microsoft.com/office/drawing/2014/main" id="{FB473E37-7B85-4869-B0AF-A8E7AD8F4AC3}"/>
+                <a16:creationId xmlns:a16="http://schemas.microsoft.com/office/drawing/2014/main" id="{711CA2BA-6826-4594-8293-E92E72FE380E}"/>
               </a:ext>
             </a:extLst>
           </p:cNvPr>
@@ -4680,7 +4680,7 @@
           <p:cNvPr id="2" name="text-60">
             <a:extLst xmlns:a="http://schemas.openxmlformats.org/drawingml/2006/main">
               <a:ext uri="{FF2B5EF4-FFF2-40B4-BE49-F238E27FC236}">
-                <a16:creationId xmlns:a16="http://schemas.microsoft.com/office/drawing/2014/main" id="{223E0C47-A24D-4117-90B9-FB0DBA8CE697}"/>
+                <a16:creationId xmlns:a16="http://schemas.microsoft.com/office/drawing/2014/main" id="{A29DC29D-33AF-4D8A-B4AC-696A2765F002}"/>
               </a:ext>
             </a:extLst>
           </p:cNvPr>
@@ -4736,7 +4736,7 @@
           <p:cNvPr id="3" name="text-61">
             <a:extLst xmlns:a="http://schemas.openxmlformats.org/drawingml/2006/main">
               <a:ext uri="{FF2B5EF4-FFF2-40B4-BE49-F238E27FC236}">
-                <a16:creationId xmlns:a16="http://schemas.microsoft.com/office/drawing/2014/main" id="{A8144FDD-C565-47CD-84A5-CC8899056F7E}"/>
+                <a16:creationId xmlns:a16="http://schemas.microsoft.com/office/drawing/2014/main" id="{A75D78A3-9D18-4CC5-8E99-25A7C77B6B0C}"/>
               </a:ext>
             </a:extLst>
           </p:cNvPr>
@@ -4792,7 +4792,7 @@
           <p:cNvPr id="4" name="text-62">
             <a:extLst xmlns:a="http://schemas.openxmlformats.org/drawingml/2006/main">
               <a:ext uri="{FF2B5EF4-FFF2-40B4-BE49-F238E27FC236}">
-                <a16:creationId xmlns:a16="http://schemas.microsoft.com/office/drawing/2014/main" id="{14AB353F-4279-4C0E-A7A1-6D26AA6B5C57}"/>
+                <a16:creationId xmlns:a16="http://schemas.microsoft.com/office/drawing/2014/main" id="{62082AC5-78A8-49C3-99BE-D91ECAABF410}"/>
               </a:ext>
             </a:extLst>
           </p:cNvPr>
@@ -4848,7 +4848,7 @@
           <p:cNvPr id="5" name="text-63">
             <a:extLst xmlns:a="http://schemas.openxmlformats.org/drawingml/2006/main">
               <a:ext uri="{FF2B5EF4-FFF2-40B4-BE49-F238E27FC236}">
-                <a16:creationId xmlns:a16="http://schemas.microsoft.com/office/drawing/2014/main" id="{D878E27B-5862-4659-A742-4917FF7E75B4}"/>
+                <a16:creationId xmlns:a16="http://schemas.microsoft.com/office/drawing/2014/main" id="{D998DB1F-68F7-460E-96D0-93B08A1CF49A}"/>
               </a:ext>
             </a:extLst>
           </p:cNvPr>
@@ -4904,7 +4904,7 @@
           <p:cNvPr id="6" name="box-64">
             <a:extLst xmlns:a="http://schemas.openxmlformats.org/drawingml/2006/main">
               <a:ext uri="{FF2B5EF4-FFF2-40B4-BE49-F238E27FC236}">
-                <a16:creationId xmlns:a16="http://schemas.microsoft.com/office/drawing/2014/main" id="{A7B7C423-B128-4B70-B1B3-3BD6B2FB60F9}"/>
+                <a16:creationId xmlns:a16="http://schemas.microsoft.com/office/drawing/2014/main" id="{E79DB1BB-8361-44F5-827F-43E67A2E292F}"/>
               </a:ext>
             </a:extLst>
           </p:cNvPr>
@@ -4937,7 +4937,7 @@
           <p:cNvPr id="7" name="dot-65">
             <a:extLst xmlns:a="http://schemas.openxmlformats.org/drawingml/2006/main">
               <a:ext uri="{FF2B5EF4-FFF2-40B4-BE49-F238E27FC236}">
-                <a16:creationId xmlns:a16="http://schemas.microsoft.com/office/drawing/2014/main" id="{F517A83B-C1E7-4668-8199-B82C431AF16E}"/>
+                <a16:creationId xmlns:a16="http://schemas.microsoft.com/office/drawing/2014/main" id="{4473D131-EE77-48ED-8C2F-A1B139BDB775}"/>
               </a:ext>
             </a:extLst>
           </p:cNvPr>
@@ -4968,7 +4968,7 @@
           <p:cNvPr id="8" name="text-66">
             <a:extLst xmlns:a="http://schemas.openxmlformats.org/drawingml/2006/main">
               <a:ext uri="{FF2B5EF4-FFF2-40B4-BE49-F238E27FC236}">
-                <a16:creationId xmlns:a16="http://schemas.microsoft.com/office/drawing/2014/main" id="{46E7FC02-7F62-4A18-AD02-07B874F84597}"/>
+                <a16:creationId xmlns:a16="http://schemas.microsoft.com/office/drawing/2014/main" id="{EC02141A-05E4-46DF-9C19-DD47195D3F8B}"/>
               </a:ext>
             </a:extLst>
           </p:cNvPr>
@@ -5024,7 +5024,7 @@
           <p:cNvPr id="9" name="text-67">
             <a:extLst xmlns:a="http://schemas.openxmlformats.org/drawingml/2006/main">
               <a:ext uri="{FF2B5EF4-FFF2-40B4-BE49-F238E27FC236}">
-                <a16:creationId xmlns:a16="http://schemas.microsoft.com/office/drawing/2014/main" id="{DE3B1ED9-BB49-474A-8C6A-DBCFFF19D0F0}"/>
+                <a16:creationId xmlns:a16="http://schemas.microsoft.com/office/drawing/2014/main" id="{D771F8D1-2DAE-49C3-AFAB-0F1755EAAA5B}"/>
               </a:ext>
             </a:extLst>
           </p:cNvPr>
@@ -5080,7 +5080,7 @@
           <p:cNvPr id="10" name="text-68">
             <a:extLst xmlns:a="http://schemas.openxmlformats.org/drawingml/2006/main">
               <a:ext uri="{FF2B5EF4-FFF2-40B4-BE49-F238E27FC236}">
-                <a16:creationId xmlns:a16="http://schemas.microsoft.com/office/drawing/2014/main" id="{F00CC188-D5AC-4DEC-A471-54A91E82C336}"/>
+                <a16:creationId xmlns:a16="http://schemas.microsoft.com/office/drawing/2014/main" id="{265CEFF7-5241-4732-BE56-6DD2BA590B02}"/>
               </a:ext>
             </a:extLst>
           </p:cNvPr>
@@ -5136,7 +5136,7 @@
           <p:cNvPr id="11" name="dot-69">
             <a:extLst xmlns:a="http://schemas.openxmlformats.org/drawingml/2006/main">
               <a:ext uri="{FF2B5EF4-FFF2-40B4-BE49-F238E27FC236}">
-                <a16:creationId xmlns:a16="http://schemas.microsoft.com/office/drawing/2014/main" id="{9E1C1005-C29B-481C-A93B-2EF692AA2CE4}"/>
+                <a16:creationId xmlns:a16="http://schemas.microsoft.com/office/drawing/2014/main" id="{7475A7BF-4FEE-48CF-9464-5DD610514D9C}"/>
               </a:ext>
             </a:extLst>
           </p:cNvPr>
@@ -5167,7 +5167,7 @@
           <p:cNvPr id="12" name="text-70">
             <a:extLst xmlns:a="http://schemas.openxmlformats.org/drawingml/2006/main">
               <a:ext uri="{FF2B5EF4-FFF2-40B4-BE49-F238E27FC236}">
-                <a16:creationId xmlns:a16="http://schemas.microsoft.com/office/drawing/2014/main" id="{5AF22C96-9D87-4684-BB0A-875A0059229B}"/>
+                <a16:creationId xmlns:a16="http://schemas.microsoft.com/office/drawing/2014/main" id="{5530697F-73F3-419E-ABF9-7F46EE5A0160}"/>
               </a:ext>
             </a:extLst>
           </p:cNvPr>
@@ -5223,7 +5223,7 @@
           <p:cNvPr id="13" name="text-71">
             <a:extLst xmlns:a="http://schemas.openxmlformats.org/drawingml/2006/main">
               <a:ext uri="{FF2B5EF4-FFF2-40B4-BE49-F238E27FC236}">
-                <a16:creationId xmlns:a16="http://schemas.microsoft.com/office/drawing/2014/main" id="{F7D1BB8C-0D7F-489E-ACA1-957BDEB2DD2D}"/>
+                <a16:creationId xmlns:a16="http://schemas.microsoft.com/office/drawing/2014/main" id="{B8A3846B-24E5-44A6-9E55-861F8EF8FE7A}"/>
               </a:ext>
             </a:extLst>
           </p:cNvPr>
@@ -5279,7 +5279,7 @@
           <p:cNvPr id="14" name="text-72">
             <a:extLst xmlns:a="http://schemas.openxmlformats.org/drawingml/2006/main">
               <a:ext uri="{FF2B5EF4-FFF2-40B4-BE49-F238E27FC236}">
-                <a16:creationId xmlns:a16="http://schemas.microsoft.com/office/drawing/2014/main" id="{3CD65CA8-7104-4B14-BAE4-78B910D85FAC}"/>
+                <a16:creationId xmlns:a16="http://schemas.microsoft.com/office/drawing/2014/main" id="{5B8748CB-BBFF-4B6B-8FDE-E2A69B33E304}"/>
               </a:ext>
             </a:extLst>
           </p:cNvPr>
@@ -5335,7 +5335,7 @@
           <p:cNvPr id="15" name="dot-73">
             <a:extLst xmlns:a="http://schemas.openxmlformats.org/drawingml/2006/main">
               <a:ext uri="{FF2B5EF4-FFF2-40B4-BE49-F238E27FC236}">
-                <a16:creationId xmlns:a16="http://schemas.microsoft.com/office/drawing/2014/main" id="{4CEA908C-C365-441C-BC65-D8FEB3997ED3}"/>
+                <a16:creationId xmlns:a16="http://schemas.microsoft.com/office/drawing/2014/main" id="{02DBDE38-F6F4-4C55-92F7-8EB4590168DA}"/>
               </a:ext>
             </a:extLst>
           </p:cNvPr>
@@ -5366,7 +5366,7 @@
           <p:cNvPr id="16" name="text-74">
             <a:extLst xmlns:a="http://schemas.openxmlformats.org/drawingml/2006/main">
               <a:ext uri="{FF2B5EF4-FFF2-40B4-BE49-F238E27FC236}">
-                <a16:creationId xmlns:a16="http://schemas.microsoft.com/office/drawing/2014/main" id="{76173E55-15FD-4468-9B12-E131A3A4FCC5}"/>
+                <a16:creationId xmlns:a16="http://schemas.microsoft.com/office/drawing/2014/main" id="{4EAC44E4-47B2-4530-A587-BC94888AA2E8}"/>
               </a:ext>
             </a:extLst>
           </p:cNvPr>
@@ -5422,7 +5422,7 @@
           <p:cNvPr id="17" name="text-75">
             <a:extLst xmlns:a="http://schemas.openxmlformats.org/drawingml/2006/main">
               <a:ext uri="{FF2B5EF4-FFF2-40B4-BE49-F238E27FC236}">
-                <a16:creationId xmlns:a16="http://schemas.microsoft.com/office/drawing/2014/main" id="{9B8C1274-37A2-4AA0-80CA-7D87EF825D71}"/>
+                <a16:creationId xmlns:a16="http://schemas.microsoft.com/office/drawing/2014/main" id="{DE5B697C-942B-4A8A-B12B-B767E6541043}"/>
               </a:ext>
             </a:extLst>
           </p:cNvPr>
@@ -5478,7 +5478,7 @@
           <p:cNvPr id="18" name="text-76">
             <a:extLst xmlns:a="http://schemas.openxmlformats.org/drawingml/2006/main">
               <a:ext uri="{FF2B5EF4-FFF2-40B4-BE49-F238E27FC236}">
-                <a16:creationId xmlns:a16="http://schemas.microsoft.com/office/drawing/2014/main" id="{08535279-17D2-43FC-AF99-84D77E38C720}"/>
+                <a16:creationId xmlns:a16="http://schemas.microsoft.com/office/drawing/2014/main" id="{230EAA8E-ED5B-4163-98E4-27244338A127}"/>
               </a:ext>
             </a:extLst>
           </p:cNvPr>
@@ -5534,7 +5534,7 @@
           <p:cNvPr id="19" name="box-77">
             <a:extLst xmlns:a="http://schemas.openxmlformats.org/drawingml/2006/main">
               <a:ext uri="{FF2B5EF4-FFF2-40B4-BE49-F238E27FC236}">
-                <a16:creationId xmlns:a16="http://schemas.microsoft.com/office/drawing/2014/main" id="{45051014-7F20-4542-B8BD-1F642F59DD7C}"/>
+                <a16:creationId xmlns:a16="http://schemas.microsoft.com/office/drawing/2014/main" id="{475294D5-DAF7-4510-B28D-C2E688217CA9}"/>
               </a:ext>
             </a:extLst>
           </p:cNvPr>
@@ -5567,7 +5567,7 @@
           <p:cNvPr id="20" name="text-78">
             <a:extLst xmlns:a="http://schemas.openxmlformats.org/drawingml/2006/main">
               <a:ext uri="{FF2B5EF4-FFF2-40B4-BE49-F238E27FC236}">
-                <a16:creationId xmlns:a16="http://schemas.microsoft.com/office/drawing/2014/main" id="{225F76A9-BA29-453D-8954-CBDCD6629610}"/>
+                <a16:creationId xmlns:a16="http://schemas.microsoft.com/office/drawing/2014/main" id="{E7E13599-4CD1-46A2-8CD3-3275896FF247}"/>
               </a:ext>
             </a:extLst>
           </p:cNvPr>
@@ -5621,7 +5621,7 @@
     </p:spTree>
     <p:extLst>
       <p:ext uri="{BB962C8B-B14F-4D97-AF65-F5344CB8AC3E}">
-        <p14:creationId xmlns:p14="http://schemas.microsoft.com/office/powerpoint/2010/main" val="1384107082"/>
+        <p14:creationId xmlns:p14="http://schemas.microsoft.com/office/powerpoint/2010/main" val="394195540"/>
       </p:ext>
     </p:extLst>
   </p:cSld>
@@ -5652,7 +5652,7 @@
           <p:cNvPr id="18" name="box-79">
             <a:extLst xmlns:a="http://schemas.openxmlformats.org/drawingml/2006/main">
               <a:ext uri="{FF2B5EF4-FFF2-40B4-BE49-F238E27FC236}">
-                <a16:creationId xmlns:a16="http://schemas.microsoft.com/office/drawing/2014/main" id="{ED610AAA-7DEF-4AB3-9F83-5E66D11239E1}"/>
+                <a16:creationId xmlns:a16="http://schemas.microsoft.com/office/drawing/2014/main" id="{455A9B25-E43B-41DA-8A53-98CFA3C491A7}"/>
               </a:ext>
             </a:extLst>
           </p:cNvPr>
@@ -5685,7 +5685,7 @@
           <p:cNvPr id="2" name="text-80">
             <a:extLst xmlns:a="http://schemas.openxmlformats.org/drawingml/2006/main">
               <a:ext uri="{FF2B5EF4-FFF2-40B4-BE49-F238E27FC236}">
-                <a16:creationId xmlns:a16="http://schemas.microsoft.com/office/drawing/2014/main" id="{655FFB04-5677-4211-B205-184E7D4C1C95}"/>
+                <a16:creationId xmlns:a16="http://schemas.microsoft.com/office/drawing/2014/main" id="{A99BF37C-D547-41FD-88F4-7F425D5D9613}"/>
               </a:ext>
             </a:extLst>
           </p:cNvPr>
@@ -5741,7 +5741,7 @@
           <p:cNvPr id="3" name="text-81">
             <a:extLst xmlns:a="http://schemas.openxmlformats.org/drawingml/2006/main">
               <a:ext uri="{FF2B5EF4-FFF2-40B4-BE49-F238E27FC236}">
-                <a16:creationId xmlns:a16="http://schemas.microsoft.com/office/drawing/2014/main" id="{856CFA1C-567D-4035-96C5-5CD47C3FDE31}"/>
+                <a16:creationId xmlns:a16="http://schemas.microsoft.com/office/drawing/2014/main" id="{756ECBBD-B037-45E3-91E6-2290849923C9}"/>
               </a:ext>
             </a:extLst>
           </p:cNvPr>
@@ -5797,7 +5797,7 @@
           <p:cNvPr id="4" name="text-82">
             <a:extLst xmlns:a="http://schemas.openxmlformats.org/drawingml/2006/main">
               <a:ext uri="{FF2B5EF4-FFF2-40B4-BE49-F238E27FC236}">
-                <a16:creationId xmlns:a16="http://schemas.microsoft.com/office/drawing/2014/main" id="{D31A45CD-77EB-428A-A2D3-1A0860BC8CC5}"/>
+                <a16:creationId xmlns:a16="http://schemas.microsoft.com/office/drawing/2014/main" id="{0212001F-FEE5-429B-987D-9F1FE28DF7F7}"/>
               </a:ext>
             </a:extLst>
           </p:cNvPr>
@@ -5853,7 +5853,7 @@
           <p:cNvPr id="5" name="text-83">
             <a:extLst xmlns:a="http://schemas.openxmlformats.org/drawingml/2006/main">
               <a:ext uri="{FF2B5EF4-FFF2-40B4-BE49-F238E27FC236}">
-                <a16:creationId xmlns:a16="http://schemas.microsoft.com/office/drawing/2014/main" id="{D2565E15-6485-4EE3-ADE9-5D9D78EF59E6}"/>
+                <a16:creationId xmlns:a16="http://schemas.microsoft.com/office/drawing/2014/main" id="{9AECB58E-53C3-424C-ADD2-88FD1B464136}"/>
               </a:ext>
             </a:extLst>
           </p:cNvPr>
@@ -5909,7 +5909,7 @@
           <p:cNvPr id="6" name="text-84">
             <a:extLst xmlns:a="http://schemas.openxmlformats.org/drawingml/2006/main">
               <a:ext uri="{FF2B5EF4-FFF2-40B4-BE49-F238E27FC236}">
-                <a16:creationId xmlns:a16="http://schemas.microsoft.com/office/drawing/2014/main" id="{AB1F2B34-7745-4BB7-B399-715B1C9D2FD1}"/>
+                <a16:creationId xmlns:a16="http://schemas.microsoft.com/office/drawing/2014/main" id="{D1D4913D-8319-4B93-9EFA-ABFAAE10A3FA}"/>
               </a:ext>
             </a:extLst>
           </p:cNvPr>
@@ -5965,7 +5965,7 @@
           <p:cNvPr id="7" name="text-85">
             <a:extLst xmlns:a="http://schemas.openxmlformats.org/drawingml/2006/main">
               <a:ext uri="{FF2B5EF4-FFF2-40B4-BE49-F238E27FC236}">
-                <a16:creationId xmlns:a16="http://schemas.microsoft.com/office/drawing/2014/main" id="{7C6852D6-BE50-4CCA-9307-771B952D9869}"/>
+                <a16:creationId xmlns:a16="http://schemas.microsoft.com/office/drawing/2014/main" id="{3BCF9A6E-EEA4-4B48-A4B3-925BD1CDB2AC}"/>
               </a:ext>
             </a:extLst>
           </p:cNvPr>
@@ -6021,7 +6021,7 @@
           <p:cNvPr id="8" name="text-86">
             <a:extLst xmlns:a="http://schemas.openxmlformats.org/drawingml/2006/main">
               <a:ext uri="{FF2B5EF4-FFF2-40B4-BE49-F238E27FC236}">
-                <a16:creationId xmlns:a16="http://schemas.microsoft.com/office/drawing/2014/main" id="{23686F73-6D27-4AE3-8D7A-D99FF3B6AD65}"/>
+                <a16:creationId xmlns:a16="http://schemas.microsoft.com/office/drawing/2014/main" id="{F1389FF6-726D-4F04-A211-575F59EDA0DD}"/>
               </a:ext>
             </a:extLst>
           </p:cNvPr>
@@ -6067,7 +6067,7 @@
                 <a:ea typeface="Arial"/>
                 <a:cs typeface="Arial"/>
               </a:rPr>
-              <a:t>29 / 29</a:t>
+              <a:t>37 / 37</a:t>
             </a:r>
           </a:p>
         </p:txBody>
@@ -6077,7 +6077,7 @@
           <p:cNvPr id="9" name="text-87">
             <a:extLst xmlns:a="http://schemas.openxmlformats.org/drawingml/2006/main">
               <a:ext uri="{FF2B5EF4-FFF2-40B4-BE49-F238E27FC236}">
-                <a16:creationId xmlns:a16="http://schemas.microsoft.com/office/drawing/2014/main" id="{F1D98C32-1C27-429A-AD0D-6DEF8ECA28B4}"/>
+                <a16:creationId xmlns:a16="http://schemas.microsoft.com/office/drawing/2014/main" id="{BDCAA7ED-C32E-4808-BE15-1ED317B8E66F}"/>
               </a:ext>
             </a:extLst>
           </p:cNvPr>
@@ -6123,7 +6123,7 @@
                 <a:ea typeface="Arial"/>
                 <a:cs typeface="Arial"/>
               </a:rPr>
-              <a:t>17</a:t>
+              <a:t>18</a:t>
             </a:r>
           </a:p>
         </p:txBody>
@@ -6133,7 +6133,7 @@
           <p:cNvPr id="10" name="text-88">
             <a:extLst xmlns:a="http://schemas.openxmlformats.org/drawingml/2006/main">
               <a:ext uri="{FF2B5EF4-FFF2-40B4-BE49-F238E27FC236}">
-                <a16:creationId xmlns:a16="http://schemas.microsoft.com/office/drawing/2014/main" id="{9B19AF61-CE77-49EC-B95E-13B345066EF3}"/>
+                <a16:creationId xmlns:a16="http://schemas.microsoft.com/office/drawing/2014/main" id="{4CC679DE-917F-4448-8EB3-B978D4C1CD3C}"/>
               </a:ext>
             </a:extLst>
           </p:cNvPr>
@@ -6235,7 +6235,7 @@
           <p:cNvPr id="11" name="text-89">
             <a:extLst xmlns:a="http://schemas.openxmlformats.org/drawingml/2006/main">
               <a:ext uri="{FF2B5EF4-FFF2-40B4-BE49-F238E27FC236}">
-                <a16:creationId xmlns:a16="http://schemas.microsoft.com/office/drawing/2014/main" id="{9ED7C3EF-D217-48AB-9080-976A3EB0054B}"/>
+                <a16:creationId xmlns:a16="http://schemas.microsoft.com/office/drawing/2014/main" id="{6EFAD34B-1CF6-4255-989C-1F284B0C8282}"/>
               </a:ext>
             </a:extLst>
           </p:cNvPr>
@@ -6337,7 +6337,7 @@
           <p:cNvPr id="12" name="text-90">
             <a:extLst xmlns:a="http://schemas.openxmlformats.org/drawingml/2006/main">
               <a:ext uri="{FF2B5EF4-FFF2-40B4-BE49-F238E27FC236}">
-                <a16:creationId xmlns:a16="http://schemas.microsoft.com/office/drawing/2014/main" id="{F879CB93-B650-4AF6-B75B-EA13866CC955}"/>
+                <a16:creationId xmlns:a16="http://schemas.microsoft.com/office/drawing/2014/main" id="{FA52ABFD-2DF6-4114-8BA3-0FD7BBB22E4B}"/>
               </a:ext>
             </a:extLst>
           </p:cNvPr>
@@ -6439,7 +6439,7 @@
           <p:cNvPr id="13" name="box-91">
             <a:extLst xmlns:a="http://schemas.openxmlformats.org/drawingml/2006/main">
               <a:ext uri="{FF2B5EF4-FFF2-40B4-BE49-F238E27FC236}">
-                <a16:creationId xmlns:a16="http://schemas.microsoft.com/office/drawing/2014/main" id="{51698320-5E90-4905-B035-C349A076CE8E}"/>
+                <a16:creationId xmlns:a16="http://schemas.microsoft.com/office/drawing/2014/main" id="{6ED0AE9B-C67E-4861-B2CD-00462E7D68BF}"/>
               </a:ext>
             </a:extLst>
           </p:cNvPr>
@@ -6472,7 +6472,7 @@
           <p:cNvPr id="14" name="text-92">
             <a:extLst xmlns:a="http://schemas.openxmlformats.org/drawingml/2006/main">
               <a:ext uri="{FF2B5EF4-FFF2-40B4-BE49-F238E27FC236}">
-                <a16:creationId xmlns:a16="http://schemas.microsoft.com/office/drawing/2014/main" id="{4712D08C-8188-44F1-B727-F8EE034E16EC}"/>
+                <a16:creationId xmlns:a16="http://schemas.microsoft.com/office/drawing/2014/main" id="{E8DBBFCA-717C-4DB0-B85F-D96EA825642D}"/>
               </a:ext>
             </a:extLst>
           </p:cNvPr>
@@ -6528,7 +6528,7 @@
           <p:cNvPr id="15" name="text-93">
             <a:extLst xmlns:a="http://schemas.openxmlformats.org/drawingml/2006/main">
               <a:ext uri="{FF2B5EF4-FFF2-40B4-BE49-F238E27FC236}">
-                <a16:creationId xmlns:a16="http://schemas.microsoft.com/office/drawing/2014/main" id="{1153917D-7FBF-49B2-A6C8-774A2C08CF48}"/>
+                <a16:creationId xmlns:a16="http://schemas.microsoft.com/office/drawing/2014/main" id="{B28C4DE0-4656-4860-A780-B2966A5C475B}"/>
               </a:ext>
             </a:extLst>
           </p:cNvPr>
@@ -6584,7 +6584,7 @@
           <p:cNvPr id="16" name="text-94">
             <a:extLst xmlns:a="http://schemas.openxmlformats.org/drawingml/2006/main">
               <a:ext uri="{FF2B5EF4-FFF2-40B4-BE49-F238E27FC236}">
-                <a16:creationId xmlns:a16="http://schemas.microsoft.com/office/drawing/2014/main" id="{C3B2AE6C-212B-4397-A727-EFBB23489BF7}"/>
+                <a16:creationId xmlns:a16="http://schemas.microsoft.com/office/drawing/2014/main" id="{43344592-54B1-4083-821C-8E206D6C0509}"/>
               </a:ext>
             </a:extLst>
           </p:cNvPr>
@@ -6640,7 +6640,7 @@
           <p:cNvPr id="17" name="text-95">
             <a:extLst xmlns:a="http://schemas.openxmlformats.org/drawingml/2006/main">
               <a:ext uri="{FF2B5EF4-FFF2-40B4-BE49-F238E27FC236}">
-                <a16:creationId xmlns:a16="http://schemas.microsoft.com/office/drawing/2014/main" id="{9F84A400-C90D-47D7-8BDC-72084F38780A}"/>
+                <a16:creationId xmlns:a16="http://schemas.microsoft.com/office/drawing/2014/main" id="{A90367EF-B46F-4D3A-BF7C-48E42D7E0579}"/>
               </a:ext>
             </a:extLst>
           </p:cNvPr>
@@ -6694,7 +6694,7 @@
     </p:spTree>
     <p:extLst>
       <p:ext uri="{BB962C8B-B14F-4D97-AF65-F5344CB8AC3E}">
-        <p14:creationId xmlns:p14="http://schemas.microsoft.com/office/powerpoint/2010/main" val="1056817073"/>
+        <p14:creationId xmlns:p14="http://schemas.microsoft.com/office/powerpoint/2010/main" val="1694482741"/>
       </p:ext>
     </p:extLst>
   </p:cSld>

</xml_diff>

<commit_message>
Sunum: v1.2.0 sözlük yön seçimi, DE-EN-TR ve 86 test
Co-Authored-By: Claude Opus 5 <noreply@anthropic.com>
</commit_message>
<xml_diff>
--- a/docs/presentation/German-Course-AI-Trilingual.pptx
+++ b/docs/presentation/German-Course-AI-Trilingual.pptx
@@ -2,18 +2,18 @@
 <file path=ppt/presentation.xml><?xml version="1.0" encoding="utf-8"?>
 <p:presentation xmlns:p="http://schemas.openxmlformats.org/presentationml/2006/main">
   <p:sldMasterIdLst>
-    <p:sldMasterId xmlns:r="http://schemas.openxmlformats.org/officeDocument/2006/relationships" id="2147483648" r:id="R14c57ff539e24198"/>
+    <p:sldMasterId xmlns:r="http://schemas.openxmlformats.org/officeDocument/2006/relationships" id="2147483648" r:id="Rcbd384e84be040be"/>
   </p:sldMasterIdLst>
   <p:notesMasterIdLst>
-    <p:notesMasterId xmlns:r="http://schemas.openxmlformats.org/officeDocument/2006/relationships" r:id="R6fd61037b7d24fe0"/>
+    <p:notesMasterId xmlns:r="http://schemas.openxmlformats.org/officeDocument/2006/relationships" r:id="R68687a610da74c29"/>
   </p:notesMasterIdLst>
   <p:sldIdLst>
-    <p:sldId xmlns:r="http://schemas.openxmlformats.org/officeDocument/2006/relationships" id="256" r:id="R889e67e590fc420d"/>
-    <p:sldId xmlns:r="http://schemas.openxmlformats.org/officeDocument/2006/relationships" id="257" r:id="Re26b2e4e4ac74968"/>
-    <p:sldId xmlns:r="http://schemas.openxmlformats.org/officeDocument/2006/relationships" id="258" r:id="R7600acda1f1d483b"/>
-    <p:sldId xmlns:r="http://schemas.openxmlformats.org/officeDocument/2006/relationships" id="259" r:id="Rea40ac7185a1480b"/>
-    <p:sldId xmlns:r="http://schemas.openxmlformats.org/officeDocument/2006/relationships" id="260" r:id="R10ec942133944d27"/>
-    <p:sldId xmlns:r="http://schemas.openxmlformats.org/officeDocument/2006/relationships" id="261" r:id="R3ca0831b9419417d"/>
+    <p:sldId xmlns:r="http://schemas.openxmlformats.org/officeDocument/2006/relationships" id="256" r:id="R8c4826a347d14401"/>
+    <p:sldId xmlns:r="http://schemas.openxmlformats.org/officeDocument/2006/relationships" id="257" r:id="Rfaeaf785f87f4dd7"/>
+    <p:sldId xmlns:r="http://schemas.openxmlformats.org/officeDocument/2006/relationships" id="258" r:id="Rd54e1d0b8b6c476a"/>
+    <p:sldId xmlns:r="http://schemas.openxmlformats.org/officeDocument/2006/relationships" id="259" r:id="R0e83bf351a1c416c"/>
+    <p:sldId xmlns:r="http://schemas.openxmlformats.org/officeDocument/2006/relationships" id="260" r:id="Rd098d8f6b5cb4816"/>
+    <p:sldId xmlns:r="http://schemas.openxmlformats.org/officeDocument/2006/relationships" id="261" r:id="Rf7a6b883fad149a3"/>
   </p:sldIdLst>
   <p:sldSz cx="12192000" cy="6858000"/>
   <p:notesSz cx="6858000" cy="9144000"/>
@@ -937,7 +937,7 @@
           </a:p>
           <a:p xmlns:a="http://schemas.openxmlformats.org/drawingml/2006/main">
             <a:r>
-              <a:t>- https://github.com/Azizsekerdil/GermanCourseAI/releases/tag/v1.1.2</a:t>
+              <a:t>- https://github.com/Azizsekerdil/GermanCourseAI/releases/tag/v1.2.0</a:t>
             </a:r>
           </a:p>
           <a:p xmlns:a="http://schemas.openxmlformats.org/drawingml/2006/main">
@@ -1010,7 +1010,7 @@
   </p:cSld>
   <p:clrMap bg1="lt1" tx1="dk1" bg2="lt2" tx2="dk2" accent1="accent1" accent2="accent2" accent3="accent3" accent4="accent4" accent5="accent5" accent6="accent6" hlink="hlink" folHlink="folHlink"/>
   <p:sldLayoutIdLst>
-    <p:sldLayoutId xmlns:r="http://schemas.openxmlformats.org/officeDocument/2006/relationships" id="2147483649" r:id="R3c7f7ed8b28a44c4"/>
+    <p:sldLayoutId xmlns:r="http://schemas.openxmlformats.org/officeDocument/2006/relationships" id="2147483649" r:id="R582f8d2294ec437e"/>
   </p:sldLayoutIdLst>
   <p:txStyles>
     <p:titleStyle>
@@ -1561,7 +1561,7 @@
           <p:cNvPr id="13" name="box-1">
             <a:extLst xmlns:a="http://schemas.openxmlformats.org/drawingml/2006/main">
               <a:ext uri="{FF2B5EF4-FFF2-40B4-BE49-F238E27FC236}">
-                <a16:creationId xmlns:a16="http://schemas.microsoft.com/office/drawing/2014/main" id="{ECB7ADD2-8B1F-47DE-8224-AC132D1EEA2D}"/>
+                <a16:creationId xmlns:a16="http://schemas.microsoft.com/office/drawing/2014/main" id="{DB6DAC9F-4D84-478B-AE1B-23B78E9D6A07}"/>
               </a:ext>
             </a:extLst>
           </p:cNvPr>
@@ -1594,7 +1594,7 @@
           <p:cNvPr id="2" name="text-2">
             <a:extLst xmlns:a="http://schemas.openxmlformats.org/drawingml/2006/main">
               <a:ext uri="{FF2B5EF4-FFF2-40B4-BE49-F238E27FC236}">
-                <a16:creationId xmlns:a16="http://schemas.microsoft.com/office/drawing/2014/main" id="{7302CB64-73C2-44F1-BAB8-F99C4DDCF8F5}"/>
+                <a16:creationId xmlns:a16="http://schemas.microsoft.com/office/drawing/2014/main" id="{5267375E-2F47-4CC5-852F-D260E80DF7EB}"/>
               </a:ext>
             </a:extLst>
           </p:cNvPr>
@@ -1650,7 +1650,7 @@
           <p:cNvPr id="3" name="text-3">
             <a:extLst xmlns:a="http://schemas.openxmlformats.org/drawingml/2006/main">
               <a:ext uri="{FF2B5EF4-FFF2-40B4-BE49-F238E27FC236}">
-                <a16:creationId xmlns:a16="http://schemas.microsoft.com/office/drawing/2014/main" id="{889B231D-FBE1-4545-B20A-F67F301D0A54}"/>
+                <a16:creationId xmlns:a16="http://schemas.microsoft.com/office/drawing/2014/main" id="{04EE5129-C585-4EF0-BCAF-DBD8C0999771}"/>
               </a:ext>
             </a:extLst>
           </p:cNvPr>
@@ -1706,7 +1706,7 @@
           <p:cNvPr id="4" name="text-4">
             <a:extLst xmlns:a="http://schemas.openxmlformats.org/drawingml/2006/main">
               <a:ext uri="{FF2B5EF4-FFF2-40B4-BE49-F238E27FC236}">
-                <a16:creationId xmlns:a16="http://schemas.microsoft.com/office/drawing/2014/main" id="{73D9CEFF-5718-499B-AB93-4489FF5A81EB}"/>
+                <a16:creationId xmlns:a16="http://schemas.microsoft.com/office/drawing/2014/main" id="{09A12ED0-9573-4E32-BCA6-BA73E3E00C86}"/>
               </a:ext>
             </a:extLst>
           </p:cNvPr>
@@ -1762,7 +1762,7 @@
           <p:cNvPr id="5" name="text-5">
             <a:extLst xmlns:a="http://schemas.openxmlformats.org/drawingml/2006/main">
               <a:ext uri="{FF2B5EF4-FFF2-40B4-BE49-F238E27FC236}">
-                <a16:creationId xmlns:a16="http://schemas.microsoft.com/office/drawing/2014/main" id="{DD0F733A-811C-4445-80A3-3B0559D20492}"/>
+                <a16:creationId xmlns:a16="http://schemas.microsoft.com/office/drawing/2014/main" id="{BF419A2C-4FA1-45FF-A548-3B1FBEE0BCE4}"/>
               </a:ext>
             </a:extLst>
           </p:cNvPr>
@@ -1818,7 +1818,7 @@
           <p:cNvPr id="6" name="text-6">
             <a:extLst xmlns:a="http://schemas.openxmlformats.org/drawingml/2006/main">
               <a:ext uri="{FF2B5EF4-FFF2-40B4-BE49-F238E27FC236}">
-                <a16:creationId xmlns:a16="http://schemas.microsoft.com/office/drawing/2014/main" id="{4B1DA49E-102E-4079-BA37-08EB976BAFFD}"/>
+                <a16:creationId xmlns:a16="http://schemas.microsoft.com/office/drawing/2014/main" id="{1D325EB1-2955-40F5-93F8-C100445D97AC}"/>
               </a:ext>
             </a:extLst>
           </p:cNvPr>
@@ -1874,7 +1874,7 @@
           <p:cNvPr id="7" name="text-7">
             <a:extLst xmlns:a="http://schemas.openxmlformats.org/drawingml/2006/main">
               <a:ext uri="{FF2B5EF4-FFF2-40B4-BE49-F238E27FC236}">
-                <a16:creationId xmlns:a16="http://schemas.microsoft.com/office/drawing/2014/main" id="{E5129634-B8A2-4C16-9BC6-6C80A205C3A6}"/>
+                <a16:creationId xmlns:a16="http://schemas.microsoft.com/office/drawing/2014/main" id="{53FB5070-83D6-4E2C-8624-F0AADDB3C377}"/>
               </a:ext>
             </a:extLst>
           </p:cNvPr>
@@ -1930,7 +1930,7 @@
           <p:cNvPr id="8" name="text-8">
             <a:extLst xmlns:a="http://schemas.openxmlformats.org/drawingml/2006/main">
               <a:ext uri="{FF2B5EF4-FFF2-40B4-BE49-F238E27FC236}">
-                <a16:creationId xmlns:a16="http://schemas.microsoft.com/office/drawing/2014/main" id="{1E76E612-1DDA-41CA-8003-2A4767B508F9}"/>
+                <a16:creationId xmlns:a16="http://schemas.microsoft.com/office/drawing/2014/main" id="{C7213DFD-D89C-437A-A289-800D23C8EA8D}"/>
               </a:ext>
             </a:extLst>
           </p:cNvPr>
@@ -1986,7 +1986,7 @@
           <p:cNvPr id="9" name="text-9">
             <a:extLst xmlns:a="http://schemas.openxmlformats.org/drawingml/2006/main">
               <a:ext uri="{FF2B5EF4-FFF2-40B4-BE49-F238E27FC236}">
-                <a16:creationId xmlns:a16="http://schemas.microsoft.com/office/drawing/2014/main" id="{8214512A-A2B3-40CB-9FE1-866BC6BB4A44}"/>
+                <a16:creationId xmlns:a16="http://schemas.microsoft.com/office/drawing/2014/main" id="{BBB86E68-240A-4D36-903B-6EA7684430B8}"/>
               </a:ext>
             </a:extLst>
           </p:cNvPr>
@@ -2042,7 +2042,7 @@
           <p:cNvPr id="10" name="box-10">
             <a:extLst xmlns:a="http://schemas.openxmlformats.org/drawingml/2006/main">
               <a:ext uri="{FF2B5EF4-FFF2-40B4-BE49-F238E27FC236}">
-                <a16:creationId xmlns:a16="http://schemas.microsoft.com/office/drawing/2014/main" id="{C9DEF490-F080-4962-9DE0-EE9767FDCFC7}"/>
+                <a16:creationId xmlns:a16="http://schemas.microsoft.com/office/drawing/2014/main" id="{AC528F4E-A01C-42AF-BF51-5EC33242F7E2}"/>
               </a:ext>
             </a:extLst>
           </p:cNvPr>
@@ -2079,7 +2079,7 @@
           <p:nvPr/>
         </p:nvPicPr>
         <p:blipFill>
-          <a:blip xmlns:r="http://schemas.openxmlformats.org/officeDocument/2006/relationships" xmlns:a="http://schemas.openxmlformats.org/drawingml/2006/main" r:embed="Rec844ba0b74b4431"/>
+          <a:blip xmlns:r="http://schemas.openxmlformats.org/officeDocument/2006/relationships" xmlns:a="http://schemas.openxmlformats.org/drawingml/2006/main" r:embed="R908af25a4a6840ef"/>
           <a:stretch xmlns:a="http://schemas.openxmlformats.org/drawingml/2006/main"/>
         </p:blipFill>
         <p:spPr>
@@ -2097,7 +2097,7 @@
           <p:cNvPr id="12" name="text-11">
             <a:extLst xmlns:a="http://schemas.openxmlformats.org/drawingml/2006/main">
               <a:ext uri="{FF2B5EF4-FFF2-40B4-BE49-F238E27FC236}">
-                <a16:creationId xmlns:a16="http://schemas.microsoft.com/office/drawing/2014/main" id="{E5D7A53A-5A22-44D5-897C-828333CEDCB1}"/>
+                <a16:creationId xmlns:a16="http://schemas.microsoft.com/office/drawing/2014/main" id="{A7FD873E-C7CC-465B-9B83-69E3DB059C61}"/>
               </a:ext>
             </a:extLst>
           </p:cNvPr>
@@ -2151,7 +2151,7 @@
     </p:spTree>
     <p:extLst>
       <p:ext uri="{BB962C8B-B14F-4D97-AF65-F5344CB8AC3E}">
-        <p14:creationId xmlns:p14="http://schemas.microsoft.com/office/powerpoint/2010/main" val="1129890898"/>
+        <p14:creationId xmlns:p14="http://schemas.microsoft.com/office/powerpoint/2010/main" val="596872282"/>
       </p:ext>
     </p:extLst>
   </p:cSld>
@@ -2182,7 +2182,7 @@
           <p:cNvPr id="14" name="box-12">
             <a:extLst xmlns:a="http://schemas.openxmlformats.org/drawingml/2006/main">
               <a:ext uri="{FF2B5EF4-FFF2-40B4-BE49-F238E27FC236}">
-                <a16:creationId xmlns:a16="http://schemas.microsoft.com/office/drawing/2014/main" id="{E33B1932-133A-44FA-A443-1A94B83B07A3}"/>
+                <a16:creationId xmlns:a16="http://schemas.microsoft.com/office/drawing/2014/main" id="{8F62D3B4-19A0-4BD7-B956-45BD498488AF}"/>
               </a:ext>
             </a:extLst>
           </p:cNvPr>
@@ -2215,7 +2215,7 @@
           <p:cNvPr id="2" name="text-13">
             <a:extLst xmlns:a="http://schemas.openxmlformats.org/drawingml/2006/main">
               <a:ext uri="{FF2B5EF4-FFF2-40B4-BE49-F238E27FC236}">
-                <a16:creationId xmlns:a16="http://schemas.microsoft.com/office/drawing/2014/main" id="{081B716C-93F6-4377-A73E-843664E9AE13}"/>
+                <a16:creationId xmlns:a16="http://schemas.microsoft.com/office/drawing/2014/main" id="{EE12E12A-6723-493D-8DFA-3BF24045E547}"/>
               </a:ext>
             </a:extLst>
           </p:cNvPr>
@@ -2271,7 +2271,7 @@
           <p:cNvPr id="3" name="text-14">
             <a:extLst xmlns:a="http://schemas.openxmlformats.org/drawingml/2006/main">
               <a:ext uri="{FF2B5EF4-FFF2-40B4-BE49-F238E27FC236}">
-                <a16:creationId xmlns:a16="http://schemas.microsoft.com/office/drawing/2014/main" id="{A138C5E1-9AAC-4BFE-9766-3C1F1D730A3F}"/>
+                <a16:creationId xmlns:a16="http://schemas.microsoft.com/office/drawing/2014/main" id="{4E0A44FC-6AEB-46C4-B904-594FC9FB59F4}"/>
               </a:ext>
             </a:extLst>
           </p:cNvPr>
@@ -2327,7 +2327,7 @@
           <p:cNvPr id="4" name="text-15">
             <a:extLst xmlns:a="http://schemas.openxmlformats.org/drawingml/2006/main">
               <a:ext uri="{FF2B5EF4-FFF2-40B4-BE49-F238E27FC236}">
-                <a16:creationId xmlns:a16="http://schemas.microsoft.com/office/drawing/2014/main" id="{E4DD800B-7EF2-4764-B050-D724F12D1384}"/>
+                <a16:creationId xmlns:a16="http://schemas.microsoft.com/office/drawing/2014/main" id="{3152F943-7428-440C-8301-8748BE221DAF}"/>
               </a:ext>
             </a:extLst>
           </p:cNvPr>
@@ -2383,7 +2383,7 @@
           <p:cNvPr id="5" name="text-16">
             <a:extLst xmlns:a="http://schemas.openxmlformats.org/drawingml/2006/main">
               <a:ext uri="{FF2B5EF4-FFF2-40B4-BE49-F238E27FC236}">
-                <a16:creationId xmlns:a16="http://schemas.microsoft.com/office/drawing/2014/main" id="{2CC35216-935A-4D9F-9AFB-2917AFAFEDF3}"/>
+                <a16:creationId xmlns:a16="http://schemas.microsoft.com/office/drawing/2014/main" id="{36F9F73A-23DD-4EBE-9F2D-F2C8A588BA6D}"/>
               </a:ext>
             </a:extLst>
           </p:cNvPr>
@@ -2439,7 +2439,7 @@
           <p:cNvPr id="6" name="text-17">
             <a:extLst xmlns:a="http://schemas.openxmlformats.org/drawingml/2006/main">
               <a:ext uri="{FF2B5EF4-FFF2-40B4-BE49-F238E27FC236}">
-                <a16:creationId xmlns:a16="http://schemas.microsoft.com/office/drawing/2014/main" id="{3D092DFA-2DA5-49C7-924E-819F7662B4C8}"/>
+                <a16:creationId xmlns:a16="http://schemas.microsoft.com/office/drawing/2014/main" id="{6FE164FC-EB88-4107-9653-B3696323DE14}"/>
               </a:ext>
             </a:extLst>
           </p:cNvPr>
@@ -2495,7 +2495,7 @@
           <p:cNvPr id="7" name="box-18">
             <a:extLst xmlns:a="http://schemas.openxmlformats.org/drawingml/2006/main">
               <a:ext uri="{FF2B5EF4-FFF2-40B4-BE49-F238E27FC236}">
-                <a16:creationId xmlns:a16="http://schemas.microsoft.com/office/drawing/2014/main" id="{C9B1D16F-C3CE-4366-8A14-BD9954A220FF}"/>
+                <a16:creationId xmlns:a16="http://schemas.microsoft.com/office/drawing/2014/main" id="{BBAA5C99-C839-4B24-BA9C-2B6BF460CC5B}"/>
               </a:ext>
             </a:extLst>
           </p:cNvPr>
@@ -2528,7 +2528,7 @@
           <p:cNvPr id="8" name="text-19">
             <a:extLst xmlns:a="http://schemas.openxmlformats.org/drawingml/2006/main">
               <a:ext uri="{FF2B5EF4-FFF2-40B4-BE49-F238E27FC236}">
-                <a16:creationId xmlns:a16="http://schemas.microsoft.com/office/drawing/2014/main" id="{1326D86C-5987-45BF-85DB-B099D3FA8FCC}"/>
+                <a16:creationId xmlns:a16="http://schemas.microsoft.com/office/drawing/2014/main" id="{A949F6EE-1794-46EF-B194-E94371D58923}"/>
               </a:ext>
             </a:extLst>
           </p:cNvPr>
@@ -2574,7 +2574,7 @@
                 <a:ea typeface="Arial"/>
                 <a:cs typeface="Arial"/>
               </a:rPr>
-              <a:t>18 Bereiche verbinden Wiederholung, Wortschatz, ein zweisprachiges Wörterbuch DE-EN, Prüfung, Grammatik und Praxis in einem ruhigen Windows-Arbeitsraum.</a:t>
+              <a:t>18 Bereiche verbinden Wiederholung, Wortschatz, ein dreisprachiges Wörterbuch DE-EN-TR, Prüfung, Grammatik und Praxis in einem ruhigen Windows-Arbeitsraum.</a:t>
             </a:r>
           </a:p>
         </p:txBody>
@@ -2584,7 +2584,7 @@
           <p:cNvPr id="9" name="text-20">
             <a:extLst xmlns:a="http://schemas.openxmlformats.org/drawingml/2006/main">
               <a:ext uri="{FF2B5EF4-FFF2-40B4-BE49-F238E27FC236}">
-                <a16:creationId xmlns:a16="http://schemas.microsoft.com/office/drawing/2014/main" id="{7D9643C4-81B4-40F6-9F9A-457DF404955E}"/>
+                <a16:creationId xmlns:a16="http://schemas.microsoft.com/office/drawing/2014/main" id="{B41CFA2D-A119-410C-8190-9567E433D3B0}"/>
               </a:ext>
             </a:extLst>
           </p:cNvPr>
@@ -2640,7 +2640,7 @@
           <p:cNvPr id="10" name="text-21">
             <a:extLst xmlns:a="http://schemas.openxmlformats.org/drawingml/2006/main">
               <a:ext uri="{FF2B5EF4-FFF2-40B4-BE49-F238E27FC236}">
-                <a16:creationId xmlns:a16="http://schemas.microsoft.com/office/drawing/2014/main" id="{144CE648-4A8F-48F7-AA8E-760E4F666F7B}"/>
+                <a16:creationId xmlns:a16="http://schemas.microsoft.com/office/drawing/2014/main" id="{4DA67DD5-62C1-4B4C-BA36-00E266DBAB9A}"/>
               </a:ext>
             </a:extLst>
           </p:cNvPr>
@@ -2696,7 +2696,7 @@
           <p:cNvPr id="11" name="box-22">
             <a:extLst xmlns:a="http://schemas.openxmlformats.org/drawingml/2006/main">
               <a:ext uri="{FF2B5EF4-FFF2-40B4-BE49-F238E27FC236}">
-                <a16:creationId xmlns:a16="http://schemas.microsoft.com/office/drawing/2014/main" id="{C0D7AFB1-EF15-4B1C-B8EE-235D407960F0}"/>
+                <a16:creationId xmlns:a16="http://schemas.microsoft.com/office/drawing/2014/main" id="{B5DA10AF-23F3-4C66-93A1-69748DBB34F6}"/>
               </a:ext>
             </a:extLst>
           </p:cNvPr>
@@ -2733,7 +2733,7 @@
           <p:nvPr/>
         </p:nvPicPr>
         <p:blipFill>
-          <a:blip xmlns:r="http://schemas.openxmlformats.org/officeDocument/2006/relationships" xmlns:a="http://schemas.openxmlformats.org/drawingml/2006/main" r:embed="R845ec1906a134e11"/>
+          <a:blip xmlns:r="http://schemas.openxmlformats.org/officeDocument/2006/relationships" xmlns:a="http://schemas.openxmlformats.org/drawingml/2006/main" r:embed="Rd5cefa8cbcf14da2"/>
           <a:stretch xmlns:a="http://schemas.openxmlformats.org/drawingml/2006/main"/>
         </p:blipFill>
         <p:spPr>
@@ -2751,7 +2751,7 @@
           <p:cNvPr id="13" name="text-23">
             <a:extLst xmlns:a="http://schemas.openxmlformats.org/drawingml/2006/main">
               <a:ext uri="{FF2B5EF4-FFF2-40B4-BE49-F238E27FC236}">
-                <a16:creationId xmlns:a16="http://schemas.microsoft.com/office/drawing/2014/main" id="{D42E335C-03E4-4397-BD70-A64862D364BD}"/>
+                <a16:creationId xmlns:a16="http://schemas.microsoft.com/office/drawing/2014/main" id="{5E9C3962-EEAD-4EE7-A790-78DA06BE945F}"/>
               </a:ext>
             </a:extLst>
           </p:cNvPr>
@@ -2805,7 +2805,7 @@
     </p:spTree>
     <p:extLst>
       <p:ext uri="{BB962C8B-B14F-4D97-AF65-F5344CB8AC3E}">
-        <p14:creationId xmlns:p14="http://schemas.microsoft.com/office/powerpoint/2010/main" val="1610947352"/>
+        <p14:creationId xmlns:p14="http://schemas.microsoft.com/office/powerpoint/2010/main" val="594986275"/>
       </p:ext>
     </p:extLst>
   </p:cSld>
@@ -2836,7 +2836,7 @@
           <p:cNvPr id="19" name="box-24">
             <a:extLst xmlns:a="http://schemas.openxmlformats.org/drawingml/2006/main">
               <a:ext uri="{FF2B5EF4-FFF2-40B4-BE49-F238E27FC236}">
-                <a16:creationId xmlns:a16="http://schemas.microsoft.com/office/drawing/2014/main" id="{A88D0937-249F-4209-91C4-D2134C584BEF}"/>
+                <a16:creationId xmlns:a16="http://schemas.microsoft.com/office/drawing/2014/main" id="{92A34BA2-05AF-4406-AFE7-A1CF9759D3CE}"/>
               </a:ext>
             </a:extLst>
           </p:cNvPr>
@@ -2869,7 +2869,7 @@
           <p:cNvPr id="2" name="text-25">
             <a:extLst xmlns:a="http://schemas.openxmlformats.org/drawingml/2006/main">
               <a:ext uri="{FF2B5EF4-FFF2-40B4-BE49-F238E27FC236}">
-                <a16:creationId xmlns:a16="http://schemas.microsoft.com/office/drawing/2014/main" id="{B453089A-B537-4CA7-AA7C-DA7E64A0214E}"/>
+                <a16:creationId xmlns:a16="http://schemas.microsoft.com/office/drawing/2014/main" id="{94B9B308-B488-4FC7-B2C9-7D5162A86BB0}"/>
               </a:ext>
             </a:extLst>
           </p:cNvPr>
@@ -2925,7 +2925,7 @@
           <p:cNvPr id="3" name="text-26">
             <a:extLst xmlns:a="http://schemas.openxmlformats.org/drawingml/2006/main">
               <a:ext uri="{FF2B5EF4-FFF2-40B4-BE49-F238E27FC236}">
-                <a16:creationId xmlns:a16="http://schemas.microsoft.com/office/drawing/2014/main" id="{E701F1F3-90D8-4CDB-9646-031231630318}"/>
+                <a16:creationId xmlns:a16="http://schemas.microsoft.com/office/drawing/2014/main" id="{EC84F5A9-52A9-44EB-BB0D-6156BF47D6A5}"/>
               </a:ext>
             </a:extLst>
           </p:cNvPr>
@@ -2981,7 +2981,7 @@
           <p:cNvPr id="4" name="text-27">
             <a:extLst xmlns:a="http://schemas.openxmlformats.org/drawingml/2006/main">
               <a:ext uri="{FF2B5EF4-FFF2-40B4-BE49-F238E27FC236}">
-                <a16:creationId xmlns:a16="http://schemas.microsoft.com/office/drawing/2014/main" id="{851F0671-2547-49EB-94C7-CE47DB92CFA7}"/>
+                <a16:creationId xmlns:a16="http://schemas.microsoft.com/office/drawing/2014/main" id="{E7D5C448-EA7D-4433-8501-6977A4C85CD3}"/>
               </a:ext>
             </a:extLst>
           </p:cNvPr>
@@ -3037,7 +3037,7 @@
           <p:cNvPr id="5" name="text-28">
             <a:extLst xmlns:a="http://schemas.openxmlformats.org/drawingml/2006/main">
               <a:ext uri="{FF2B5EF4-FFF2-40B4-BE49-F238E27FC236}">
-                <a16:creationId xmlns:a16="http://schemas.microsoft.com/office/drawing/2014/main" id="{39F4B3FC-A084-4218-BFF3-E7793807FAD2}"/>
+                <a16:creationId xmlns:a16="http://schemas.microsoft.com/office/drawing/2014/main" id="{D851E3E4-8D2B-4C3C-B944-E3EB0C9BE3EC}"/>
               </a:ext>
             </a:extLst>
           </p:cNvPr>
@@ -3093,7 +3093,7 @@
           <p:cNvPr id="6" name="text-29">
             <a:extLst xmlns:a="http://schemas.openxmlformats.org/drawingml/2006/main">
               <a:ext uri="{FF2B5EF4-FFF2-40B4-BE49-F238E27FC236}">
-                <a16:creationId xmlns:a16="http://schemas.microsoft.com/office/drawing/2014/main" id="{402AFB21-D954-4E51-8B0E-98DADA9C01F6}"/>
+                <a16:creationId xmlns:a16="http://schemas.microsoft.com/office/drawing/2014/main" id="{F60C1993-8D31-4C34-ABDA-463D5BFF2E05}"/>
               </a:ext>
             </a:extLst>
           </p:cNvPr>
@@ -3149,7 +3149,7 @@
           <p:cNvPr id="7" name="box-30">
             <a:extLst xmlns:a="http://schemas.openxmlformats.org/drawingml/2006/main">
               <a:ext uri="{FF2B5EF4-FFF2-40B4-BE49-F238E27FC236}">
-                <a16:creationId xmlns:a16="http://schemas.microsoft.com/office/drawing/2014/main" id="{4711F673-DC15-47B8-8069-9D742E3EC82C}"/>
+                <a16:creationId xmlns:a16="http://schemas.microsoft.com/office/drawing/2014/main" id="{872CA90A-72D3-412E-9524-581AED41D333}"/>
               </a:ext>
             </a:extLst>
           </p:cNvPr>
@@ -3182,7 +3182,7 @@
           <p:cNvPr id="8" name="text-31">
             <a:extLst xmlns:a="http://schemas.openxmlformats.org/drawingml/2006/main">
               <a:ext uri="{FF2B5EF4-FFF2-40B4-BE49-F238E27FC236}">
-                <a16:creationId xmlns:a16="http://schemas.microsoft.com/office/drawing/2014/main" id="{4C0FB158-D765-4B02-8D90-466B3767D756}"/>
+                <a16:creationId xmlns:a16="http://schemas.microsoft.com/office/drawing/2014/main" id="{10E1E981-6D60-4881-8BE0-8F301BA1DC35}"/>
               </a:ext>
             </a:extLst>
           </p:cNvPr>
@@ -3238,7 +3238,7 @@
           <p:cNvPr id="9" name="text-32">
             <a:extLst xmlns:a="http://schemas.openxmlformats.org/drawingml/2006/main">
               <a:ext uri="{FF2B5EF4-FFF2-40B4-BE49-F238E27FC236}">
-                <a16:creationId xmlns:a16="http://schemas.microsoft.com/office/drawing/2014/main" id="{0719875C-0CA0-4036-BB23-AA0D46C8AEF8}"/>
+                <a16:creationId xmlns:a16="http://schemas.microsoft.com/office/drawing/2014/main" id="{88E9C127-BFBB-4858-B0A9-4B19F7C6ACA8}"/>
               </a:ext>
             </a:extLst>
           </p:cNvPr>
@@ -3294,7 +3294,7 @@
           <p:cNvPr id="10" name="text-33">
             <a:extLst xmlns:a="http://schemas.openxmlformats.org/drawingml/2006/main">
               <a:ext uri="{FF2B5EF4-FFF2-40B4-BE49-F238E27FC236}">
-                <a16:creationId xmlns:a16="http://schemas.microsoft.com/office/drawing/2014/main" id="{2EC1ECA7-3964-443B-825F-03345539AA4D}"/>
+                <a16:creationId xmlns:a16="http://schemas.microsoft.com/office/drawing/2014/main" id="{42241732-D5D6-4EB1-AB7C-2293C41B3348}"/>
               </a:ext>
             </a:extLst>
           </p:cNvPr>
@@ -3350,7 +3350,7 @@
           <p:cNvPr id="11" name="box-34">
             <a:extLst xmlns:a="http://schemas.openxmlformats.org/drawingml/2006/main">
               <a:ext uri="{FF2B5EF4-FFF2-40B4-BE49-F238E27FC236}">
-                <a16:creationId xmlns:a16="http://schemas.microsoft.com/office/drawing/2014/main" id="{E328E655-E96E-47D7-B280-49E0331E394E}"/>
+                <a16:creationId xmlns:a16="http://schemas.microsoft.com/office/drawing/2014/main" id="{A95F438F-AB83-4483-9C0C-E4E5C13BD05C}"/>
               </a:ext>
             </a:extLst>
           </p:cNvPr>
@@ -3383,7 +3383,7 @@
           <p:cNvPr id="12" name="text-35">
             <a:extLst xmlns:a="http://schemas.openxmlformats.org/drawingml/2006/main">
               <a:ext uri="{FF2B5EF4-FFF2-40B4-BE49-F238E27FC236}">
-                <a16:creationId xmlns:a16="http://schemas.microsoft.com/office/drawing/2014/main" id="{4D7E0A45-221A-4295-A139-5518B2224703}"/>
+                <a16:creationId xmlns:a16="http://schemas.microsoft.com/office/drawing/2014/main" id="{0CFD4A77-47B1-4655-80AC-7EAF0161448B}"/>
               </a:ext>
             </a:extLst>
           </p:cNvPr>
@@ -3439,7 +3439,7 @@
           <p:cNvPr id="13" name="text-36">
             <a:extLst xmlns:a="http://schemas.openxmlformats.org/drawingml/2006/main">
               <a:ext uri="{FF2B5EF4-FFF2-40B4-BE49-F238E27FC236}">
-                <a16:creationId xmlns:a16="http://schemas.microsoft.com/office/drawing/2014/main" id="{63B6A9F0-FAC0-49C9-A1A0-DB67373BAC68}"/>
+                <a16:creationId xmlns:a16="http://schemas.microsoft.com/office/drawing/2014/main" id="{1CDA6CAA-F3E7-4F3E-B16A-E3F6570025B1}"/>
               </a:ext>
             </a:extLst>
           </p:cNvPr>
@@ -3485,7 +3485,7 @@
                 <a:ea typeface="Arial"/>
                 <a:cs typeface="Arial"/>
               </a:rPr>
-              <a:t>160 A1 entries, a 1,260-entry DE-EN dictionary, strict spelling, exams, favorites and mistakes share one SQLite record.</a:t>
+              <a:t>160 A1 entries, a 1,260-entry DE-EN-TR dictionary with selectable direction, strict spelling, exams, favorites and mistakes share one SQLite record.</a:t>
             </a:r>
           </a:p>
         </p:txBody>
@@ -3495,7 +3495,7 @@
           <p:cNvPr id="14" name="text-37">
             <a:extLst xmlns:a="http://schemas.openxmlformats.org/drawingml/2006/main">
               <a:ext uri="{FF2B5EF4-FFF2-40B4-BE49-F238E27FC236}">
-                <a16:creationId xmlns:a16="http://schemas.microsoft.com/office/drawing/2014/main" id="{54E79D31-6555-47D1-8E36-5033140A02BF}"/>
+                <a16:creationId xmlns:a16="http://schemas.microsoft.com/office/drawing/2014/main" id="{5D3B49BA-4446-4DDF-8F3A-85B871FEC381}"/>
               </a:ext>
             </a:extLst>
           </p:cNvPr>
@@ -3551,7 +3551,7 @@
           <p:cNvPr id="15" name="box-38">
             <a:extLst xmlns:a="http://schemas.openxmlformats.org/drawingml/2006/main">
               <a:ext uri="{FF2B5EF4-FFF2-40B4-BE49-F238E27FC236}">
-                <a16:creationId xmlns:a16="http://schemas.microsoft.com/office/drawing/2014/main" id="{A390B7DF-C245-4074-8A4D-8E8C64544E60}"/>
+                <a16:creationId xmlns:a16="http://schemas.microsoft.com/office/drawing/2014/main" id="{61EC830C-DC89-488F-97CF-246C16FA5FFD}"/>
               </a:ext>
             </a:extLst>
           </p:cNvPr>
@@ -3584,7 +3584,7 @@
           <p:cNvPr id="16" name="text-39">
             <a:extLst xmlns:a="http://schemas.openxmlformats.org/drawingml/2006/main">
               <a:ext uri="{FF2B5EF4-FFF2-40B4-BE49-F238E27FC236}">
-                <a16:creationId xmlns:a16="http://schemas.microsoft.com/office/drawing/2014/main" id="{1F7A5F40-BAF3-4F18-98A6-3568D3EA3483}"/>
+                <a16:creationId xmlns:a16="http://schemas.microsoft.com/office/drawing/2014/main" id="{998F8535-9117-4711-81E5-A3945CB8EF08}"/>
               </a:ext>
             </a:extLst>
           </p:cNvPr>
@@ -3640,7 +3640,7 @@
           <p:cNvPr id="17" name="text-40">
             <a:extLst xmlns:a="http://schemas.openxmlformats.org/drawingml/2006/main">
               <a:ext uri="{FF2B5EF4-FFF2-40B4-BE49-F238E27FC236}">
-                <a16:creationId xmlns:a16="http://schemas.microsoft.com/office/drawing/2014/main" id="{7853B88D-B678-4ED1-9260-02945E0778D3}"/>
+                <a16:creationId xmlns:a16="http://schemas.microsoft.com/office/drawing/2014/main" id="{3A3A2EAA-F046-4E4C-AFE3-296AE88C3951}"/>
               </a:ext>
             </a:extLst>
           </p:cNvPr>
@@ -3696,7 +3696,7 @@
           <p:cNvPr id="18" name="text-41">
             <a:extLst xmlns:a="http://schemas.openxmlformats.org/drawingml/2006/main">
               <a:ext uri="{FF2B5EF4-FFF2-40B4-BE49-F238E27FC236}">
-                <a16:creationId xmlns:a16="http://schemas.microsoft.com/office/drawing/2014/main" id="{7E05DE00-113F-4F39-BBBA-3D1BA1627F29}"/>
+                <a16:creationId xmlns:a16="http://schemas.microsoft.com/office/drawing/2014/main" id="{A5F87B11-377E-4EF5-9602-82ABDF57AE31}"/>
               </a:ext>
             </a:extLst>
           </p:cNvPr>
@@ -3750,7 +3750,7 @@
     </p:spTree>
     <p:extLst>
       <p:ext uri="{BB962C8B-B14F-4D97-AF65-F5344CB8AC3E}">
-        <p14:creationId xmlns:p14="http://schemas.microsoft.com/office/powerpoint/2010/main" val="1728093575"/>
+        <p14:creationId xmlns:p14="http://schemas.microsoft.com/office/powerpoint/2010/main" val="129713678"/>
       </p:ext>
     </p:extLst>
   </p:cSld>
@@ -3781,7 +3781,7 @@
           <p:cNvPr id="18" name="box-42">
             <a:extLst xmlns:a="http://schemas.openxmlformats.org/drawingml/2006/main">
               <a:ext uri="{FF2B5EF4-FFF2-40B4-BE49-F238E27FC236}">
-                <a16:creationId xmlns:a16="http://schemas.microsoft.com/office/drawing/2014/main" id="{09FD2316-D4D8-48EE-9483-A3C65DD6F881}"/>
+                <a16:creationId xmlns:a16="http://schemas.microsoft.com/office/drawing/2014/main" id="{97C55A65-1C79-4059-962C-02D21191DB79}"/>
               </a:ext>
             </a:extLst>
           </p:cNvPr>
@@ -3814,7 +3814,7 @@
           <p:cNvPr id="2" name="text-43">
             <a:extLst xmlns:a="http://schemas.openxmlformats.org/drawingml/2006/main">
               <a:ext uri="{FF2B5EF4-FFF2-40B4-BE49-F238E27FC236}">
-                <a16:creationId xmlns:a16="http://schemas.microsoft.com/office/drawing/2014/main" id="{B8D6BB38-8EF8-403C-89A6-2BA649AF6152}"/>
+                <a16:creationId xmlns:a16="http://schemas.microsoft.com/office/drawing/2014/main" id="{3CA18004-B494-4C76-B0F7-00F3127F3CD5}"/>
               </a:ext>
             </a:extLst>
           </p:cNvPr>
@@ -3870,7 +3870,7 @@
           <p:cNvPr id="3" name="text-44">
             <a:extLst xmlns:a="http://schemas.openxmlformats.org/drawingml/2006/main">
               <a:ext uri="{FF2B5EF4-FFF2-40B4-BE49-F238E27FC236}">
-                <a16:creationId xmlns:a16="http://schemas.microsoft.com/office/drawing/2014/main" id="{AF3A3A66-3E2E-4458-9548-98232CFFF6BE}"/>
+                <a16:creationId xmlns:a16="http://schemas.microsoft.com/office/drawing/2014/main" id="{82D30C58-BE95-4055-8C29-6D6B02724E90}"/>
               </a:ext>
             </a:extLst>
           </p:cNvPr>
@@ -3926,7 +3926,7 @@
           <p:cNvPr id="4" name="text-45">
             <a:extLst xmlns:a="http://schemas.openxmlformats.org/drawingml/2006/main">
               <a:ext uri="{FF2B5EF4-FFF2-40B4-BE49-F238E27FC236}">
-                <a16:creationId xmlns:a16="http://schemas.microsoft.com/office/drawing/2014/main" id="{6D7DA84B-3ADB-4D77-BE93-3DB1739AAEE1}"/>
+                <a16:creationId xmlns:a16="http://schemas.microsoft.com/office/drawing/2014/main" id="{348C1204-FF34-45EA-9A3E-242512EED031}"/>
               </a:ext>
             </a:extLst>
           </p:cNvPr>
@@ -3982,7 +3982,7 @@
           <p:cNvPr id="5" name="text-46">
             <a:extLst xmlns:a="http://schemas.openxmlformats.org/drawingml/2006/main">
               <a:ext uri="{FF2B5EF4-FFF2-40B4-BE49-F238E27FC236}">
-                <a16:creationId xmlns:a16="http://schemas.microsoft.com/office/drawing/2014/main" id="{1EBA72E3-09B7-40BE-9906-911293D8ACDA}"/>
+                <a16:creationId xmlns:a16="http://schemas.microsoft.com/office/drawing/2014/main" id="{05D79A9E-4BD7-45FE-A1ED-98BD91878563}"/>
               </a:ext>
             </a:extLst>
           </p:cNvPr>
@@ -4038,7 +4038,7 @@
           <p:cNvPr id="6" name="box-47">
             <a:extLst xmlns:a="http://schemas.openxmlformats.org/drawingml/2006/main">
               <a:ext uri="{FF2B5EF4-FFF2-40B4-BE49-F238E27FC236}">
-                <a16:creationId xmlns:a16="http://schemas.microsoft.com/office/drawing/2014/main" id="{758E1A76-D95E-4ECC-83FA-32D184AD4DE8}"/>
+                <a16:creationId xmlns:a16="http://schemas.microsoft.com/office/drawing/2014/main" id="{1A0DD97D-DE24-42BE-8AE9-5CFF7A720814}"/>
               </a:ext>
             </a:extLst>
           </p:cNvPr>
@@ -4071,7 +4071,7 @@
           <p:cNvPr id="7" name="text-48">
             <a:extLst xmlns:a="http://schemas.openxmlformats.org/drawingml/2006/main">
               <a:ext uri="{FF2B5EF4-FFF2-40B4-BE49-F238E27FC236}">
-                <a16:creationId xmlns:a16="http://schemas.microsoft.com/office/drawing/2014/main" id="{9A22E521-0E89-40B1-A9B3-CFF3D5B23EB9}"/>
+                <a16:creationId xmlns:a16="http://schemas.microsoft.com/office/drawing/2014/main" id="{0D3F467A-7B55-4A08-93BC-E4393579A1B8}"/>
               </a:ext>
             </a:extLst>
           </p:cNvPr>
@@ -4127,7 +4127,7 @@
           <p:cNvPr id="8" name="text-49">
             <a:extLst xmlns:a="http://schemas.openxmlformats.org/drawingml/2006/main">
               <a:ext uri="{FF2B5EF4-FFF2-40B4-BE49-F238E27FC236}">
-                <a16:creationId xmlns:a16="http://schemas.microsoft.com/office/drawing/2014/main" id="{301045D3-6FE6-4269-8236-4FE9BB3D8157}"/>
+                <a16:creationId xmlns:a16="http://schemas.microsoft.com/office/drawing/2014/main" id="{DB02D4B7-AD1D-480A-B0C2-886223FD4E0C}"/>
               </a:ext>
             </a:extLst>
           </p:cNvPr>
@@ -4183,7 +4183,7 @@
           <p:cNvPr id="9" name="box-50">
             <a:extLst xmlns:a="http://schemas.openxmlformats.org/drawingml/2006/main">
               <a:ext uri="{FF2B5EF4-FFF2-40B4-BE49-F238E27FC236}">
-                <a16:creationId xmlns:a16="http://schemas.microsoft.com/office/drawing/2014/main" id="{B4430621-3A8E-467B-84A8-A5F0AB257F13}"/>
+                <a16:creationId xmlns:a16="http://schemas.microsoft.com/office/drawing/2014/main" id="{F67D3A52-A3C3-4B49-9B24-3041D0D1BED3}"/>
               </a:ext>
             </a:extLst>
           </p:cNvPr>
@@ -4216,7 +4216,7 @@
           <p:cNvPr id="10" name="text-51">
             <a:extLst xmlns:a="http://schemas.openxmlformats.org/drawingml/2006/main">
               <a:ext uri="{FF2B5EF4-FFF2-40B4-BE49-F238E27FC236}">
-                <a16:creationId xmlns:a16="http://schemas.microsoft.com/office/drawing/2014/main" id="{A12E063A-A877-4757-956C-2D00C8FDF03C}"/>
+                <a16:creationId xmlns:a16="http://schemas.microsoft.com/office/drawing/2014/main" id="{034868B8-543B-4CF7-AF7A-0A3B2267F0C6}"/>
               </a:ext>
             </a:extLst>
           </p:cNvPr>
@@ -4272,7 +4272,7 @@
           <p:cNvPr id="11" name="text-52">
             <a:extLst xmlns:a="http://schemas.openxmlformats.org/drawingml/2006/main">
               <a:ext uri="{FF2B5EF4-FFF2-40B4-BE49-F238E27FC236}">
-                <a16:creationId xmlns:a16="http://schemas.microsoft.com/office/drawing/2014/main" id="{7E52C945-CE90-45BF-9B56-9AFF28055C7C}"/>
+                <a16:creationId xmlns:a16="http://schemas.microsoft.com/office/drawing/2014/main" id="{C6CF868F-CE9D-43C3-8A24-97F162B7CD7F}"/>
               </a:ext>
             </a:extLst>
           </p:cNvPr>
@@ -4328,7 +4328,7 @@
           <p:cNvPr id="12" name="box-53">
             <a:extLst xmlns:a="http://schemas.openxmlformats.org/drawingml/2006/main">
               <a:ext uri="{FF2B5EF4-FFF2-40B4-BE49-F238E27FC236}">
-                <a16:creationId xmlns:a16="http://schemas.microsoft.com/office/drawing/2014/main" id="{6846920C-6EDC-417C-BA64-C617D37952CD}"/>
+                <a16:creationId xmlns:a16="http://schemas.microsoft.com/office/drawing/2014/main" id="{0BA21ABF-B321-44BC-AE19-56FF8A089CAD}"/>
               </a:ext>
             </a:extLst>
           </p:cNvPr>
@@ -4361,7 +4361,7 @@
           <p:cNvPr id="13" name="text-54">
             <a:extLst xmlns:a="http://schemas.openxmlformats.org/drawingml/2006/main">
               <a:ext uri="{FF2B5EF4-FFF2-40B4-BE49-F238E27FC236}">
-                <a16:creationId xmlns:a16="http://schemas.microsoft.com/office/drawing/2014/main" id="{40E592CB-854B-4271-A240-BC9AAAA74A7F}"/>
+                <a16:creationId xmlns:a16="http://schemas.microsoft.com/office/drawing/2014/main" id="{BE699737-8986-4D3D-BE7B-1848D55FE462}"/>
               </a:ext>
             </a:extLst>
           </p:cNvPr>
@@ -4417,7 +4417,7 @@
           <p:cNvPr id="14" name="text-55">
             <a:extLst xmlns:a="http://schemas.openxmlformats.org/drawingml/2006/main">
               <a:ext uri="{FF2B5EF4-FFF2-40B4-BE49-F238E27FC236}">
-                <a16:creationId xmlns:a16="http://schemas.microsoft.com/office/drawing/2014/main" id="{94AA6685-E4B5-4D24-8480-708D59BE0B8E}"/>
+                <a16:creationId xmlns:a16="http://schemas.microsoft.com/office/drawing/2014/main" id="{09F8DF43-0D19-484D-9E9B-956155A5C655}"/>
               </a:ext>
             </a:extLst>
           </p:cNvPr>
@@ -4473,7 +4473,7 @@
           <p:cNvPr id="15" name="box-56">
             <a:extLst xmlns:a="http://schemas.openxmlformats.org/drawingml/2006/main">
               <a:ext uri="{FF2B5EF4-FFF2-40B4-BE49-F238E27FC236}">
-                <a16:creationId xmlns:a16="http://schemas.microsoft.com/office/drawing/2014/main" id="{B07F4D49-F0B1-4675-A75F-25DC6158AF45}"/>
+                <a16:creationId xmlns:a16="http://schemas.microsoft.com/office/drawing/2014/main" id="{0E441D89-8F20-4297-87A6-78E782759395}"/>
               </a:ext>
             </a:extLst>
           </p:cNvPr>
@@ -4506,7 +4506,7 @@
           <p:cNvPr id="16" name="text-57">
             <a:extLst xmlns:a="http://schemas.openxmlformats.org/drawingml/2006/main">
               <a:ext uri="{FF2B5EF4-FFF2-40B4-BE49-F238E27FC236}">
-                <a16:creationId xmlns:a16="http://schemas.microsoft.com/office/drawing/2014/main" id="{1C24CC5D-A433-4471-B361-ABA6C30AEB2E}"/>
+                <a16:creationId xmlns:a16="http://schemas.microsoft.com/office/drawing/2014/main" id="{1FA414CB-5370-46E1-8F03-BF869738348F}"/>
               </a:ext>
             </a:extLst>
           </p:cNvPr>
@@ -4562,7 +4562,7 @@
           <p:cNvPr id="17" name="text-58">
             <a:extLst xmlns:a="http://schemas.openxmlformats.org/drawingml/2006/main">
               <a:ext uri="{FF2B5EF4-FFF2-40B4-BE49-F238E27FC236}">
-                <a16:creationId xmlns:a16="http://schemas.microsoft.com/office/drawing/2014/main" id="{3616D272-1819-4750-8F91-75E1E30FA13C}"/>
+                <a16:creationId xmlns:a16="http://schemas.microsoft.com/office/drawing/2014/main" id="{226B3944-B5BE-4A4B-A596-3173E2C1D8B8}"/>
               </a:ext>
             </a:extLst>
           </p:cNvPr>
@@ -4608,7 +4608,7 @@
                 <a:ea typeface="Arial"/>
                 <a:cs typeface="Arial"/>
               </a:rPr>
-              <a:t>Sözlük çoğuldan tekili bulur · dictionary resolves plurals · Wörterbuch findet den Singular</a:t>
+              <a:t>Sözlük DE↔EN↔TR yön seçimli · dictionary DE/EN/TR with direction switch · Wörterbuch DE/EN/TR mit Richtungswahl</a:t>
             </a:r>
           </a:p>
         </p:txBody>
@@ -4616,7 +4616,7 @@
     </p:spTree>
     <p:extLst>
       <p:ext uri="{BB962C8B-B14F-4D97-AF65-F5344CB8AC3E}">
-        <p14:creationId xmlns:p14="http://schemas.microsoft.com/office/powerpoint/2010/main" val="1875877072"/>
+        <p14:creationId xmlns:p14="http://schemas.microsoft.com/office/powerpoint/2010/main" val="1262386143"/>
       </p:ext>
     </p:extLst>
   </p:cSld>
@@ -4647,7 +4647,7 @@
           <p:cNvPr id="21" name="box-59">
             <a:extLst xmlns:a="http://schemas.openxmlformats.org/drawingml/2006/main">
               <a:ext uri="{FF2B5EF4-FFF2-40B4-BE49-F238E27FC236}">
-                <a16:creationId xmlns:a16="http://schemas.microsoft.com/office/drawing/2014/main" id="{B030CE66-1C18-445D-9C1B-D8172376FD3C}"/>
+                <a16:creationId xmlns:a16="http://schemas.microsoft.com/office/drawing/2014/main" id="{CC8872A3-4FCA-4CE6-A9EB-2B9A2777E1B2}"/>
               </a:ext>
             </a:extLst>
           </p:cNvPr>
@@ -4680,7 +4680,7 @@
           <p:cNvPr id="2" name="text-60">
             <a:extLst xmlns:a="http://schemas.openxmlformats.org/drawingml/2006/main">
               <a:ext uri="{FF2B5EF4-FFF2-40B4-BE49-F238E27FC236}">
-                <a16:creationId xmlns:a16="http://schemas.microsoft.com/office/drawing/2014/main" id="{0F30FB06-E096-4D72-9812-29DCBF62D47E}"/>
+                <a16:creationId xmlns:a16="http://schemas.microsoft.com/office/drawing/2014/main" id="{07A915D4-B064-484F-83B3-51EB19AC66CB}"/>
               </a:ext>
             </a:extLst>
           </p:cNvPr>
@@ -4736,7 +4736,7 @@
           <p:cNvPr id="3" name="text-61">
             <a:extLst xmlns:a="http://schemas.openxmlformats.org/drawingml/2006/main">
               <a:ext uri="{FF2B5EF4-FFF2-40B4-BE49-F238E27FC236}">
-                <a16:creationId xmlns:a16="http://schemas.microsoft.com/office/drawing/2014/main" id="{C15DEB1D-CEA1-44A1-B8BA-23AB0F83700B}"/>
+                <a16:creationId xmlns:a16="http://schemas.microsoft.com/office/drawing/2014/main" id="{213FBECB-FE92-4731-B056-3A9EACC07477}"/>
               </a:ext>
             </a:extLst>
           </p:cNvPr>
@@ -4792,7 +4792,7 @@
           <p:cNvPr id="4" name="text-62">
             <a:extLst xmlns:a="http://schemas.openxmlformats.org/drawingml/2006/main">
               <a:ext uri="{FF2B5EF4-FFF2-40B4-BE49-F238E27FC236}">
-                <a16:creationId xmlns:a16="http://schemas.microsoft.com/office/drawing/2014/main" id="{59EABAB4-753B-4F62-91EB-5197D5D1ED1C}"/>
+                <a16:creationId xmlns:a16="http://schemas.microsoft.com/office/drawing/2014/main" id="{9EE46C01-5EEE-4A58-B211-C2813C937C82}"/>
               </a:ext>
             </a:extLst>
           </p:cNvPr>
@@ -4848,7 +4848,7 @@
           <p:cNvPr id="5" name="text-63">
             <a:extLst xmlns:a="http://schemas.openxmlformats.org/drawingml/2006/main">
               <a:ext uri="{FF2B5EF4-FFF2-40B4-BE49-F238E27FC236}">
-                <a16:creationId xmlns:a16="http://schemas.microsoft.com/office/drawing/2014/main" id="{FFCDD576-C7B9-49D9-965F-B7703F359A96}"/>
+                <a16:creationId xmlns:a16="http://schemas.microsoft.com/office/drawing/2014/main" id="{863C23BD-119E-4B57-837F-3253D2AFD7BF}"/>
               </a:ext>
             </a:extLst>
           </p:cNvPr>
@@ -4904,7 +4904,7 @@
           <p:cNvPr id="6" name="box-64">
             <a:extLst xmlns:a="http://schemas.openxmlformats.org/drawingml/2006/main">
               <a:ext uri="{FF2B5EF4-FFF2-40B4-BE49-F238E27FC236}">
-                <a16:creationId xmlns:a16="http://schemas.microsoft.com/office/drawing/2014/main" id="{8617E585-5652-473B-9ADA-F4A05578C69E}"/>
+                <a16:creationId xmlns:a16="http://schemas.microsoft.com/office/drawing/2014/main" id="{2222045F-6A9C-4BF1-AEFF-FB96522A75C4}"/>
               </a:ext>
             </a:extLst>
           </p:cNvPr>
@@ -4937,7 +4937,7 @@
           <p:cNvPr id="7" name="dot-65">
             <a:extLst xmlns:a="http://schemas.openxmlformats.org/drawingml/2006/main">
               <a:ext uri="{FF2B5EF4-FFF2-40B4-BE49-F238E27FC236}">
-                <a16:creationId xmlns:a16="http://schemas.microsoft.com/office/drawing/2014/main" id="{DD64BE3C-76AD-4F7E-89F1-CDB9E31933E5}"/>
+                <a16:creationId xmlns:a16="http://schemas.microsoft.com/office/drawing/2014/main" id="{11BABC0B-8AEC-456D-BA83-38635110A94D}"/>
               </a:ext>
             </a:extLst>
           </p:cNvPr>
@@ -4968,7 +4968,7 @@
           <p:cNvPr id="8" name="text-66">
             <a:extLst xmlns:a="http://schemas.openxmlformats.org/drawingml/2006/main">
               <a:ext uri="{FF2B5EF4-FFF2-40B4-BE49-F238E27FC236}">
-                <a16:creationId xmlns:a16="http://schemas.microsoft.com/office/drawing/2014/main" id="{6508250D-36B4-4F33-B406-E5649C387E26}"/>
+                <a16:creationId xmlns:a16="http://schemas.microsoft.com/office/drawing/2014/main" id="{3FDDED3F-1593-4E3D-93AC-A2659275256B}"/>
               </a:ext>
             </a:extLst>
           </p:cNvPr>
@@ -5024,7 +5024,7 @@
           <p:cNvPr id="9" name="text-67">
             <a:extLst xmlns:a="http://schemas.openxmlformats.org/drawingml/2006/main">
               <a:ext uri="{FF2B5EF4-FFF2-40B4-BE49-F238E27FC236}">
-                <a16:creationId xmlns:a16="http://schemas.microsoft.com/office/drawing/2014/main" id="{F0C12B2F-ECA6-4453-99C2-BB150A18BDA1}"/>
+                <a16:creationId xmlns:a16="http://schemas.microsoft.com/office/drawing/2014/main" id="{2EBF4B4C-F216-45C7-AADB-9C422E3B2A45}"/>
               </a:ext>
             </a:extLst>
           </p:cNvPr>
@@ -5080,7 +5080,7 @@
           <p:cNvPr id="10" name="text-68">
             <a:extLst xmlns:a="http://schemas.openxmlformats.org/drawingml/2006/main">
               <a:ext uri="{FF2B5EF4-FFF2-40B4-BE49-F238E27FC236}">
-                <a16:creationId xmlns:a16="http://schemas.microsoft.com/office/drawing/2014/main" id="{CE4796E1-8CAC-4EC9-975B-022AF295ADEF}"/>
+                <a16:creationId xmlns:a16="http://schemas.microsoft.com/office/drawing/2014/main" id="{657BC802-353C-4437-8D3F-92E7BA336C95}"/>
               </a:ext>
             </a:extLst>
           </p:cNvPr>
@@ -5136,7 +5136,7 @@
           <p:cNvPr id="11" name="dot-69">
             <a:extLst xmlns:a="http://schemas.openxmlformats.org/drawingml/2006/main">
               <a:ext uri="{FF2B5EF4-FFF2-40B4-BE49-F238E27FC236}">
-                <a16:creationId xmlns:a16="http://schemas.microsoft.com/office/drawing/2014/main" id="{0EBFDE20-1E68-4AA7-9FDC-5083FFE15976}"/>
+                <a16:creationId xmlns:a16="http://schemas.microsoft.com/office/drawing/2014/main" id="{0122CF94-D0F0-432F-86BE-12A78D44CE50}"/>
               </a:ext>
             </a:extLst>
           </p:cNvPr>
@@ -5167,7 +5167,7 @@
           <p:cNvPr id="12" name="text-70">
             <a:extLst xmlns:a="http://schemas.openxmlformats.org/drawingml/2006/main">
               <a:ext uri="{FF2B5EF4-FFF2-40B4-BE49-F238E27FC236}">
-                <a16:creationId xmlns:a16="http://schemas.microsoft.com/office/drawing/2014/main" id="{F0CBBF78-733E-4507-B3D9-A9F3B42843ED}"/>
+                <a16:creationId xmlns:a16="http://schemas.microsoft.com/office/drawing/2014/main" id="{11CB8F24-9DE3-4619-9FAA-CBCFC79B2B74}"/>
               </a:ext>
             </a:extLst>
           </p:cNvPr>
@@ -5223,7 +5223,7 @@
           <p:cNvPr id="13" name="text-71">
             <a:extLst xmlns:a="http://schemas.openxmlformats.org/drawingml/2006/main">
               <a:ext uri="{FF2B5EF4-FFF2-40B4-BE49-F238E27FC236}">
-                <a16:creationId xmlns:a16="http://schemas.microsoft.com/office/drawing/2014/main" id="{6D63AE65-4B38-4BA6-8B0E-BC3D8FC41E92}"/>
+                <a16:creationId xmlns:a16="http://schemas.microsoft.com/office/drawing/2014/main" id="{A4148DEB-BE20-4D5A-805B-C2715DB7F9EA}"/>
               </a:ext>
             </a:extLst>
           </p:cNvPr>
@@ -5279,7 +5279,7 @@
           <p:cNvPr id="14" name="text-72">
             <a:extLst xmlns:a="http://schemas.openxmlformats.org/drawingml/2006/main">
               <a:ext uri="{FF2B5EF4-FFF2-40B4-BE49-F238E27FC236}">
-                <a16:creationId xmlns:a16="http://schemas.microsoft.com/office/drawing/2014/main" id="{8B6AFCC9-3642-426C-8B67-20C5B042E660}"/>
+                <a16:creationId xmlns:a16="http://schemas.microsoft.com/office/drawing/2014/main" id="{6FB89C06-1EF8-4D90-8057-DD2394F39D2E}"/>
               </a:ext>
             </a:extLst>
           </p:cNvPr>
@@ -5335,7 +5335,7 @@
           <p:cNvPr id="15" name="dot-73">
             <a:extLst xmlns:a="http://schemas.openxmlformats.org/drawingml/2006/main">
               <a:ext uri="{FF2B5EF4-FFF2-40B4-BE49-F238E27FC236}">
-                <a16:creationId xmlns:a16="http://schemas.microsoft.com/office/drawing/2014/main" id="{523BE894-F557-4105-ADB1-DB297951A04E}"/>
+                <a16:creationId xmlns:a16="http://schemas.microsoft.com/office/drawing/2014/main" id="{0607C023-7AC8-4F9E-B7A6-4188FD94BE00}"/>
               </a:ext>
             </a:extLst>
           </p:cNvPr>
@@ -5366,7 +5366,7 @@
           <p:cNvPr id="16" name="text-74">
             <a:extLst xmlns:a="http://schemas.openxmlformats.org/drawingml/2006/main">
               <a:ext uri="{FF2B5EF4-FFF2-40B4-BE49-F238E27FC236}">
-                <a16:creationId xmlns:a16="http://schemas.microsoft.com/office/drawing/2014/main" id="{C58E37E3-3BE3-4C5A-84CD-7D823ED934D6}"/>
+                <a16:creationId xmlns:a16="http://schemas.microsoft.com/office/drawing/2014/main" id="{8C3A3089-7C04-430C-9978-6DDA158CF503}"/>
               </a:ext>
             </a:extLst>
           </p:cNvPr>
@@ -5422,7 +5422,7 @@
           <p:cNvPr id="17" name="text-75">
             <a:extLst xmlns:a="http://schemas.openxmlformats.org/drawingml/2006/main">
               <a:ext uri="{FF2B5EF4-FFF2-40B4-BE49-F238E27FC236}">
-                <a16:creationId xmlns:a16="http://schemas.microsoft.com/office/drawing/2014/main" id="{77D50507-F297-47C0-9241-7A97D5D21DEC}"/>
+                <a16:creationId xmlns:a16="http://schemas.microsoft.com/office/drawing/2014/main" id="{FD9A7182-60EA-44D5-8DDB-A3FE0494E5DA}"/>
               </a:ext>
             </a:extLst>
           </p:cNvPr>
@@ -5478,7 +5478,7 @@
           <p:cNvPr id="18" name="text-76">
             <a:extLst xmlns:a="http://schemas.openxmlformats.org/drawingml/2006/main">
               <a:ext uri="{FF2B5EF4-FFF2-40B4-BE49-F238E27FC236}">
-                <a16:creationId xmlns:a16="http://schemas.microsoft.com/office/drawing/2014/main" id="{083F3DC4-F88A-40A3-855C-0061AD311841}"/>
+                <a16:creationId xmlns:a16="http://schemas.microsoft.com/office/drawing/2014/main" id="{1CAB923D-193F-4207-9B1A-2DEF2CE3A609}"/>
               </a:ext>
             </a:extLst>
           </p:cNvPr>
@@ -5534,7 +5534,7 @@
           <p:cNvPr id="19" name="box-77">
             <a:extLst xmlns:a="http://schemas.openxmlformats.org/drawingml/2006/main">
               <a:ext uri="{FF2B5EF4-FFF2-40B4-BE49-F238E27FC236}">
-                <a16:creationId xmlns:a16="http://schemas.microsoft.com/office/drawing/2014/main" id="{EE833D58-1CC4-4D00-835E-88A42DC448F3}"/>
+                <a16:creationId xmlns:a16="http://schemas.microsoft.com/office/drawing/2014/main" id="{7063F775-887A-4FDF-AA44-E7EA54212294}"/>
               </a:ext>
             </a:extLst>
           </p:cNvPr>
@@ -5567,7 +5567,7 @@
           <p:cNvPr id="20" name="text-78">
             <a:extLst xmlns:a="http://schemas.openxmlformats.org/drawingml/2006/main">
               <a:ext uri="{FF2B5EF4-FFF2-40B4-BE49-F238E27FC236}">
-                <a16:creationId xmlns:a16="http://schemas.microsoft.com/office/drawing/2014/main" id="{EDF00F7C-B7E8-4FA7-89CC-1A121B59AC75}"/>
+                <a16:creationId xmlns:a16="http://schemas.microsoft.com/office/drawing/2014/main" id="{AF9FC780-281C-482C-A160-5B219F0017B3}"/>
               </a:ext>
             </a:extLst>
           </p:cNvPr>
@@ -5621,7 +5621,7 @@
     </p:spTree>
     <p:extLst>
       <p:ext uri="{BB962C8B-B14F-4D97-AF65-F5344CB8AC3E}">
-        <p14:creationId xmlns:p14="http://schemas.microsoft.com/office/powerpoint/2010/main" val="737752390"/>
+        <p14:creationId xmlns:p14="http://schemas.microsoft.com/office/powerpoint/2010/main" val="1592586532"/>
       </p:ext>
     </p:extLst>
   </p:cSld>
@@ -5652,7 +5652,7 @@
           <p:cNvPr id="18" name="box-79">
             <a:extLst xmlns:a="http://schemas.openxmlformats.org/drawingml/2006/main">
               <a:ext uri="{FF2B5EF4-FFF2-40B4-BE49-F238E27FC236}">
-                <a16:creationId xmlns:a16="http://schemas.microsoft.com/office/drawing/2014/main" id="{008E3398-0B7C-487C-9FBA-B06C87D2E681}"/>
+                <a16:creationId xmlns:a16="http://schemas.microsoft.com/office/drawing/2014/main" id="{9BF2063D-965C-44A5-BAFE-44A43D4F4EB7}"/>
               </a:ext>
             </a:extLst>
           </p:cNvPr>
@@ -5685,7 +5685,7 @@
           <p:cNvPr id="2" name="text-80">
             <a:extLst xmlns:a="http://schemas.openxmlformats.org/drawingml/2006/main">
               <a:ext uri="{FF2B5EF4-FFF2-40B4-BE49-F238E27FC236}">
-                <a16:creationId xmlns:a16="http://schemas.microsoft.com/office/drawing/2014/main" id="{8E43AB92-040D-4D87-AEEC-774E825442F7}"/>
+                <a16:creationId xmlns:a16="http://schemas.microsoft.com/office/drawing/2014/main" id="{D56A71AE-8550-4032-B568-5831F62ED6A0}"/>
               </a:ext>
             </a:extLst>
           </p:cNvPr>
@@ -5741,7 +5741,7 @@
           <p:cNvPr id="3" name="text-81">
             <a:extLst xmlns:a="http://schemas.openxmlformats.org/drawingml/2006/main">
               <a:ext uri="{FF2B5EF4-FFF2-40B4-BE49-F238E27FC236}">
-                <a16:creationId xmlns:a16="http://schemas.microsoft.com/office/drawing/2014/main" id="{D12E8566-4DBB-4CDC-9C16-64296B20991D}"/>
+                <a16:creationId xmlns:a16="http://schemas.microsoft.com/office/drawing/2014/main" id="{FFA29013-99EA-49A3-BFD5-87E6EAD0DA16}"/>
               </a:ext>
             </a:extLst>
           </p:cNvPr>
@@ -5797,7 +5797,7 @@
           <p:cNvPr id="4" name="text-82">
             <a:extLst xmlns:a="http://schemas.openxmlformats.org/drawingml/2006/main">
               <a:ext uri="{FF2B5EF4-FFF2-40B4-BE49-F238E27FC236}">
-                <a16:creationId xmlns:a16="http://schemas.microsoft.com/office/drawing/2014/main" id="{A75DE5CD-9352-4BA5-906A-FF235AD80A34}"/>
+                <a16:creationId xmlns:a16="http://schemas.microsoft.com/office/drawing/2014/main" id="{B599A8D4-F59C-4240-A667-52DF5B0065A8}"/>
               </a:ext>
             </a:extLst>
           </p:cNvPr>
@@ -5853,7 +5853,7 @@
           <p:cNvPr id="5" name="text-83">
             <a:extLst xmlns:a="http://schemas.openxmlformats.org/drawingml/2006/main">
               <a:ext uri="{FF2B5EF4-FFF2-40B4-BE49-F238E27FC236}">
-                <a16:creationId xmlns:a16="http://schemas.microsoft.com/office/drawing/2014/main" id="{6CC6BEC3-91AD-4C6B-82EE-B585B94A275F}"/>
+                <a16:creationId xmlns:a16="http://schemas.microsoft.com/office/drawing/2014/main" id="{52D78FF0-B093-47E4-8B25-4CEC47770C9B}"/>
               </a:ext>
             </a:extLst>
           </p:cNvPr>
@@ -5909,7 +5909,7 @@
           <p:cNvPr id="6" name="text-84">
             <a:extLst xmlns:a="http://schemas.openxmlformats.org/drawingml/2006/main">
               <a:ext uri="{FF2B5EF4-FFF2-40B4-BE49-F238E27FC236}">
-                <a16:creationId xmlns:a16="http://schemas.microsoft.com/office/drawing/2014/main" id="{270B6A19-47E4-40FB-B62A-8A95B0BC49EE}"/>
+                <a16:creationId xmlns:a16="http://schemas.microsoft.com/office/drawing/2014/main" id="{835E659D-C50C-489D-AEDF-926E923A1CB5}"/>
               </a:ext>
             </a:extLst>
           </p:cNvPr>
@@ -5965,7 +5965,7 @@
           <p:cNvPr id="7" name="text-85">
             <a:extLst xmlns:a="http://schemas.openxmlformats.org/drawingml/2006/main">
               <a:ext uri="{FF2B5EF4-FFF2-40B4-BE49-F238E27FC236}">
-                <a16:creationId xmlns:a16="http://schemas.microsoft.com/office/drawing/2014/main" id="{43A0F352-429B-49D5-BE40-02B32662ACE9}"/>
+                <a16:creationId xmlns:a16="http://schemas.microsoft.com/office/drawing/2014/main" id="{3CE6A196-E2B0-4130-83C2-81A3DAE0A5D7}"/>
               </a:ext>
             </a:extLst>
           </p:cNvPr>
@@ -6021,7 +6021,7 @@
           <p:cNvPr id="8" name="text-86">
             <a:extLst xmlns:a="http://schemas.openxmlformats.org/drawingml/2006/main">
               <a:ext uri="{FF2B5EF4-FFF2-40B4-BE49-F238E27FC236}">
-                <a16:creationId xmlns:a16="http://schemas.microsoft.com/office/drawing/2014/main" id="{022E99E2-874D-48D7-95E4-49DD0FD51220}"/>
+                <a16:creationId xmlns:a16="http://schemas.microsoft.com/office/drawing/2014/main" id="{5515909F-271E-481C-BE41-B16DDE1DBFB3}"/>
               </a:ext>
             </a:extLst>
           </p:cNvPr>
@@ -6067,7 +6067,7 @@
                 <a:ea typeface="Arial"/>
                 <a:cs typeface="Arial"/>
               </a:rPr>
-              <a:t>70 / 70</a:t>
+              <a:t>86 / 86</a:t>
             </a:r>
           </a:p>
         </p:txBody>
@@ -6077,7 +6077,7 @@
           <p:cNvPr id="9" name="text-87">
             <a:extLst xmlns:a="http://schemas.openxmlformats.org/drawingml/2006/main">
               <a:ext uri="{FF2B5EF4-FFF2-40B4-BE49-F238E27FC236}">
-                <a16:creationId xmlns:a16="http://schemas.microsoft.com/office/drawing/2014/main" id="{43FD3B3D-332F-4573-9A2F-14BD2346ECA0}"/>
+                <a16:creationId xmlns:a16="http://schemas.microsoft.com/office/drawing/2014/main" id="{4D5BF624-9651-412A-9AC7-6846EBA2380D}"/>
               </a:ext>
             </a:extLst>
           </p:cNvPr>
@@ -6133,7 +6133,7 @@
           <p:cNvPr id="10" name="text-88">
             <a:extLst xmlns:a="http://schemas.openxmlformats.org/drawingml/2006/main">
               <a:ext uri="{FF2B5EF4-FFF2-40B4-BE49-F238E27FC236}">
-                <a16:creationId xmlns:a16="http://schemas.microsoft.com/office/drawing/2014/main" id="{26340892-6CAB-4D83-85E4-FAA7E481B6F5}"/>
+                <a16:creationId xmlns:a16="http://schemas.microsoft.com/office/drawing/2014/main" id="{1FA0FBBB-93A0-4CCE-9B9F-E57E22C78CAB}"/>
               </a:ext>
             </a:extLst>
           </p:cNvPr>
@@ -6235,7 +6235,7 @@
           <p:cNvPr id="11" name="text-89">
             <a:extLst xmlns:a="http://schemas.openxmlformats.org/drawingml/2006/main">
               <a:ext uri="{FF2B5EF4-FFF2-40B4-BE49-F238E27FC236}">
-                <a16:creationId xmlns:a16="http://schemas.microsoft.com/office/drawing/2014/main" id="{CDF660C7-0A91-4F65-A7DF-F54B3EE50186}"/>
+                <a16:creationId xmlns:a16="http://schemas.microsoft.com/office/drawing/2014/main" id="{2D7AE4AF-ABA1-4CDE-ADAD-6E101001E89E}"/>
               </a:ext>
             </a:extLst>
           </p:cNvPr>
@@ -6337,7 +6337,7 @@
           <p:cNvPr id="12" name="text-90">
             <a:extLst xmlns:a="http://schemas.openxmlformats.org/drawingml/2006/main">
               <a:ext uri="{FF2B5EF4-FFF2-40B4-BE49-F238E27FC236}">
-                <a16:creationId xmlns:a16="http://schemas.microsoft.com/office/drawing/2014/main" id="{DC6C3574-DB9A-428A-84F8-72398D4C1DEA}"/>
+                <a16:creationId xmlns:a16="http://schemas.microsoft.com/office/drawing/2014/main" id="{8EC2E6C2-6FB4-44D9-9A0C-EF14C4223A7E}"/>
               </a:ext>
             </a:extLst>
           </p:cNvPr>
@@ -6439,7 +6439,7 @@
           <p:cNvPr id="13" name="box-91">
             <a:extLst xmlns:a="http://schemas.openxmlformats.org/drawingml/2006/main">
               <a:ext uri="{FF2B5EF4-FFF2-40B4-BE49-F238E27FC236}">
-                <a16:creationId xmlns:a16="http://schemas.microsoft.com/office/drawing/2014/main" id="{26DBDBCB-53D6-4163-9174-6F0E737EB575}"/>
+                <a16:creationId xmlns:a16="http://schemas.microsoft.com/office/drawing/2014/main" id="{B32C322C-414A-4678-902B-1A6ED941C958}"/>
               </a:ext>
             </a:extLst>
           </p:cNvPr>
@@ -6472,7 +6472,7 @@
           <p:cNvPr id="14" name="text-92">
             <a:extLst xmlns:a="http://schemas.openxmlformats.org/drawingml/2006/main">
               <a:ext uri="{FF2B5EF4-FFF2-40B4-BE49-F238E27FC236}">
-                <a16:creationId xmlns:a16="http://schemas.microsoft.com/office/drawing/2014/main" id="{6D421409-C49F-4A13-8AD5-C78F9C7DA902}"/>
+                <a16:creationId xmlns:a16="http://schemas.microsoft.com/office/drawing/2014/main" id="{26B2B46D-A0C8-49C3-A33B-43DED751D20F}"/>
               </a:ext>
             </a:extLst>
           </p:cNvPr>
@@ -6528,7 +6528,7 @@
           <p:cNvPr id="15" name="text-93">
             <a:extLst xmlns:a="http://schemas.openxmlformats.org/drawingml/2006/main">
               <a:ext uri="{FF2B5EF4-FFF2-40B4-BE49-F238E27FC236}">
-                <a16:creationId xmlns:a16="http://schemas.microsoft.com/office/drawing/2014/main" id="{486F4FA2-9D0D-46E3-9354-8F2906355D00}"/>
+                <a16:creationId xmlns:a16="http://schemas.microsoft.com/office/drawing/2014/main" id="{EA0FE66C-E5F3-4770-8476-F51FB78F88BA}"/>
               </a:ext>
             </a:extLst>
           </p:cNvPr>
@@ -6574,7 +6574,7 @@
                 <a:ea typeface="Arial"/>
                 <a:cs typeface="Arial"/>
               </a:rPr>
-              <a:t>Windows 10/11 (x64) + macOS (Apple Silicon) — İndirme: github.com/Azizsekerdil/GermanCourseAI/releases (v1.1.2) · (özel repo)</a:t>
+              <a:t>Windows 10/11 (x64) + macOS (Apple Silicon) — İndirme: github.com/Azizsekerdil/GermanCourseAI/releases (v1.2.0) · (özel repo)</a:t>
             </a:r>
           </a:p>
         </p:txBody>
@@ -6584,7 +6584,7 @@
           <p:cNvPr id="16" name="text-94">
             <a:extLst xmlns:a="http://schemas.openxmlformats.org/drawingml/2006/main">
               <a:ext uri="{FF2B5EF4-FFF2-40B4-BE49-F238E27FC236}">
-                <a16:creationId xmlns:a16="http://schemas.microsoft.com/office/drawing/2014/main" id="{7A9B7946-7959-4B3B-A558-2B643C46DA0B}"/>
+                <a16:creationId xmlns:a16="http://schemas.microsoft.com/office/drawing/2014/main" id="{6A096659-B102-4B26-840E-DC6539D95958}"/>
               </a:ext>
             </a:extLst>
           </p:cNvPr>
@@ -6630,7 +6630,7 @@
                 <a:ea typeface="Arial"/>
                 <a:cs typeface="Arial"/>
               </a:rPr>
-              <a:t>Windows 10/11 (x64) &amp; macOS (Apple Silicon) — Download: GitHub Releases (v1.1.2)</a:t>
+              <a:t>Windows 10/11 (x64) &amp; macOS (Apple Silicon) — Download: GitHub Releases (v1.2.0)</a:t>
             </a:r>
           </a:p>
         </p:txBody>
@@ -6640,7 +6640,7 @@
           <p:cNvPr id="17" name="text-95">
             <a:extLst xmlns:a="http://schemas.openxmlformats.org/drawingml/2006/main">
               <a:ext uri="{FF2B5EF4-FFF2-40B4-BE49-F238E27FC236}">
-                <a16:creationId xmlns:a16="http://schemas.microsoft.com/office/drawing/2014/main" id="{B5DE2CBA-0339-432E-9BAF-CEDBC5F4D955}"/>
+                <a16:creationId xmlns:a16="http://schemas.microsoft.com/office/drawing/2014/main" id="{5729A71B-508E-4089-9045-D872A2523B78}"/>
               </a:ext>
             </a:extLst>
           </p:cNvPr>
@@ -6694,7 +6694,7 @@
     </p:spTree>
     <p:extLst>
       <p:ext uri="{BB962C8B-B14F-4D97-AF65-F5344CB8AC3E}">
-        <p14:creationId xmlns:p14="http://schemas.microsoft.com/office/powerpoint/2010/main" val="1193501957"/>
+        <p14:creationId xmlns:p14="http://schemas.microsoft.com/office/powerpoint/2010/main" val="658931556"/>
       </p:ext>
     </p:extLst>
   </p:cSld>

</xml_diff>